<commit_message>
Fix hotel solution cache and match slide diagram
</commit_message>
<xml_diff>
--- a/docs/exercicios-select-hotel/Exercicios_SELECT_Hotel_slides.pptx
+++ b/docs/exercicios-select-hotel/Exercicios_SELECT_Hotel_slides.pptx
@@ -2,33 +2,33 @@
 <file path=ppt/presentation.xml><?xml version="1.0" encoding="utf-8"?>
 <p:presentation xmlns:p="http://schemas.openxmlformats.org/presentationml/2006/main">
   <p:sldMasterIdLst>
-    <p:sldMasterId xmlns:r="http://schemas.openxmlformats.org/officeDocument/2006/relationships" id="2147483648" r:id="R6f6fe5e1bd00409d"/>
+    <p:sldMasterId xmlns:r="http://schemas.openxmlformats.org/officeDocument/2006/relationships" id="2147483648" r:id="Re0b4b312d60d433b"/>
   </p:sldMasterIdLst>
   <p:notesMasterIdLst>
-    <p:notesMasterId xmlns:r="http://schemas.openxmlformats.org/officeDocument/2006/relationships" r:id="R738aa3731f9441e7"/>
+    <p:notesMasterId xmlns:r="http://schemas.openxmlformats.org/officeDocument/2006/relationships" r:id="Rc3b078620a204ee5"/>
   </p:notesMasterIdLst>
   <p:sldIdLst>
-    <p:sldId xmlns:r="http://schemas.openxmlformats.org/officeDocument/2006/relationships" id="256" r:id="R4c4a30e8a780441e"/>
-    <p:sldId xmlns:r="http://schemas.openxmlformats.org/officeDocument/2006/relationships" id="257" r:id="R9be6241062b54ddd"/>
-    <p:sldId xmlns:r="http://schemas.openxmlformats.org/officeDocument/2006/relationships" id="258" r:id="R9a6c16b32b554a0e"/>
-    <p:sldId xmlns:r="http://schemas.openxmlformats.org/officeDocument/2006/relationships" id="259" r:id="Rd7898229b5e94fd3"/>
-    <p:sldId xmlns:r="http://schemas.openxmlformats.org/officeDocument/2006/relationships" id="260" r:id="Rc83cf61f20564b0a"/>
-    <p:sldId xmlns:r="http://schemas.openxmlformats.org/officeDocument/2006/relationships" id="261" r:id="R1143b0b6e7324095"/>
-    <p:sldId xmlns:r="http://schemas.openxmlformats.org/officeDocument/2006/relationships" id="262" r:id="Rccff91d5e88641d0"/>
-    <p:sldId xmlns:r="http://schemas.openxmlformats.org/officeDocument/2006/relationships" id="263" r:id="R518956af9d6949ec"/>
-    <p:sldId xmlns:r="http://schemas.openxmlformats.org/officeDocument/2006/relationships" id="264" r:id="Rd33daaa564d84050"/>
-    <p:sldId xmlns:r="http://schemas.openxmlformats.org/officeDocument/2006/relationships" id="265" r:id="R2d51f89e7f5443b1"/>
-    <p:sldId xmlns:r="http://schemas.openxmlformats.org/officeDocument/2006/relationships" id="266" r:id="R975126d759df48a3"/>
-    <p:sldId xmlns:r="http://schemas.openxmlformats.org/officeDocument/2006/relationships" id="267" r:id="R32d758c62b1c44a2"/>
-    <p:sldId xmlns:r="http://schemas.openxmlformats.org/officeDocument/2006/relationships" id="268" r:id="R6950083df5f3499f"/>
-    <p:sldId xmlns:r="http://schemas.openxmlformats.org/officeDocument/2006/relationships" id="269" r:id="Re1d0df44c3264909"/>
-    <p:sldId xmlns:r="http://schemas.openxmlformats.org/officeDocument/2006/relationships" id="270" r:id="R2500208d7c594836"/>
-    <p:sldId xmlns:r="http://schemas.openxmlformats.org/officeDocument/2006/relationships" id="271" r:id="Rcf14514af54546e1"/>
-    <p:sldId xmlns:r="http://schemas.openxmlformats.org/officeDocument/2006/relationships" id="272" r:id="R3102cfe2a28c438d"/>
-    <p:sldId xmlns:r="http://schemas.openxmlformats.org/officeDocument/2006/relationships" id="273" r:id="Rf8dc63ab336e40b1"/>
-    <p:sldId xmlns:r="http://schemas.openxmlformats.org/officeDocument/2006/relationships" id="274" r:id="Ra740a4e46fe742e7"/>
-    <p:sldId xmlns:r="http://schemas.openxmlformats.org/officeDocument/2006/relationships" id="275" r:id="Rbbcea9da54df48c6"/>
-    <p:sldId xmlns:r="http://schemas.openxmlformats.org/officeDocument/2006/relationships" id="276" r:id="Rc22a85f2e7004eb0"/>
+    <p:sldId xmlns:r="http://schemas.openxmlformats.org/officeDocument/2006/relationships" id="256" r:id="R25da5e9b0b3e4018"/>
+    <p:sldId xmlns:r="http://schemas.openxmlformats.org/officeDocument/2006/relationships" id="257" r:id="Re3ad6bb096e64ca8"/>
+    <p:sldId xmlns:r="http://schemas.openxmlformats.org/officeDocument/2006/relationships" id="258" r:id="R14a871f5baa249ef"/>
+    <p:sldId xmlns:r="http://schemas.openxmlformats.org/officeDocument/2006/relationships" id="259" r:id="R20d81eb25afe45bf"/>
+    <p:sldId xmlns:r="http://schemas.openxmlformats.org/officeDocument/2006/relationships" id="260" r:id="R62b7efc1f2404982"/>
+    <p:sldId xmlns:r="http://schemas.openxmlformats.org/officeDocument/2006/relationships" id="261" r:id="Ra7e00068b20345da"/>
+    <p:sldId xmlns:r="http://schemas.openxmlformats.org/officeDocument/2006/relationships" id="262" r:id="R113ee49d76b84fcd"/>
+    <p:sldId xmlns:r="http://schemas.openxmlformats.org/officeDocument/2006/relationships" id="263" r:id="Rf99422fe0ce445ba"/>
+    <p:sldId xmlns:r="http://schemas.openxmlformats.org/officeDocument/2006/relationships" id="264" r:id="R9114b54fa54447e0"/>
+    <p:sldId xmlns:r="http://schemas.openxmlformats.org/officeDocument/2006/relationships" id="265" r:id="R96b5aaf8f5ac4492"/>
+    <p:sldId xmlns:r="http://schemas.openxmlformats.org/officeDocument/2006/relationships" id="266" r:id="R8b28f6b157b848fb"/>
+    <p:sldId xmlns:r="http://schemas.openxmlformats.org/officeDocument/2006/relationships" id="267" r:id="Rec0c5ef3929047c7"/>
+    <p:sldId xmlns:r="http://schemas.openxmlformats.org/officeDocument/2006/relationships" id="268" r:id="Rd9353d11db784812"/>
+    <p:sldId xmlns:r="http://schemas.openxmlformats.org/officeDocument/2006/relationships" id="269" r:id="R3d3f008844f24f74"/>
+    <p:sldId xmlns:r="http://schemas.openxmlformats.org/officeDocument/2006/relationships" id="270" r:id="Rd4123a91b9a6449f"/>
+    <p:sldId xmlns:r="http://schemas.openxmlformats.org/officeDocument/2006/relationships" id="271" r:id="R6ede5e9c10f043ac"/>
+    <p:sldId xmlns:r="http://schemas.openxmlformats.org/officeDocument/2006/relationships" id="272" r:id="R4b97d1f357884ce9"/>
+    <p:sldId xmlns:r="http://schemas.openxmlformats.org/officeDocument/2006/relationships" id="273" r:id="Rcc0d18c7b9af41aa"/>
+    <p:sldId xmlns:r="http://schemas.openxmlformats.org/officeDocument/2006/relationships" id="274" r:id="R5671723481ea4970"/>
+    <p:sldId xmlns:r="http://schemas.openxmlformats.org/officeDocument/2006/relationships" id="275" r:id="R8e544d75b79d4945"/>
+    <p:sldId xmlns:r="http://schemas.openxmlformats.org/officeDocument/2006/relationships" id="276" r:id="R6dc5d420ed13428a"/>
   </p:sldIdLst>
   <p:sldSz cx="12192000" cy="6858000"/>
   <p:notesSz cx="6858000" cy="9144000"/>
@@ -1846,7 +1846,7 @@
   </p:cSld>
   <p:clrMap bg1="lt1" tx1="dk1" bg2="lt2" tx2="dk2" accent1="accent1" accent2="accent2" accent3="accent3" accent4="accent4" accent5="accent5" accent6="accent6" hlink="hlink" folHlink="folHlink"/>
   <p:sldLayoutIdLst>
-    <p:sldLayoutId xmlns:r="http://schemas.openxmlformats.org/officeDocument/2006/relationships" id="2147483649" r:id="Rff1491ba5e4f40ca"/>
+    <p:sldLayoutId xmlns:r="http://schemas.openxmlformats.org/officeDocument/2006/relationships" id="2147483649" r:id="Rcef3f87e4daa4ccd"/>
   </p:sldLayoutIdLst>
   <p:txStyles>
     <p:titleStyle>
@@ -2390,7 +2390,7 @@
           <p:cNvPr id="9" name="">
             <a:extLst xmlns:a="http://schemas.openxmlformats.org/drawingml/2006/main">
               <a:ext uri="{FF2B5EF4-FFF2-40B4-BE49-F238E27FC236}">
-                <a16:creationId xmlns:a16="http://schemas.microsoft.com/office/drawing/2014/main" id="{AE6BF361-EB01-4B85-908B-A967DF11E36E}"/>
+                <a16:creationId xmlns:a16="http://schemas.microsoft.com/office/drawing/2014/main" id="{65D78992-DD36-480F-92BC-61BDA7B5F4E7}"/>
               </a:ext>
             </a:extLst>
           </p:cNvPr>
@@ -2420,7 +2420,7 @@
           <p:cNvPr id="2" name="">
             <a:extLst xmlns:a="http://schemas.openxmlformats.org/drawingml/2006/main">
               <a:ext uri="{FF2B5EF4-FFF2-40B4-BE49-F238E27FC236}">
-                <a16:creationId xmlns:a16="http://schemas.microsoft.com/office/drawing/2014/main" id="{14A823E1-04E7-4C5D-89B6-D1631BCA0FA8}"/>
+                <a16:creationId xmlns:a16="http://schemas.microsoft.com/office/drawing/2014/main" id="{9C89B12D-B05A-424A-A3C9-7CD7204C5865}"/>
               </a:ext>
             </a:extLst>
           </p:cNvPr>
@@ -2450,7 +2450,7 @@
           <p:cNvPr id="3" name="">
             <a:extLst xmlns:a="http://schemas.openxmlformats.org/drawingml/2006/main">
               <a:ext uri="{FF2B5EF4-FFF2-40B4-BE49-F238E27FC236}">
-                <a16:creationId xmlns:a16="http://schemas.microsoft.com/office/drawing/2014/main" id="{F7DECAF0-7295-481F-8FF1-84DA656D9500}"/>
+                <a16:creationId xmlns:a16="http://schemas.microsoft.com/office/drawing/2014/main" id="{A2B7F1DD-0C53-4ABB-B8B4-801B76FE39A5}"/>
               </a:ext>
             </a:extLst>
           </p:cNvPr>
@@ -2507,7 +2507,7 @@
           <p:cNvPr id="4" name="">
             <a:extLst xmlns:a="http://schemas.openxmlformats.org/drawingml/2006/main">
               <a:ext uri="{FF2B5EF4-FFF2-40B4-BE49-F238E27FC236}">
-                <a16:creationId xmlns:a16="http://schemas.microsoft.com/office/drawing/2014/main" id="{4A4BD35A-2275-42D9-A9D3-F74E49A23B4D}"/>
+                <a16:creationId xmlns:a16="http://schemas.microsoft.com/office/drawing/2014/main" id="{F7B95A85-74D6-4801-8509-ACA0DCFF8D51}"/>
               </a:ext>
             </a:extLst>
           </p:cNvPr>
@@ -2587,7 +2587,7 @@
           <p:cNvPr id="5" name="">
             <a:extLst xmlns:a="http://schemas.openxmlformats.org/drawingml/2006/main">
               <a:ext uri="{FF2B5EF4-FFF2-40B4-BE49-F238E27FC236}">
-                <a16:creationId xmlns:a16="http://schemas.microsoft.com/office/drawing/2014/main" id="{460F3A3C-96A1-4940-A44F-28DA5F68CF8B}"/>
+                <a16:creationId xmlns:a16="http://schemas.microsoft.com/office/drawing/2014/main" id="{4DB6F8B5-B6FE-45D7-94D5-712F8C0B3B5F}"/>
               </a:ext>
             </a:extLst>
           </p:cNvPr>
@@ -2644,7 +2644,7 @@
           <p:cNvPr id="6" name="">
             <a:extLst xmlns:a="http://schemas.openxmlformats.org/drawingml/2006/main">
               <a:ext uri="{FF2B5EF4-FFF2-40B4-BE49-F238E27FC236}">
-                <a16:creationId xmlns:a16="http://schemas.microsoft.com/office/drawing/2014/main" id="{878A5551-06B6-4CD0-9BB6-F987EF936853}"/>
+                <a16:creationId xmlns:a16="http://schemas.microsoft.com/office/drawing/2014/main" id="{9596E680-046D-4BFB-8F33-D178901B42E3}"/>
               </a:ext>
             </a:extLst>
           </p:cNvPr>
@@ -2701,7 +2701,7 @@
           <p:cNvPr id="7" name="">
             <a:extLst xmlns:a="http://schemas.openxmlformats.org/drawingml/2006/main">
               <a:ext uri="{FF2B5EF4-FFF2-40B4-BE49-F238E27FC236}">
-                <a16:creationId xmlns:a16="http://schemas.microsoft.com/office/drawing/2014/main" id="{CCFCBED6-492A-48C5-838C-79E94D5AD1C3}"/>
+                <a16:creationId xmlns:a16="http://schemas.microsoft.com/office/drawing/2014/main" id="{D8414C19-E45C-43D9-9D90-ED89BFA73808}"/>
               </a:ext>
             </a:extLst>
           </p:cNvPr>
@@ -2733,7 +2733,7 @@
           <p:cNvPr id="8" name="">
             <a:extLst xmlns:a="http://schemas.openxmlformats.org/drawingml/2006/main">
               <a:ext uri="{FF2B5EF4-FFF2-40B4-BE49-F238E27FC236}">
-                <a16:creationId xmlns:a16="http://schemas.microsoft.com/office/drawing/2014/main" id="{54E4D1E0-2322-49FE-AC19-E2C8FE9D7B4A}"/>
+                <a16:creationId xmlns:a16="http://schemas.microsoft.com/office/drawing/2014/main" id="{5C4D6FBA-F02C-43DA-AA3F-9D19D3A4863D}"/>
               </a:ext>
             </a:extLst>
           </p:cNvPr>
@@ -2872,7 +2872,7 @@
     </p:spTree>
     <p:extLst>
       <p:ext uri="{BB962C8B-B14F-4D97-AF65-F5344CB8AC3E}">
-        <p14:creationId xmlns:p14="http://schemas.microsoft.com/office/powerpoint/2010/main" val="1647814811"/>
+        <p14:creationId xmlns:p14="http://schemas.microsoft.com/office/powerpoint/2010/main" val="527017607"/>
       </p:ext>
     </p:extLst>
   </p:cSld>
@@ -2896,7 +2896,7 @@
           <p:cNvPr id="10" name="">
             <a:extLst xmlns:a="http://schemas.openxmlformats.org/drawingml/2006/main">
               <a:ext uri="{FF2B5EF4-FFF2-40B4-BE49-F238E27FC236}">
-                <a16:creationId xmlns:a16="http://schemas.microsoft.com/office/drawing/2014/main" id="{B13D4CEE-CF86-47CA-94A2-B4BC1EF80C81}"/>
+                <a16:creationId xmlns:a16="http://schemas.microsoft.com/office/drawing/2014/main" id="{C6C98FFC-CDA0-4449-BAC7-AE0E42D27A09}"/>
               </a:ext>
             </a:extLst>
           </p:cNvPr>
@@ -2926,7 +2926,7 @@
           <p:cNvPr id="2" name="">
             <a:extLst xmlns:a="http://schemas.openxmlformats.org/drawingml/2006/main">
               <a:ext uri="{FF2B5EF4-FFF2-40B4-BE49-F238E27FC236}">
-                <a16:creationId xmlns:a16="http://schemas.microsoft.com/office/drawing/2014/main" id="{762839D1-C8F9-437F-9AEC-17C858E0FBAD}"/>
+                <a16:creationId xmlns:a16="http://schemas.microsoft.com/office/drawing/2014/main" id="{C78FB430-CAAC-4FA8-9241-9D5CBAEA72A6}"/>
               </a:ext>
             </a:extLst>
           </p:cNvPr>
@@ -2956,7 +2956,7 @@
           <p:cNvPr id="3" name="">
             <a:extLst xmlns:a="http://schemas.openxmlformats.org/drawingml/2006/main">
               <a:ext uri="{FF2B5EF4-FFF2-40B4-BE49-F238E27FC236}">
-                <a16:creationId xmlns:a16="http://schemas.microsoft.com/office/drawing/2014/main" id="{E81F319E-B11C-4041-994F-D0E657794385}"/>
+                <a16:creationId xmlns:a16="http://schemas.microsoft.com/office/drawing/2014/main" id="{571C3474-42F7-4138-BE77-5CD36B9F4F8B}"/>
               </a:ext>
             </a:extLst>
           </p:cNvPr>
@@ -3013,7 +3013,7 @@
           <p:cNvPr id="4" name="">
             <a:extLst xmlns:a="http://schemas.openxmlformats.org/drawingml/2006/main">
               <a:ext uri="{FF2B5EF4-FFF2-40B4-BE49-F238E27FC236}">
-                <a16:creationId xmlns:a16="http://schemas.microsoft.com/office/drawing/2014/main" id="{4EF065EC-9470-47A6-994D-06C6C288A405}"/>
+                <a16:creationId xmlns:a16="http://schemas.microsoft.com/office/drawing/2014/main" id="{BF012B69-E740-496C-B582-57F60828E8CB}"/>
               </a:ext>
             </a:extLst>
           </p:cNvPr>
@@ -3070,7 +3070,7 @@
           <p:cNvPr id="5" name="">
             <a:extLst xmlns:a="http://schemas.openxmlformats.org/drawingml/2006/main">
               <a:ext uri="{FF2B5EF4-FFF2-40B4-BE49-F238E27FC236}">
-                <a16:creationId xmlns:a16="http://schemas.microsoft.com/office/drawing/2014/main" id="{95AE8C82-2326-488A-9A41-9A08D6DEB20A}"/>
+                <a16:creationId xmlns:a16="http://schemas.microsoft.com/office/drawing/2014/main" id="{49D2FF93-A5D3-4586-B8B5-8A4CE0C667A8}"/>
               </a:ext>
             </a:extLst>
           </p:cNvPr>
@@ -3127,7 +3127,7 @@
           <p:cNvPr id="6" name="">
             <a:extLst xmlns:a="http://schemas.openxmlformats.org/drawingml/2006/main">
               <a:ext uri="{FF2B5EF4-FFF2-40B4-BE49-F238E27FC236}">
-                <a16:creationId xmlns:a16="http://schemas.microsoft.com/office/drawing/2014/main" id="{16287AFC-5611-4822-9D94-67B930588278}"/>
+                <a16:creationId xmlns:a16="http://schemas.microsoft.com/office/drawing/2014/main" id="{C038982F-777D-4559-807A-92A44C538393}"/>
               </a:ext>
             </a:extLst>
           </p:cNvPr>
@@ -3184,7 +3184,7 @@
           <p:cNvPr id="7" name="">
             <a:extLst xmlns:a="http://schemas.openxmlformats.org/drawingml/2006/main">
               <a:ext uri="{FF2B5EF4-FFF2-40B4-BE49-F238E27FC236}">
-                <a16:creationId xmlns:a16="http://schemas.microsoft.com/office/drawing/2014/main" id="{E4D08275-A93B-4A5F-9A0D-D86443337103}"/>
+                <a16:creationId xmlns:a16="http://schemas.microsoft.com/office/drawing/2014/main" id="{A346ADEE-7B00-4C6B-ABDD-2D952EBD9458}"/>
               </a:ext>
             </a:extLst>
           </p:cNvPr>
@@ -3241,7 +3241,7 @@
           <p:cNvPr id="8" name="">
             <a:extLst xmlns:a="http://schemas.openxmlformats.org/drawingml/2006/main">
               <a:ext uri="{FF2B5EF4-FFF2-40B4-BE49-F238E27FC236}">
-                <a16:creationId xmlns:a16="http://schemas.microsoft.com/office/drawing/2014/main" id="{3BF979CF-96EC-46C4-BFF6-10DA5AB42226}"/>
+                <a16:creationId xmlns:a16="http://schemas.microsoft.com/office/drawing/2014/main" id="{BF5CAAAF-1E49-495A-91D2-28661BCD5BE9}"/>
               </a:ext>
             </a:extLst>
           </p:cNvPr>
@@ -3273,7 +3273,7 @@
           <p:cNvPr id="9" name="">
             <a:extLst xmlns:a="http://schemas.openxmlformats.org/drawingml/2006/main">
               <a:ext uri="{FF2B5EF4-FFF2-40B4-BE49-F238E27FC236}">
-                <a16:creationId xmlns:a16="http://schemas.microsoft.com/office/drawing/2014/main" id="{9D50C93B-59F3-4121-8CAB-8F176998BB0C}"/>
+                <a16:creationId xmlns:a16="http://schemas.microsoft.com/office/drawing/2014/main" id="{FCB1EDAC-7CAC-4166-8C96-D77A458F17D5}"/>
               </a:ext>
             </a:extLst>
           </p:cNvPr>
@@ -3374,7 +3374,7 @@
     </p:spTree>
     <p:extLst>
       <p:ext uri="{BB962C8B-B14F-4D97-AF65-F5344CB8AC3E}">
-        <p14:creationId xmlns:p14="http://schemas.microsoft.com/office/powerpoint/2010/main" val="1943181240"/>
+        <p14:creationId xmlns:p14="http://schemas.microsoft.com/office/powerpoint/2010/main" val="1482149818"/>
       </p:ext>
     </p:extLst>
   </p:cSld>
@@ -3398,7 +3398,7 @@
           <p:cNvPr id="10" name="">
             <a:extLst xmlns:a="http://schemas.openxmlformats.org/drawingml/2006/main">
               <a:ext uri="{FF2B5EF4-FFF2-40B4-BE49-F238E27FC236}">
-                <a16:creationId xmlns:a16="http://schemas.microsoft.com/office/drawing/2014/main" id="{7A3745B9-B459-4D4F-8D40-F4AA08A06484}"/>
+                <a16:creationId xmlns:a16="http://schemas.microsoft.com/office/drawing/2014/main" id="{45EB32FE-92EF-450C-87D4-BE42F92F3168}"/>
               </a:ext>
             </a:extLst>
           </p:cNvPr>
@@ -3428,7 +3428,7 @@
           <p:cNvPr id="2" name="">
             <a:extLst xmlns:a="http://schemas.openxmlformats.org/drawingml/2006/main">
               <a:ext uri="{FF2B5EF4-FFF2-40B4-BE49-F238E27FC236}">
-                <a16:creationId xmlns:a16="http://schemas.microsoft.com/office/drawing/2014/main" id="{191C0E7D-4853-4260-8B8C-64977FDE531E}"/>
+                <a16:creationId xmlns:a16="http://schemas.microsoft.com/office/drawing/2014/main" id="{CFE75E6A-2844-4C49-8F43-25F3C44E2F32}"/>
               </a:ext>
             </a:extLst>
           </p:cNvPr>
@@ -3458,7 +3458,7 @@
           <p:cNvPr id="3" name="">
             <a:extLst xmlns:a="http://schemas.openxmlformats.org/drawingml/2006/main">
               <a:ext uri="{FF2B5EF4-FFF2-40B4-BE49-F238E27FC236}">
-                <a16:creationId xmlns:a16="http://schemas.microsoft.com/office/drawing/2014/main" id="{B926CF9F-AEEC-41B0-847B-1FEAB9F8FD74}"/>
+                <a16:creationId xmlns:a16="http://schemas.microsoft.com/office/drawing/2014/main" id="{DBD89395-481A-414C-BF24-0B52BAF6FEEE}"/>
               </a:ext>
             </a:extLst>
           </p:cNvPr>
@@ -3515,7 +3515,7 @@
           <p:cNvPr id="4" name="">
             <a:extLst xmlns:a="http://schemas.openxmlformats.org/drawingml/2006/main">
               <a:ext uri="{FF2B5EF4-FFF2-40B4-BE49-F238E27FC236}">
-                <a16:creationId xmlns:a16="http://schemas.microsoft.com/office/drawing/2014/main" id="{8C175126-A140-441C-A8B0-715B352355CA}"/>
+                <a16:creationId xmlns:a16="http://schemas.microsoft.com/office/drawing/2014/main" id="{8C3A82C0-1162-4054-A7F9-C80D1A8C2FC5}"/>
               </a:ext>
             </a:extLst>
           </p:cNvPr>
@@ -3572,7 +3572,7 @@
           <p:cNvPr id="5" name="">
             <a:extLst xmlns:a="http://schemas.openxmlformats.org/drawingml/2006/main">
               <a:ext uri="{FF2B5EF4-FFF2-40B4-BE49-F238E27FC236}">
-                <a16:creationId xmlns:a16="http://schemas.microsoft.com/office/drawing/2014/main" id="{76232579-344A-4F81-A016-D45CF693DB1A}"/>
+                <a16:creationId xmlns:a16="http://schemas.microsoft.com/office/drawing/2014/main" id="{78F61AC7-81B6-4A1A-A556-891990DF8868}"/>
               </a:ext>
             </a:extLst>
           </p:cNvPr>
@@ -3629,7 +3629,7 @@
           <p:cNvPr id="6" name="">
             <a:extLst xmlns:a="http://schemas.openxmlformats.org/drawingml/2006/main">
               <a:ext uri="{FF2B5EF4-FFF2-40B4-BE49-F238E27FC236}">
-                <a16:creationId xmlns:a16="http://schemas.microsoft.com/office/drawing/2014/main" id="{03E0B093-2333-49C7-BCCF-5D639BD720ED}"/>
+                <a16:creationId xmlns:a16="http://schemas.microsoft.com/office/drawing/2014/main" id="{7B655D9C-B7F3-4AB5-A397-29BDF58C0EE2}"/>
               </a:ext>
             </a:extLst>
           </p:cNvPr>
@@ -3686,7 +3686,7 @@
           <p:cNvPr id="7" name="">
             <a:extLst xmlns:a="http://schemas.openxmlformats.org/drawingml/2006/main">
               <a:ext uri="{FF2B5EF4-FFF2-40B4-BE49-F238E27FC236}">
-                <a16:creationId xmlns:a16="http://schemas.microsoft.com/office/drawing/2014/main" id="{33F3A85D-8741-4A18-8A09-18C11D5F2DC9}"/>
+                <a16:creationId xmlns:a16="http://schemas.microsoft.com/office/drawing/2014/main" id="{D5009010-4126-4C38-9B57-84B2E9EA7D0E}"/>
               </a:ext>
             </a:extLst>
           </p:cNvPr>
@@ -3743,7 +3743,7 @@
           <p:cNvPr id="8" name="">
             <a:extLst xmlns:a="http://schemas.openxmlformats.org/drawingml/2006/main">
               <a:ext uri="{FF2B5EF4-FFF2-40B4-BE49-F238E27FC236}">
-                <a16:creationId xmlns:a16="http://schemas.microsoft.com/office/drawing/2014/main" id="{FCC309BB-92A5-4533-9AC1-DD52BC561F00}"/>
+                <a16:creationId xmlns:a16="http://schemas.microsoft.com/office/drawing/2014/main" id="{189501D7-906D-43B9-A38A-0A2B2930DADB}"/>
               </a:ext>
             </a:extLst>
           </p:cNvPr>
@@ -3775,7 +3775,7 @@
           <p:cNvPr id="9" name="">
             <a:extLst xmlns:a="http://schemas.openxmlformats.org/drawingml/2006/main">
               <a:ext uri="{FF2B5EF4-FFF2-40B4-BE49-F238E27FC236}">
-                <a16:creationId xmlns:a16="http://schemas.microsoft.com/office/drawing/2014/main" id="{1E463BC3-D2B2-4AE0-9957-A30F5CD833BA}"/>
+                <a16:creationId xmlns:a16="http://schemas.microsoft.com/office/drawing/2014/main" id="{DE9A5419-77BD-45F0-A0AB-1ADD8624AFD7}"/>
               </a:ext>
             </a:extLst>
           </p:cNvPr>
@@ -3922,7 +3922,7 @@
     </p:spTree>
     <p:extLst>
       <p:ext uri="{BB962C8B-B14F-4D97-AF65-F5344CB8AC3E}">
-        <p14:creationId xmlns:p14="http://schemas.microsoft.com/office/powerpoint/2010/main" val="2003981036"/>
+        <p14:creationId xmlns:p14="http://schemas.microsoft.com/office/powerpoint/2010/main" val="728817908"/>
       </p:ext>
     </p:extLst>
   </p:cSld>
@@ -3946,7 +3946,7 @@
           <p:cNvPr id="10" name="">
             <a:extLst xmlns:a="http://schemas.openxmlformats.org/drawingml/2006/main">
               <a:ext uri="{FF2B5EF4-FFF2-40B4-BE49-F238E27FC236}">
-                <a16:creationId xmlns:a16="http://schemas.microsoft.com/office/drawing/2014/main" id="{EC940B40-73C2-41DE-A0CF-53BF5A293918}"/>
+                <a16:creationId xmlns:a16="http://schemas.microsoft.com/office/drawing/2014/main" id="{A12AEE70-6FA1-45E7-A224-4EC7558DB54E}"/>
               </a:ext>
             </a:extLst>
           </p:cNvPr>
@@ -3976,7 +3976,7 @@
           <p:cNvPr id="2" name="">
             <a:extLst xmlns:a="http://schemas.openxmlformats.org/drawingml/2006/main">
               <a:ext uri="{FF2B5EF4-FFF2-40B4-BE49-F238E27FC236}">
-                <a16:creationId xmlns:a16="http://schemas.microsoft.com/office/drawing/2014/main" id="{E8B812D0-3F36-4AF4-9796-31AFA0C51D6F}"/>
+                <a16:creationId xmlns:a16="http://schemas.microsoft.com/office/drawing/2014/main" id="{7972EBAC-6A30-4B4B-A6CF-AAE3C58AB3E4}"/>
               </a:ext>
             </a:extLst>
           </p:cNvPr>
@@ -4006,7 +4006,7 @@
           <p:cNvPr id="3" name="">
             <a:extLst xmlns:a="http://schemas.openxmlformats.org/drawingml/2006/main">
               <a:ext uri="{FF2B5EF4-FFF2-40B4-BE49-F238E27FC236}">
-                <a16:creationId xmlns:a16="http://schemas.microsoft.com/office/drawing/2014/main" id="{AB737493-B68C-48B9-94ED-D0F18353ACD3}"/>
+                <a16:creationId xmlns:a16="http://schemas.microsoft.com/office/drawing/2014/main" id="{B7619BE4-4E03-4814-A519-C697EAD33CFE}"/>
               </a:ext>
             </a:extLst>
           </p:cNvPr>
@@ -4063,7 +4063,7 @@
           <p:cNvPr id="4" name="">
             <a:extLst xmlns:a="http://schemas.openxmlformats.org/drawingml/2006/main">
               <a:ext uri="{FF2B5EF4-FFF2-40B4-BE49-F238E27FC236}">
-                <a16:creationId xmlns:a16="http://schemas.microsoft.com/office/drawing/2014/main" id="{87C85187-5CD3-4BF8-A3CE-DE1C975B4EC2}"/>
+                <a16:creationId xmlns:a16="http://schemas.microsoft.com/office/drawing/2014/main" id="{30D54ED0-37A0-4B28-9A23-609689038281}"/>
               </a:ext>
             </a:extLst>
           </p:cNvPr>
@@ -4120,7 +4120,7 @@
           <p:cNvPr id="5" name="">
             <a:extLst xmlns:a="http://schemas.openxmlformats.org/drawingml/2006/main">
               <a:ext uri="{FF2B5EF4-FFF2-40B4-BE49-F238E27FC236}">
-                <a16:creationId xmlns:a16="http://schemas.microsoft.com/office/drawing/2014/main" id="{4F54224C-ABBC-4553-8B19-7C11E42B6706}"/>
+                <a16:creationId xmlns:a16="http://schemas.microsoft.com/office/drawing/2014/main" id="{9AE05C73-8462-4BE2-A550-026EFE596E35}"/>
               </a:ext>
             </a:extLst>
           </p:cNvPr>
@@ -4177,7 +4177,7 @@
           <p:cNvPr id="6" name="">
             <a:extLst xmlns:a="http://schemas.openxmlformats.org/drawingml/2006/main">
               <a:ext uri="{FF2B5EF4-FFF2-40B4-BE49-F238E27FC236}">
-                <a16:creationId xmlns:a16="http://schemas.microsoft.com/office/drawing/2014/main" id="{EEFB986E-1963-4CD1-9C09-5B17E92EBF2C}"/>
+                <a16:creationId xmlns:a16="http://schemas.microsoft.com/office/drawing/2014/main" id="{C440B9AF-EA53-4D3C-8FF8-300CECD9BC50}"/>
               </a:ext>
             </a:extLst>
           </p:cNvPr>
@@ -4234,7 +4234,7 @@
           <p:cNvPr id="7" name="">
             <a:extLst xmlns:a="http://schemas.openxmlformats.org/drawingml/2006/main">
               <a:ext uri="{FF2B5EF4-FFF2-40B4-BE49-F238E27FC236}">
-                <a16:creationId xmlns:a16="http://schemas.microsoft.com/office/drawing/2014/main" id="{F5125577-E411-460F-8ECC-B81D29CD4B63}"/>
+                <a16:creationId xmlns:a16="http://schemas.microsoft.com/office/drawing/2014/main" id="{9E034660-5446-47F5-BBB8-DD0DB855D4BE}"/>
               </a:ext>
             </a:extLst>
           </p:cNvPr>
@@ -4291,7 +4291,7 @@
           <p:cNvPr id="8" name="">
             <a:extLst xmlns:a="http://schemas.openxmlformats.org/drawingml/2006/main">
               <a:ext uri="{FF2B5EF4-FFF2-40B4-BE49-F238E27FC236}">
-                <a16:creationId xmlns:a16="http://schemas.microsoft.com/office/drawing/2014/main" id="{E2DD3320-6721-4F9A-AEC3-06BFA3ABF76B}"/>
+                <a16:creationId xmlns:a16="http://schemas.microsoft.com/office/drawing/2014/main" id="{69CBDB79-2036-426F-B6CF-7A1F19F69646}"/>
               </a:ext>
             </a:extLst>
           </p:cNvPr>
@@ -4323,7 +4323,7 @@
           <p:cNvPr id="9" name="">
             <a:extLst xmlns:a="http://schemas.openxmlformats.org/drawingml/2006/main">
               <a:ext uri="{FF2B5EF4-FFF2-40B4-BE49-F238E27FC236}">
-                <a16:creationId xmlns:a16="http://schemas.microsoft.com/office/drawing/2014/main" id="{68163613-66F0-46DC-ADC5-A878B28BF3AC}"/>
+                <a16:creationId xmlns:a16="http://schemas.microsoft.com/office/drawing/2014/main" id="{5CE5A72B-D644-4CCC-869A-6BC38FDE44C2}"/>
               </a:ext>
             </a:extLst>
           </p:cNvPr>
@@ -4585,7 +4585,7 @@
     </p:spTree>
     <p:extLst>
       <p:ext uri="{BB962C8B-B14F-4D97-AF65-F5344CB8AC3E}">
-        <p14:creationId xmlns:p14="http://schemas.microsoft.com/office/powerpoint/2010/main" val="1539509694"/>
+        <p14:creationId xmlns:p14="http://schemas.microsoft.com/office/powerpoint/2010/main" val="1498753876"/>
       </p:ext>
     </p:extLst>
   </p:cSld>
@@ -4609,7 +4609,7 @@
           <p:cNvPr id="10" name="">
             <a:extLst xmlns:a="http://schemas.openxmlformats.org/drawingml/2006/main">
               <a:ext uri="{FF2B5EF4-FFF2-40B4-BE49-F238E27FC236}">
-                <a16:creationId xmlns:a16="http://schemas.microsoft.com/office/drawing/2014/main" id="{C32D2BE1-40B9-4C3A-B638-BBD5530CA09C}"/>
+                <a16:creationId xmlns:a16="http://schemas.microsoft.com/office/drawing/2014/main" id="{90500EBF-692D-4233-94C1-617362E56BEB}"/>
               </a:ext>
             </a:extLst>
           </p:cNvPr>
@@ -4639,7 +4639,7 @@
           <p:cNvPr id="2" name="">
             <a:extLst xmlns:a="http://schemas.openxmlformats.org/drawingml/2006/main">
               <a:ext uri="{FF2B5EF4-FFF2-40B4-BE49-F238E27FC236}">
-                <a16:creationId xmlns:a16="http://schemas.microsoft.com/office/drawing/2014/main" id="{B0B4D399-270C-4A3D-AD9C-01430AF06522}"/>
+                <a16:creationId xmlns:a16="http://schemas.microsoft.com/office/drawing/2014/main" id="{AFA0232A-8965-42F5-92F4-1122E3C9C1C6}"/>
               </a:ext>
             </a:extLst>
           </p:cNvPr>
@@ -4669,7 +4669,7 @@
           <p:cNvPr id="3" name="">
             <a:extLst xmlns:a="http://schemas.openxmlformats.org/drawingml/2006/main">
               <a:ext uri="{FF2B5EF4-FFF2-40B4-BE49-F238E27FC236}">
-                <a16:creationId xmlns:a16="http://schemas.microsoft.com/office/drawing/2014/main" id="{9751969A-696B-4651-B16A-9EF3725384F2}"/>
+                <a16:creationId xmlns:a16="http://schemas.microsoft.com/office/drawing/2014/main" id="{1EC68D7A-6FBF-4153-83CF-7E08F758D4E9}"/>
               </a:ext>
             </a:extLst>
           </p:cNvPr>
@@ -4726,7 +4726,7 @@
           <p:cNvPr id="4" name="">
             <a:extLst xmlns:a="http://schemas.openxmlformats.org/drawingml/2006/main">
               <a:ext uri="{FF2B5EF4-FFF2-40B4-BE49-F238E27FC236}">
-                <a16:creationId xmlns:a16="http://schemas.microsoft.com/office/drawing/2014/main" id="{7BF204D1-A5CD-4F10-9D4E-E4E08E500C3A}"/>
+                <a16:creationId xmlns:a16="http://schemas.microsoft.com/office/drawing/2014/main" id="{30767D82-0D65-4B8E-8AC6-8BA529758148}"/>
               </a:ext>
             </a:extLst>
           </p:cNvPr>
@@ -4783,7 +4783,7 @@
           <p:cNvPr id="5" name="">
             <a:extLst xmlns:a="http://schemas.openxmlformats.org/drawingml/2006/main">
               <a:ext uri="{FF2B5EF4-FFF2-40B4-BE49-F238E27FC236}">
-                <a16:creationId xmlns:a16="http://schemas.microsoft.com/office/drawing/2014/main" id="{2FED3984-038D-4B77-A73E-5BE5E4A65622}"/>
+                <a16:creationId xmlns:a16="http://schemas.microsoft.com/office/drawing/2014/main" id="{B57DA13C-11B7-46A1-A359-7DDA68432FF5}"/>
               </a:ext>
             </a:extLst>
           </p:cNvPr>
@@ -4840,7 +4840,7 @@
           <p:cNvPr id="6" name="">
             <a:extLst xmlns:a="http://schemas.openxmlformats.org/drawingml/2006/main">
               <a:ext uri="{FF2B5EF4-FFF2-40B4-BE49-F238E27FC236}">
-                <a16:creationId xmlns:a16="http://schemas.microsoft.com/office/drawing/2014/main" id="{CD5D480D-C9D5-4006-9604-022BD18EA5D6}"/>
+                <a16:creationId xmlns:a16="http://schemas.microsoft.com/office/drawing/2014/main" id="{647EC9E0-80DF-4732-BCBD-619157544886}"/>
               </a:ext>
             </a:extLst>
           </p:cNvPr>
@@ -4897,7 +4897,7 @@
           <p:cNvPr id="7" name="">
             <a:extLst xmlns:a="http://schemas.openxmlformats.org/drawingml/2006/main">
               <a:ext uri="{FF2B5EF4-FFF2-40B4-BE49-F238E27FC236}">
-                <a16:creationId xmlns:a16="http://schemas.microsoft.com/office/drawing/2014/main" id="{BC8B344C-F07D-4FA6-8015-D27AC30347F1}"/>
+                <a16:creationId xmlns:a16="http://schemas.microsoft.com/office/drawing/2014/main" id="{E4181B16-4E8E-44C3-B989-149F865A1DAB}"/>
               </a:ext>
             </a:extLst>
           </p:cNvPr>
@@ -4954,7 +4954,7 @@
           <p:cNvPr id="8" name="">
             <a:extLst xmlns:a="http://schemas.openxmlformats.org/drawingml/2006/main">
               <a:ext uri="{FF2B5EF4-FFF2-40B4-BE49-F238E27FC236}">
-                <a16:creationId xmlns:a16="http://schemas.microsoft.com/office/drawing/2014/main" id="{327989AA-DF10-449D-BE09-BFD76BDD8F86}"/>
+                <a16:creationId xmlns:a16="http://schemas.microsoft.com/office/drawing/2014/main" id="{CF8A7311-0716-4B53-9110-F3450E004335}"/>
               </a:ext>
             </a:extLst>
           </p:cNvPr>
@@ -4986,7 +4986,7 @@
           <p:cNvPr id="9" name="">
             <a:extLst xmlns:a="http://schemas.openxmlformats.org/drawingml/2006/main">
               <a:ext uri="{FF2B5EF4-FFF2-40B4-BE49-F238E27FC236}">
-                <a16:creationId xmlns:a16="http://schemas.microsoft.com/office/drawing/2014/main" id="{E6A96EE7-1811-405B-BF34-05F46F5DE606}"/>
+                <a16:creationId xmlns:a16="http://schemas.microsoft.com/office/drawing/2014/main" id="{9D378567-CAD6-4AA0-ACCB-0D1C85444FBC}"/>
               </a:ext>
             </a:extLst>
           </p:cNvPr>
@@ -5087,7 +5087,7 @@
     </p:spTree>
     <p:extLst>
       <p:ext uri="{BB962C8B-B14F-4D97-AF65-F5344CB8AC3E}">
-        <p14:creationId xmlns:p14="http://schemas.microsoft.com/office/powerpoint/2010/main" val="1859184771"/>
+        <p14:creationId xmlns:p14="http://schemas.microsoft.com/office/powerpoint/2010/main" val="11965413"/>
       </p:ext>
     </p:extLst>
   </p:cSld>
@@ -5111,7 +5111,7 @@
           <p:cNvPr id="10" name="">
             <a:extLst xmlns:a="http://schemas.openxmlformats.org/drawingml/2006/main">
               <a:ext uri="{FF2B5EF4-FFF2-40B4-BE49-F238E27FC236}">
-                <a16:creationId xmlns:a16="http://schemas.microsoft.com/office/drawing/2014/main" id="{54A553A7-2015-4627-91E5-C389DAF8DB18}"/>
+                <a16:creationId xmlns:a16="http://schemas.microsoft.com/office/drawing/2014/main" id="{0F69D06D-65E0-46B1-AB65-98F6A6E76463}"/>
               </a:ext>
             </a:extLst>
           </p:cNvPr>
@@ -5141,7 +5141,7 @@
           <p:cNvPr id="2" name="">
             <a:extLst xmlns:a="http://schemas.openxmlformats.org/drawingml/2006/main">
               <a:ext uri="{FF2B5EF4-FFF2-40B4-BE49-F238E27FC236}">
-                <a16:creationId xmlns:a16="http://schemas.microsoft.com/office/drawing/2014/main" id="{E9A7ED1D-0C03-4335-ABF0-A9AA11093F76}"/>
+                <a16:creationId xmlns:a16="http://schemas.microsoft.com/office/drawing/2014/main" id="{0DFA65DB-A32F-4413-9157-17D2F55E55B8}"/>
               </a:ext>
             </a:extLst>
           </p:cNvPr>
@@ -5171,7 +5171,7 @@
           <p:cNvPr id="3" name="">
             <a:extLst xmlns:a="http://schemas.openxmlformats.org/drawingml/2006/main">
               <a:ext uri="{FF2B5EF4-FFF2-40B4-BE49-F238E27FC236}">
-                <a16:creationId xmlns:a16="http://schemas.microsoft.com/office/drawing/2014/main" id="{0C15704D-DFAD-4ACD-A017-88FFEE74A39B}"/>
+                <a16:creationId xmlns:a16="http://schemas.microsoft.com/office/drawing/2014/main" id="{19A189DD-E4DA-49E4-BFEC-249923EEAFDB}"/>
               </a:ext>
             </a:extLst>
           </p:cNvPr>
@@ -5228,7 +5228,7 @@
           <p:cNvPr id="4" name="">
             <a:extLst xmlns:a="http://schemas.openxmlformats.org/drawingml/2006/main">
               <a:ext uri="{FF2B5EF4-FFF2-40B4-BE49-F238E27FC236}">
-                <a16:creationId xmlns:a16="http://schemas.microsoft.com/office/drawing/2014/main" id="{F80BA6BA-003B-4A81-9CCB-0F02BA02259D}"/>
+                <a16:creationId xmlns:a16="http://schemas.microsoft.com/office/drawing/2014/main" id="{A4BFDA48-F3EA-4169-A96B-9138EB25C513}"/>
               </a:ext>
             </a:extLst>
           </p:cNvPr>
@@ -5285,7 +5285,7 @@
           <p:cNvPr id="5" name="">
             <a:extLst xmlns:a="http://schemas.openxmlformats.org/drawingml/2006/main">
               <a:ext uri="{FF2B5EF4-FFF2-40B4-BE49-F238E27FC236}">
-                <a16:creationId xmlns:a16="http://schemas.microsoft.com/office/drawing/2014/main" id="{397FD9B4-BAB5-4C68-933B-10CA9B6D6323}"/>
+                <a16:creationId xmlns:a16="http://schemas.microsoft.com/office/drawing/2014/main" id="{885F422A-6A7D-4920-87D2-49B0CA745C9E}"/>
               </a:ext>
             </a:extLst>
           </p:cNvPr>
@@ -5342,7 +5342,7 @@
           <p:cNvPr id="6" name="">
             <a:extLst xmlns:a="http://schemas.openxmlformats.org/drawingml/2006/main">
               <a:ext uri="{FF2B5EF4-FFF2-40B4-BE49-F238E27FC236}">
-                <a16:creationId xmlns:a16="http://schemas.microsoft.com/office/drawing/2014/main" id="{58CA6874-C1C6-4AFF-8CBC-34DA78BAE71A}"/>
+                <a16:creationId xmlns:a16="http://schemas.microsoft.com/office/drawing/2014/main" id="{0AAB2F22-D2D2-4AA2-A5DF-4832582F3DAE}"/>
               </a:ext>
             </a:extLst>
           </p:cNvPr>
@@ -5399,7 +5399,7 @@
           <p:cNvPr id="7" name="">
             <a:extLst xmlns:a="http://schemas.openxmlformats.org/drawingml/2006/main">
               <a:ext uri="{FF2B5EF4-FFF2-40B4-BE49-F238E27FC236}">
-                <a16:creationId xmlns:a16="http://schemas.microsoft.com/office/drawing/2014/main" id="{CF53B08D-F128-4913-899B-E61E85F1942D}"/>
+                <a16:creationId xmlns:a16="http://schemas.microsoft.com/office/drawing/2014/main" id="{D55754DC-CA23-4819-BCD3-9A5703553E71}"/>
               </a:ext>
             </a:extLst>
           </p:cNvPr>
@@ -5456,7 +5456,7 @@
           <p:cNvPr id="8" name="">
             <a:extLst xmlns:a="http://schemas.openxmlformats.org/drawingml/2006/main">
               <a:ext uri="{FF2B5EF4-FFF2-40B4-BE49-F238E27FC236}">
-                <a16:creationId xmlns:a16="http://schemas.microsoft.com/office/drawing/2014/main" id="{20393EF4-6E08-4D46-92C8-325A312D8F6E}"/>
+                <a16:creationId xmlns:a16="http://schemas.microsoft.com/office/drawing/2014/main" id="{8209680B-7F54-4198-9EDE-62FC90B949C5}"/>
               </a:ext>
             </a:extLst>
           </p:cNvPr>
@@ -5488,7 +5488,7 @@
           <p:cNvPr id="9" name="">
             <a:extLst xmlns:a="http://schemas.openxmlformats.org/drawingml/2006/main">
               <a:ext uri="{FF2B5EF4-FFF2-40B4-BE49-F238E27FC236}">
-                <a16:creationId xmlns:a16="http://schemas.microsoft.com/office/drawing/2014/main" id="{0D0EC9F4-F09A-49EA-9A6B-741F7B1694DB}"/>
+                <a16:creationId xmlns:a16="http://schemas.microsoft.com/office/drawing/2014/main" id="{BADFB4C1-AD21-4F58-B92F-A07638E1E707}"/>
               </a:ext>
             </a:extLst>
           </p:cNvPr>
@@ -5704,7 +5704,7 @@
     </p:spTree>
     <p:extLst>
       <p:ext uri="{BB962C8B-B14F-4D97-AF65-F5344CB8AC3E}">
-        <p14:creationId xmlns:p14="http://schemas.microsoft.com/office/powerpoint/2010/main" val="2140922772"/>
+        <p14:creationId xmlns:p14="http://schemas.microsoft.com/office/powerpoint/2010/main" val="572508919"/>
       </p:ext>
     </p:extLst>
   </p:cSld>
@@ -5728,7 +5728,7 @@
           <p:cNvPr id="10" name="">
             <a:extLst xmlns:a="http://schemas.openxmlformats.org/drawingml/2006/main">
               <a:ext uri="{FF2B5EF4-FFF2-40B4-BE49-F238E27FC236}">
-                <a16:creationId xmlns:a16="http://schemas.microsoft.com/office/drawing/2014/main" id="{16CCAE6D-A7A5-45FF-9DF0-3A9DDBFAAB5E}"/>
+                <a16:creationId xmlns:a16="http://schemas.microsoft.com/office/drawing/2014/main" id="{FB77256D-6A43-4CC1-8D88-107E5014A860}"/>
               </a:ext>
             </a:extLst>
           </p:cNvPr>
@@ -5758,7 +5758,7 @@
           <p:cNvPr id="2" name="">
             <a:extLst xmlns:a="http://schemas.openxmlformats.org/drawingml/2006/main">
               <a:ext uri="{FF2B5EF4-FFF2-40B4-BE49-F238E27FC236}">
-                <a16:creationId xmlns:a16="http://schemas.microsoft.com/office/drawing/2014/main" id="{711C390B-937A-415A-8FE9-2D04F263F9DC}"/>
+                <a16:creationId xmlns:a16="http://schemas.microsoft.com/office/drawing/2014/main" id="{DA908FB2-BE7A-42B4-881A-3A9C66403872}"/>
               </a:ext>
             </a:extLst>
           </p:cNvPr>
@@ -5788,7 +5788,7 @@
           <p:cNvPr id="3" name="">
             <a:extLst xmlns:a="http://schemas.openxmlformats.org/drawingml/2006/main">
               <a:ext uri="{FF2B5EF4-FFF2-40B4-BE49-F238E27FC236}">
-                <a16:creationId xmlns:a16="http://schemas.microsoft.com/office/drawing/2014/main" id="{2F33341A-5BB3-4415-A56C-C3FB5E13E921}"/>
+                <a16:creationId xmlns:a16="http://schemas.microsoft.com/office/drawing/2014/main" id="{C269EA95-DD0A-4164-89F2-FA496655C04F}"/>
               </a:ext>
             </a:extLst>
           </p:cNvPr>
@@ -5845,7 +5845,7 @@
           <p:cNvPr id="4" name="">
             <a:extLst xmlns:a="http://schemas.openxmlformats.org/drawingml/2006/main">
               <a:ext uri="{FF2B5EF4-FFF2-40B4-BE49-F238E27FC236}">
-                <a16:creationId xmlns:a16="http://schemas.microsoft.com/office/drawing/2014/main" id="{01E3FBE5-84FE-4678-BF86-7A200A7CE397}"/>
+                <a16:creationId xmlns:a16="http://schemas.microsoft.com/office/drawing/2014/main" id="{922B00A1-C416-4A54-9346-B0954F050ADE}"/>
               </a:ext>
             </a:extLst>
           </p:cNvPr>
@@ -5902,7 +5902,7 @@
           <p:cNvPr id="5" name="">
             <a:extLst xmlns:a="http://schemas.openxmlformats.org/drawingml/2006/main">
               <a:ext uri="{FF2B5EF4-FFF2-40B4-BE49-F238E27FC236}">
-                <a16:creationId xmlns:a16="http://schemas.microsoft.com/office/drawing/2014/main" id="{8E7AB922-18F3-42B0-91A8-47299A0BB5AC}"/>
+                <a16:creationId xmlns:a16="http://schemas.microsoft.com/office/drawing/2014/main" id="{274C7526-6038-4CE8-A161-48022D132047}"/>
               </a:ext>
             </a:extLst>
           </p:cNvPr>
@@ -5959,7 +5959,7 @@
           <p:cNvPr id="6" name="">
             <a:extLst xmlns:a="http://schemas.openxmlformats.org/drawingml/2006/main">
               <a:ext uri="{FF2B5EF4-FFF2-40B4-BE49-F238E27FC236}">
-                <a16:creationId xmlns:a16="http://schemas.microsoft.com/office/drawing/2014/main" id="{FBAAB0CD-AE3C-4CE8-862F-3C7698680153}"/>
+                <a16:creationId xmlns:a16="http://schemas.microsoft.com/office/drawing/2014/main" id="{47DC8555-99FD-4768-98BD-1DE4A8FF37B1}"/>
               </a:ext>
             </a:extLst>
           </p:cNvPr>
@@ -6016,7 +6016,7 @@
           <p:cNvPr id="7" name="">
             <a:extLst xmlns:a="http://schemas.openxmlformats.org/drawingml/2006/main">
               <a:ext uri="{FF2B5EF4-FFF2-40B4-BE49-F238E27FC236}">
-                <a16:creationId xmlns:a16="http://schemas.microsoft.com/office/drawing/2014/main" id="{3EAC64D9-3321-4040-BEFE-7E1EE1656D3E}"/>
+                <a16:creationId xmlns:a16="http://schemas.microsoft.com/office/drawing/2014/main" id="{C63ED1E5-AA15-4983-AD8A-B8AD5FBB8784}"/>
               </a:ext>
             </a:extLst>
           </p:cNvPr>
@@ -6073,7 +6073,7 @@
           <p:cNvPr id="8" name="">
             <a:extLst xmlns:a="http://schemas.openxmlformats.org/drawingml/2006/main">
               <a:ext uri="{FF2B5EF4-FFF2-40B4-BE49-F238E27FC236}">
-                <a16:creationId xmlns:a16="http://schemas.microsoft.com/office/drawing/2014/main" id="{4AEB1FA5-7FCD-4330-8F37-DBC116BE3449}"/>
+                <a16:creationId xmlns:a16="http://schemas.microsoft.com/office/drawing/2014/main" id="{F50C2451-E28F-452C-A480-5D471CA88A84}"/>
               </a:ext>
             </a:extLst>
           </p:cNvPr>
@@ -6105,7 +6105,7 @@
           <p:cNvPr id="9" name="">
             <a:extLst xmlns:a="http://schemas.openxmlformats.org/drawingml/2006/main">
               <a:ext uri="{FF2B5EF4-FFF2-40B4-BE49-F238E27FC236}">
-                <a16:creationId xmlns:a16="http://schemas.microsoft.com/office/drawing/2014/main" id="{67088E26-C910-415E-BC35-DA61F6A3A2B7}"/>
+                <a16:creationId xmlns:a16="http://schemas.microsoft.com/office/drawing/2014/main" id="{BFAFC696-131C-48A3-942C-360BC28D0E7D}"/>
               </a:ext>
             </a:extLst>
           </p:cNvPr>
@@ -6321,7 +6321,7 @@
     </p:spTree>
     <p:extLst>
       <p:ext uri="{BB962C8B-B14F-4D97-AF65-F5344CB8AC3E}">
-        <p14:creationId xmlns:p14="http://schemas.microsoft.com/office/powerpoint/2010/main" val="1493977231"/>
+        <p14:creationId xmlns:p14="http://schemas.microsoft.com/office/powerpoint/2010/main" val="249199960"/>
       </p:ext>
     </p:extLst>
   </p:cSld>
@@ -6345,7 +6345,7 @@
           <p:cNvPr id="10" name="">
             <a:extLst xmlns:a="http://schemas.openxmlformats.org/drawingml/2006/main">
               <a:ext uri="{FF2B5EF4-FFF2-40B4-BE49-F238E27FC236}">
-                <a16:creationId xmlns:a16="http://schemas.microsoft.com/office/drawing/2014/main" id="{020A65AC-DB63-4292-A4A6-A60D41EC0285}"/>
+                <a16:creationId xmlns:a16="http://schemas.microsoft.com/office/drawing/2014/main" id="{8139352A-E79E-4466-8FE2-7A355B2ABDE7}"/>
               </a:ext>
             </a:extLst>
           </p:cNvPr>
@@ -6375,7 +6375,7 @@
           <p:cNvPr id="2" name="">
             <a:extLst xmlns:a="http://schemas.openxmlformats.org/drawingml/2006/main">
               <a:ext uri="{FF2B5EF4-FFF2-40B4-BE49-F238E27FC236}">
-                <a16:creationId xmlns:a16="http://schemas.microsoft.com/office/drawing/2014/main" id="{78C2813A-6BC2-4010-9F38-0242E0309330}"/>
+                <a16:creationId xmlns:a16="http://schemas.microsoft.com/office/drawing/2014/main" id="{337683BA-DD71-497A-B63E-8DFCBE848C07}"/>
               </a:ext>
             </a:extLst>
           </p:cNvPr>
@@ -6405,7 +6405,7 @@
           <p:cNvPr id="3" name="">
             <a:extLst xmlns:a="http://schemas.openxmlformats.org/drawingml/2006/main">
               <a:ext uri="{FF2B5EF4-FFF2-40B4-BE49-F238E27FC236}">
-                <a16:creationId xmlns:a16="http://schemas.microsoft.com/office/drawing/2014/main" id="{7DB34ABD-8558-41B4-86DD-A2807DEEE0A9}"/>
+                <a16:creationId xmlns:a16="http://schemas.microsoft.com/office/drawing/2014/main" id="{0C6E80CA-B63F-4786-8939-57F63CCEA035}"/>
               </a:ext>
             </a:extLst>
           </p:cNvPr>
@@ -6462,7 +6462,7 @@
           <p:cNvPr id="4" name="">
             <a:extLst xmlns:a="http://schemas.openxmlformats.org/drawingml/2006/main">
               <a:ext uri="{FF2B5EF4-FFF2-40B4-BE49-F238E27FC236}">
-                <a16:creationId xmlns:a16="http://schemas.microsoft.com/office/drawing/2014/main" id="{E60FC179-338B-421F-B5C9-4236D53D778B}"/>
+                <a16:creationId xmlns:a16="http://schemas.microsoft.com/office/drawing/2014/main" id="{5A7F76A3-44FF-4D9E-84E5-2FCB83B1DA6B}"/>
               </a:ext>
             </a:extLst>
           </p:cNvPr>
@@ -6519,7 +6519,7 @@
           <p:cNvPr id="5" name="">
             <a:extLst xmlns:a="http://schemas.openxmlformats.org/drawingml/2006/main">
               <a:ext uri="{FF2B5EF4-FFF2-40B4-BE49-F238E27FC236}">
-                <a16:creationId xmlns:a16="http://schemas.microsoft.com/office/drawing/2014/main" id="{10C0E4DC-C51C-4CC6-9465-1AC3F9B4F652}"/>
+                <a16:creationId xmlns:a16="http://schemas.microsoft.com/office/drawing/2014/main" id="{FF65C0E3-CD85-4D57-A048-BFB3A4E9D132}"/>
               </a:ext>
             </a:extLst>
           </p:cNvPr>
@@ -6576,7 +6576,7 @@
           <p:cNvPr id="6" name="">
             <a:extLst xmlns:a="http://schemas.openxmlformats.org/drawingml/2006/main">
               <a:ext uri="{FF2B5EF4-FFF2-40B4-BE49-F238E27FC236}">
-                <a16:creationId xmlns:a16="http://schemas.microsoft.com/office/drawing/2014/main" id="{EDF10909-2702-46DF-8DA0-980C4EBC7AAF}"/>
+                <a16:creationId xmlns:a16="http://schemas.microsoft.com/office/drawing/2014/main" id="{0873EDF3-582A-4569-8BE8-A32BA432582D}"/>
               </a:ext>
             </a:extLst>
           </p:cNvPr>
@@ -6633,7 +6633,7 @@
           <p:cNvPr id="7" name="">
             <a:extLst xmlns:a="http://schemas.openxmlformats.org/drawingml/2006/main">
               <a:ext uri="{FF2B5EF4-FFF2-40B4-BE49-F238E27FC236}">
-                <a16:creationId xmlns:a16="http://schemas.microsoft.com/office/drawing/2014/main" id="{B0A197CC-B2A3-44B6-9C23-0B9FC77E6C86}"/>
+                <a16:creationId xmlns:a16="http://schemas.microsoft.com/office/drawing/2014/main" id="{391A90ED-4CD5-4163-B4CC-A3420844793C}"/>
               </a:ext>
             </a:extLst>
           </p:cNvPr>
@@ -6690,7 +6690,7 @@
           <p:cNvPr id="8" name="">
             <a:extLst xmlns:a="http://schemas.openxmlformats.org/drawingml/2006/main">
               <a:ext uri="{FF2B5EF4-FFF2-40B4-BE49-F238E27FC236}">
-                <a16:creationId xmlns:a16="http://schemas.microsoft.com/office/drawing/2014/main" id="{B48AAF60-6024-47BF-9126-C97459534D21}"/>
+                <a16:creationId xmlns:a16="http://schemas.microsoft.com/office/drawing/2014/main" id="{35716776-D042-4102-9003-FCE1E1002895}"/>
               </a:ext>
             </a:extLst>
           </p:cNvPr>
@@ -6722,7 +6722,7 @@
           <p:cNvPr id="9" name="">
             <a:extLst xmlns:a="http://schemas.openxmlformats.org/drawingml/2006/main">
               <a:ext uri="{FF2B5EF4-FFF2-40B4-BE49-F238E27FC236}">
-                <a16:creationId xmlns:a16="http://schemas.microsoft.com/office/drawing/2014/main" id="{54C8C706-4143-44F6-A318-71C898954EE4}"/>
+                <a16:creationId xmlns:a16="http://schemas.microsoft.com/office/drawing/2014/main" id="{A0C6076F-86B7-4F0B-A15C-D6E8ECE159C9}"/>
               </a:ext>
             </a:extLst>
           </p:cNvPr>
@@ -6800,7 +6800,7 @@
     </p:spTree>
     <p:extLst>
       <p:ext uri="{BB962C8B-B14F-4D97-AF65-F5344CB8AC3E}">
-        <p14:creationId xmlns:p14="http://schemas.microsoft.com/office/powerpoint/2010/main" val="1222544933"/>
+        <p14:creationId xmlns:p14="http://schemas.microsoft.com/office/powerpoint/2010/main" val="713817785"/>
       </p:ext>
     </p:extLst>
   </p:cSld>
@@ -6824,7 +6824,7 @@
           <p:cNvPr id="10" name="">
             <a:extLst xmlns:a="http://schemas.openxmlformats.org/drawingml/2006/main">
               <a:ext uri="{FF2B5EF4-FFF2-40B4-BE49-F238E27FC236}">
-                <a16:creationId xmlns:a16="http://schemas.microsoft.com/office/drawing/2014/main" id="{1B003338-B670-4428-8B82-4DC6B83FD6FF}"/>
+                <a16:creationId xmlns:a16="http://schemas.microsoft.com/office/drawing/2014/main" id="{3C1014D7-E122-42AC-966B-AE5FC749C543}"/>
               </a:ext>
             </a:extLst>
           </p:cNvPr>
@@ -6854,7 +6854,7 @@
           <p:cNvPr id="2" name="">
             <a:extLst xmlns:a="http://schemas.openxmlformats.org/drawingml/2006/main">
               <a:ext uri="{FF2B5EF4-FFF2-40B4-BE49-F238E27FC236}">
-                <a16:creationId xmlns:a16="http://schemas.microsoft.com/office/drawing/2014/main" id="{74BE0452-8097-4149-A0C3-68AF5D1651A1}"/>
+                <a16:creationId xmlns:a16="http://schemas.microsoft.com/office/drawing/2014/main" id="{E6C4CA07-F2A4-4FAC-80AE-AB9F89167C66}"/>
               </a:ext>
             </a:extLst>
           </p:cNvPr>
@@ -6884,7 +6884,7 @@
           <p:cNvPr id="3" name="">
             <a:extLst xmlns:a="http://schemas.openxmlformats.org/drawingml/2006/main">
               <a:ext uri="{FF2B5EF4-FFF2-40B4-BE49-F238E27FC236}">
-                <a16:creationId xmlns:a16="http://schemas.microsoft.com/office/drawing/2014/main" id="{8A01CAAC-51E3-436D-90F9-3CC526634A18}"/>
+                <a16:creationId xmlns:a16="http://schemas.microsoft.com/office/drawing/2014/main" id="{F160DF16-CD20-473E-9B55-36EB56A46297}"/>
               </a:ext>
             </a:extLst>
           </p:cNvPr>
@@ -6941,7 +6941,7 @@
           <p:cNvPr id="4" name="">
             <a:extLst xmlns:a="http://schemas.openxmlformats.org/drawingml/2006/main">
               <a:ext uri="{FF2B5EF4-FFF2-40B4-BE49-F238E27FC236}">
-                <a16:creationId xmlns:a16="http://schemas.microsoft.com/office/drawing/2014/main" id="{3894CCD6-673D-4FC6-A25E-43258C95FCA2}"/>
+                <a16:creationId xmlns:a16="http://schemas.microsoft.com/office/drawing/2014/main" id="{95A8D841-4A1C-4A46-BC15-223AAE097B50}"/>
               </a:ext>
             </a:extLst>
           </p:cNvPr>
@@ -6998,7 +6998,7 @@
           <p:cNvPr id="5" name="">
             <a:extLst xmlns:a="http://schemas.openxmlformats.org/drawingml/2006/main">
               <a:ext uri="{FF2B5EF4-FFF2-40B4-BE49-F238E27FC236}">
-                <a16:creationId xmlns:a16="http://schemas.microsoft.com/office/drawing/2014/main" id="{75F13124-3C7F-467B-AE48-0180B10CBBDC}"/>
+                <a16:creationId xmlns:a16="http://schemas.microsoft.com/office/drawing/2014/main" id="{91157E24-5758-41BC-A3D7-1C2BAB226514}"/>
               </a:ext>
             </a:extLst>
           </p:cNvPr>
@@ -7055,7 +7055,7 @@
           <p:cNvPr id="6" name="">
             <a:extLst xmlns:a="http://schemas.openxmlformats.org/drawingml/2006/main">
               <a:ext uri="{FF2B5EF4-FFF2-40B4-BE49-F238E27FC236}">
-                <a16:creationId xmlns:a16="http://schemas.microsoft.com/office/drawing/2014/main" id="{95369DB9-B260-4BA2-9A77-41CDD4FB11BB}"/>
+                <a16:creationId xmlns:a16="http://schemas.microsoft.com/office/drawing/2014/main" id="{40988BB6-E20F-41DD-B83E-508042864620}"/>
               </a:ext>
             </a:extLst>
           </p:cNvPr>
@@ -7112,7 +7112,7 @@
           <p:cNvPr id="7" name="">
             <a:extLst xmlns:a="http://schemas.openxmlformats.org/drawingml/2006/main">
               <a:ext uri="{FF2B5EF4-FFF2-40B4-BE49-F238E27FC236}">
-                <a16:creationId xmlns:a16="http://schemas.microsoft.com/office/drawing/2014/main" id="{AB61A793-516D-473A-B92E-62723C6B0746}"/>
+                <a16:creationId xmlns:a16="http://schemas.microsoft.com/office/drawing/2014/main" id="{34898922-11D8-4BE1-83BF-006F15A9F1D6}"/>
               </a:ext>
             </a:extLst>
           </p:cNvPr>
@@ -7169,7 +7169,7 @@
           <p:cNvPr id="8" name="">
             <a:extLst xmlns:a="http://schemas.openxmlformats.org/drawingml/2006/main">
               <a:ext uri="{FF2B5EF4-FFF2-40B4-BE49-F238E27FC236}">
-                <a16:creationId xmlns:a16="http://schemas.microsoft.com/office/drawing/2014/main" id="{CA534B84-1680-4F07-9EAD-30573DF07091}"/>
+                <a16:creationId xmlns:a16="http://schemas.microsoft.com/office/drawing/2014/main" id="{9C7E4832-83F7-456C-B040-00D4BCD7CACB}"/>
               </a:ext>
             </a:extLst>
           </p:cNvPr>
@@ -7201,7 +7201,7 @@
           <p:cNvPr id="9" name="">
             <a:extLst xmlns:a="http://schemas.openxmlformats.org/drawingml/2006/main">
               <a:ext uri="{FF2B5EF4-FFF2-40B4-BE49-F238E27FC236}">
-                <a16:creationId xmlns:a16="http://schemas.microsoft.com/office/drawing/2014/main" id="{A88EA694-62AC-4D32-BEA0-6867A807FA4F}"/>
+                <a16:creationId xmlns:a16="http://schemas.microsoft.com/office/drawing/2014/main" id="{047A3EF8-2B3E-4B42-B372-FACCBA311025}"/>
               </a:ext>
             </a:extLst>
           </p:cNvPr>
@@ -7394,7 +7394,7 @@
     </p:spTree>
     <p:extLst>
       <p:ext uri="{BB962C8B-B14F-4D97-AF65-F5344CB8AC3E}">
-        <p14:creationId xmlns:p14="http://schemas.microsoft.com/office/powerpoint/2010/main" val="423561344"/>
+        <p14:creationId xmlns:p14="http://schemas.microsoft.com/office/powerpoint/2010/main" val="755400682"/>
       </p:ext>
     </p:extLst>
   </p:cSld>
@@ -7418,7 +7418,7 @@
           <p:cNvPr id="10" name="">
             <a:extLst xmlns:a="http://schemas.openxmlformats.org/drawingml/2006/main">
               <a:ext uri="{FF2B5EF4-FFF2-40B4-BE49-F238E27FC236}">
-                <a16:creationId xmlns:a16="http://schemas.microsoft.com/office/drawing/2014/main" id="{D8F6B562-FFDC-44E3-B81F-234D5533D8D5}"/>
+                <a16:creationId xmlns:a16="http://schemas.microsoft.com/office/drawing/2014/main" id="{78E5C6A2-26DF-4D23-9DA1-05ECB4D2CD85}"/>
               </a:ext>
             </a:extLst>
           </p:cNvPr>
@@ -7448,7 +7448,7 @@
           <p:cNvPr id="2" name="">
             <a:extLst xmlns:a="http://schemas.openxmlformats.org/drawingml/2006/main">
               <a:ext uri="{FF2B5EF4-FFF2-40B4-BE49-F238E27FC236}">
-                <a16:creationId xmlns:a16="http://schemas.microsoft.com/office/drawing/2014/main" id="{5EDE410C-F315-4C0D-9682-50BD915E0F3E}"/>
+                <a16:creationId xmlns:a16="http://schemas.microsoft.com/office/drawing/2014/main" id="{B99DCA7A-4FA8-4F2C-AE6E-AA865834557C}"/>
               </a:ext>
             </a:extLst>
           </p:cNvPr>
@@ -7478,7 +7478,7 @@
           <p:cNvPr id="3" name="">
             <a:extLst xmlns:a="http://schemas.openxmlformats.org/drawingml/2006/main">
               <a:ext uri="{FF2B5EF4-FFF2-40B4-BE49-F238E27FC236}">
-                <a16:creationId xmlns:a16="http://schemas.microsoft.com/office/drawing/2014/main" id="{C7FB465F-0E28-4299-8E59-8740F99A59AD}"/>
+                <a16:creationId xmlns:a16="http://schemas.microsoft.com/office/drawing/2014/main" id="{CCDD8997-F70C-4078-8742-C90CEEE9C45D}"/>
               </a:ext>
             </a:extLst>
           </p:cNvPr>
@@ -7535,7 +7535,7 @@
           <p:cNvPr id="4" name="">
             <a:extLst xmlns:a="http://schemas.openxmlformats.org/drawingml/2006/main">
               <a:ext uri="{FF2B5EF4-FFF2-40B4-BE49-F238E27FC236}">
-                <a16:creationId xmlns:a16="http://schemas.microsoft.com/office/drawing/2014/main" id="{4B76BE2F-125C-426B-9404-95E861F2FF9C}"/>
+                <a16:creationId xmlns:a16="http://schemas.microsoft.com/office/drawing/2014/main" id="{10914719-81EF-4782-BD81-ECA9E368FB34}"/>
               </a:ext>
             </a:extLst>
           </p:cNvPr>
@@ -7592,7 +7592,7 @@
           <p:cNvPr id="5" name="">
             <a:extLst xmlns:a="http://schemas.openxmlformats.org/drawingml/2006/main">
               <a:ext uri="{FF2B5EF4-FFF2-40B4-BE49-F238E27FC236}">
-                <a16:creationId xmlns:a16="http://schemas.microsoft.com/office/drawing/2014/main" id="{F0E851A3-6409-498B-BC1B-E5828BF71766}"/>
+                <a16:creationId xmlns:a16="http://schemas.microsoft.com/office/drawing/2014/main" id="{2C275F99-082F-4142-867B-9DE6A8284D2A}"/>
               </a:ext>
             </a:extLst>
           </p:cNvPr>
@@ -7649,7 +7649,7 @@
           <p:cNvPr id="6" name="">
             <a:extLst xmlns:a="http://schemas.openxmlformats.org/drawingml/2006/main">
               <a:ext uri="{FF2B5EF4-FFF2-40B4-BE49-F238E27FC236}">
-                <a16:creationId xmlns:a16="http://schemas.microsoft.com/office/drawing/2014/main" id="{5D3677EE-F03E-4ED0-90D9-3ECAAA5C6285}"/>
+                <a16:creationId xmlns:a16="http://schemas.microsoft.com/office/drawing/2014/main" id="{BBF77A9D-1F18-49DB-ACEC-8D1B15E452B0}"/>
               </a:ext>
             </a:extLst>
           </p:cNvPr>
@@ -7706,7 +7706,7 @@
           <p:cNvPr id="7" name="">
             <a:extLst xmlns:a="http://schemas.openxmlformats.org/drawingml/2006/main">
               <a:ext uri="{FF2B5EF4-FFF2-40B4-BE49-F238E27FC236}">
-                <a16:creationId xmlns:a16="http://schemas.microsoft.com/office/drawing/2014/main" id="{95C05024-687D-4299-848B-41396A8C3226}"/>
+                <a16:creationId xmlns:a16="http://schemas.microsoft.com/office/drawing/2014/main" id="{81AD9E47-270D-4F1D-86F2-9CCB10C1FD17}"/>
               </a:ext>
             </a:extLst>
           </p:cNvPr>
@@ -7763,7 +7763,7 @@
           <p:cNvPr id="8" name="">
             <a:extLst xmlns:a="http://schemas.openxmlformats.org/drawingml/2006/main">
               <a:ext uri="{FF2B5EF4-FFF2-40B4-BE49-F238E27FC236}">
-                <a16:creationId xmlns:a16="http://schemas.microsoft.com/office/drawing/2014/main" id="{DF6A77ED-0BA5-4B43-9764-88FFF94A13A4}"/>
+                <a16:creationId xmlns:a16="http://schemas.microsoft.com/office/drawing/2014/main" id="{E7CC7953-26F7-4E80-90EE-E77196234996}"/>
               </a:ext>
             </a:extLst>
           </p:cNvPr>
@@ -7795,7 +7795,7 @@
           <p:cNvPr id="9" name="">
             <a:extLst xmlns:a="http://schemas.openxmlformats.org/drawingml/2006/main">
               <a:ext uri="{FF2B5EF4-FFF2-40B4-BE49-F238E27FC236}">
-                <a16:creationId xmlns:a16="http://schemas.microsoft.com/office/drawing/2014/main" id="{3872A44E-7FF8-4425-81CC-110FFBF1722C}"/>
+                <a16:creationId xmlns:a16="http://schemas.microsoft.com/office/drawing/2014/main" id="{FF34A9BC-EDEA-449B-AEBA-35ED3A2DCDB3}"/>
               </a:ext>
             </a:extLst>
           </p:cNvPr>
@@ -7988,7 +7988,7 @@
     </p:spTree>
     <p:extLst>
       <p:ext uri="{BB962C8B-B14F-4D97-AF65-F5344CB8AC3E}">
-        <p14:creationId xmlns:p14="http://schemas.microsoft.com/office/powerpoint/2010/main" val="1478244627"/>
+        <p14:creationId xmlns:p14="http://schemas.microsoft.com/office/powerpoint/2010/main" val="1772428763"/>
       </p:ext>
     </p:extLst>
   </p:cSld>
@@ -8012,7 +8012,7 @@
           <p:cNvPr id="10" name="">
             <a:extLst xmlns:a="http://schemas.openxmlformats.org/drawingml/2006/main">
               <a:ext uri="{FF2B5EF4-FFF2-40B4-BE49-F238E27FC236}">
-                <a16:creationId xmlns:a16="http://schemas.microsoft.com/office/drawing/2014/main" id="{FE10862B-8284-4553-8BDC-3BD78586A0C2}"/>
+                <a16:creationId xmlns:a16="http://schemas.microsoft.com/office/drawing/2014/main" id="{CF63E148-1E61-442F-89D2-1C7E85AAC954}"/>
               </a:ext>
             </a:extLst>
           </p:cNvPr>
@@ -8042,7 +8042,7 @@
           <p:cNvPr id="2" name="">
             <a:extLst xmlns:a="http://schemas.openxmlformats.org/drawingml/2006/main">
               <a:ext uri="{FF2B5EF4-FFF2-40B4-BE49-F238E27FC236}">
-                <a16:creationId xmlns:a16="http://schemas.microsoft.com/office/drawing/2014/main" id="{83E32853-341F-4E81-A23E-AA03DE197CA1}"/>
+                <a16:creationId xmlns:a16="http://schemas.microsoft.com/office/drawing/2014/main" id="{65081075-FE10-4FD7-B6EE-31694773F723}"/>
               </a:ext>
             </a:extLst>
           </p:cNvPr>
@@ -8072,7 +8072,7 @@
           <p:cNvPr id="3" name="">
             <a:extLst xmlns:a="http://schemas.openxmlformats.org/drawingml/2006/main">
               <a:ext uri="{FF2B5EF4-FFF2-40B4-BE49-F238E27FC236}">
-                <a16:creationId xmlns:a16="http://schemas.microsoft.com/office/drawing/2014/main" id="{CB1FDCDE-405F-4197-BF5F-A54E3627BCB6}"/>
+                <a16:creationId xmlns:a16="http://schemas.microsoft.com/office/drawing/2014/main" id="{43BF3C0B-7561-409E-824E-0750B2C63506}"/>
               </a:ext>
             </a:extLst>
           </p:cNvPr>
@@ -8129,7 +8129,7 @@
           <p:cNvPr id="4" name="">
             <a:extLst xmlns:a="http://schemas.openxmlformats.org/drawingml/2006/main">
               <a:ext uri="{FF2B5EF4-FFF2-40B4-BE49-F238E27FC236}">
-                <a16:creationId xmlns:a16="http://schemas.microsoft.com/office/drawing/2014/main" id="{4DB128E3-00D3-4D93-BBFA-EBF054F2636B}"/>
+                <a16:creationId xmlns:a16="http://schemas.microsoft.com/office/drawing/2014/main" id="{5B1EBB27-5BFE-442A-AE59-054A708CEA3C}"/>
               </a:ext>
             </a:extLst>
           </p:cNvPr>
@@ -8186,7 +8186,7 @@
           <p:cNvPr id="5" name="">
             <a:extLst xmlns:a="http://schemas.openxmlformats.org/drawingml/2006/main">
               <a:ext uri="{FF2B5EF4-FFF2-40B4-BE49-F238E27FC236}">
-                <a16:creationId xmlns:a16="http://schemas.microsoft.com/office/drawing/2014/main" id="{D1A905C9-FC24-44DA-8734-9A0F52408C96}"/>
+                <a16:creationId xmlns:a16="http://schemas.microsoft.com/office/drawing/2014/main" id="{C4BCB3CA-CA8C-4500-9097-20EFA18E5E56}"/>
               </a:ext>
             </a:extLst>
           </p:cNvPr>
@@ -8243,7 +8243,7 @@
           <p:cNvPr id="6" name="">
             <a:extLst xmlns:a="http://schemas.openxmlformats.org/drawingml/2006/main">
               <a:ext uri="{FF2B5EF4-FFF2-40B4-BE49-F238E27FC236}">
-                <a16:creationId xmlns:a16="http://schemas.microsoft.com/office/drawing/2014/main" id="{A31E677C-2315-4001-91EF-137AB6818C14}"/>
+                <a16:creationId xmlns:a16="http://schemas.microsoft.com/office/drawing/2014/main" id="{376899B3-C8C7-4607-AAE4-24F9736B4312}"/>
               </a:ext>
             </a:extLst>
           </p:cNvPr>
@@ -8300,7 +8300,7 @@
           <p:cNvPr id="7" name="">
             <a:extLst xmlns:a="http://schemas.openxmlformats.org/drawingml/2006/main">
               <a:ext uri="{FF2B5EF4-FFF2-40B4-BE49-F238E27FC236}">
-                <a16:creationId xmlns:a16="http://schemas.microsoft.com/office/drawing/2014/main" id="{4780E586-FBFC-4DBE-9AA5-CDA5B7405FB5}"/>
+                <a16:creationId xmlns:a16="http://schemas.microsoft.com/office/drawing/2014/main" id="{D4E579DC-1FE5-4558-8019-38BCB29615FC}"/>
               </a:ext>
             </a:extLst>
           </p:cNvPr>
@@ -8357,7 +8357,7 @@
           <p:cNvPr id="8" name="">
             <a:extLst xmlns:a="http://schemas.openxmlformats.org/drawingml/2006/main">
               <a:ext uri="{FF2B5EF4-FFF2-40B4-BE49-F238E27FC236}">
-                <a16:creationId xmlns:a16="http://schemas.microsoft.com/office/drawing/2014/main" id="{5014CE02-4817-4503-AD99-8F136091698F}"/>
+                <a16:creationId xmlns:a16="http://schemas.microsoft.com/office/drawing/2014/main" id="{6BA71788-31BC-40D6-815D-672BD2B058B3}"/>
               </a:ext>
             </a:extLst>
           </p:cNvPr>
@@ -8389,7 +8389,7 @@
           <p:cNvPr id="9" name="">
             <a:extLst xmlns:a="http://schemas.openxmlformats.org/drawingml/2006/main">
               <a:ext uri="{FF2B5EF4-FFF2-40B4-BE49-F238E27FC236}">
-                <a16:creationId xmlns:a16="http://schemas.microsoft.com/office/drawing/2014/main" id="{43C036CD-7B7D-4232-B0C4-C4EC927D162D}"/>
+                <a16:creationId xmlns:a16="http://schemas.microsoft.com/office/drawing/2014/main" id="{20574E5F-C0D1-4253-905C-5FD50BA83260}"/>
               </a:ext>
             </a:extLst>
           </p:cNvPr>
@@ -8490,7 +8490,7 @@
     </p:spTree>
     <p:extLst>
       <p:ext uri="{BB962C8B-B14F-4D97-AF65-F5344CB8AC3E}">
-        <p14:creationId xmlns:p14="http://schemas.microsoft.com/office/powerpoint/2010/main" val="1100937984"/>
+        <p14:creationId xmlns:p14="http://schemas.microsoft.com/office/powerpoint/2010/main" val="198671774"/>
       </p:ext>
     </p:extLst>
   </p:cSld>
@@ -8511,10 +8511,10 @@
       </p:grpSpPr>
       <p:sp>
         <p:nvSpPr>
-          <p:cNvPr id="37" name="">
-            <a:extLst xmlns:a="http://schemas.openxmlformats.org/drawingml/2006/main">
-              <a:ext uri="{FF2B5EF4-FFF2-40B4-BE49-F238E27FC236}">
-                <a16:creationId xmlns:a16="http://schemas.microsoft.com/office/drawing/2014/main" id="{1A358F8D-8F85-45FD-BFA2-364643436BA6}"/>
+          <p:cNvPr id="8" name="">
+            <a:extLst xmlns:a="http://schemas.openxmlformats.org/drawingml/2006/main">
+              <a:ext uri="{FF2B5EF4-FFF2-40B4-BE49-F238E27FC236}">
+                <a16:creationId xmlns:a16="http://schemas.microsoft.com/office/drawing/2014/main" id="{DE20A791-5167-4ADA-9615-0733AF112BED}"/>
               </a:ext>
             </a:extLst>
           </p:cNvPr>
@@ -8544,7 +8544,7 @@
           <p:cNvPr id="2" name="">
             <a:extLst xmlns:a="http://schemas.openxmlformats.org/drawingml/2006/main">
               <a:ext uri="{FF2B5EF4-FFF2-40B4-BE49-F238E27FC236}">
-                <a16:creationId xmlns:a16="http://schemas.microsoft.com/office/drawing/2014/main" id="{E2FCF941-748F-4A14-997B-79F0145E8514}"/>
+                <a16:creationId xmlns:a16="http://schemas.microsoft.com/office/drawing/2014/main" id="{519822C4-BFCE-4AD1-8059-2076B5B523B8}"/>
               </a:ext>
             </a:extLst>
           </p:cNvPr>
@@ -8574,7 +8574,7 @@
           <p:cNvPr id="3" name="">
             <a:extLst xmlns:a="http://schemas.openxmlformats.org/drawingml/2006/main">
               <a:ext uri="{FF2B5EF4-FFF2-40B4-BE49-F238E27FC236}">
-                <a16:creationId xmlns:a16="http://schemas.microsoft.com/office/drawing/2014/main" id="{8C55E81A-F7FC-4824-AAF9-A9BB77A07979}"/>
+                <a16:creationId xmlns:a16="http://schemas.microsoft.com/office/drawing/2014/main" id="{9EB45E64-1DCE-4314-AEDA-0487B2D67F90}"/>
               </a:ext>
             </a:extLst>
           </p:cNvPr>
@@ -8631,7 +8631,7 @@
           <p:cNvPr id="4" name="">
             <a:extLst xmlns:a="http://schemas.openxmlformats.org/drawingml/2006/main">
               <a:ext uri="{FF2B5EF4-FFF2-40B4-BE49-F238E27FC236}">
-                <a16:creationId xmlns:a16="http://schemas.microsoft.com/office/drawing/2014/main" id="{674B7FF0-D061-400E-B77B-BAEE4C04A74B}"/>
+                <a16:creationId xmlns:a16="http://schemas.microsoft.com/office/drawing/2014/main" id="{DEFED370-D876-4E12-B034-68516BE37115}"/>
               </a:ext>
             </a:extLst>
           </p:cNvPr>
@@ -8688,7 +8688,7 @@
           <p:cNvPr id="5" name="">
             <a:extLst xmlns:a="http://schemas.openxmlformats.org/drawingml/2006/main">
               <a:ext uri="{FF2B5EF4-FFF2-40B4-BE49-F238E27FC236}">
-                <a16:creationId xmlns:a16="http://schemas.microsoft.com/office/drawing/2014/main" id="{C52F5024-0530-413E-A422-672643C0D3CB}"/>
+                <a16:creationId xmlns:a16="http://schemas.microsoft.com/office/drawing/2014/main" id="{61060ECE-10B5-4619-A641-2BEB9B4F8902}"/>
               </a:ext>
             </a:extLst>
           </p:cNvPr>
@@ -8740,58 +8740,46 @@
           </a:p>
         </p:txBody>
       </p:sp>
-      <p:sp>
-        <p:nvSpPr>
-          <p:cNvPr id="6" name="">
-            <a:extLst xmlns:a="http://schemas.openxmlformats.org/drawingml/2006/main">
-              <a:ext uri="{FF2B5EF4-FFF2-40B4-BE49-F238E27FC236}">
-                <a16:creationId xmlns:a16="http://schemas.microsoft.com/office/drawing/2014/main" id="{20327C36-429D-4ADC-BBA7-6921E6A1DCA0}"/>
-              </a:ext>
-            </a:extLst>
-          </p:cNvPr>
-          <p:cNvSpPr>
-            <a:spLocks xmlns:a="http://schemas.openxmlformats.org/drawingml/2006/main" noGrp="1"/>
-          </p:cNvSpPr>
-          <p:nvPr/>
-        </p:nvSpPr>
-        <p:spPr>
-          <a:xfrm xmlns:a="http://schemas.openxmlformats.org/drawingml/2006/main">
-            <a:off x="428625" y="1190625"/>
-            <a:ext cx="2000250" cy="1000125"/>
-          </a:xfrm>
-          <a:prstGeom xmlns:a="http://schemas.openxmlformats.org/drawingml/2006/main" prst="roundRect">
-            <a:avLst>
-              <a:gd name="adj" fmla="val 7619"/>
-            </a:avLst>
-          </a:prstGeom>
-          <a:solidFill xmlns:a="http://schemas.openxmlformats.org/drawingml/2006/main">
-            <a:srgbClr val="FFFFFF"/>
-          </a:solidFill>
-          <a:ln xmlns:a="http://schemas.openxmlformats.org/drawingml/2006/main" w="9525">
-            <a:solidFill>
-              <a:srgbClr val="D8E0E6"/>
-            </a:solidFill>
-          </a:ln>
-        </p:spPr>
-      </p:sp>
+      <p:pic>
+        <p:nvPicPr>
+          <p:cNvPr id="13" name=""/>
+          <p:cNvPicPr>
+            <a:picLocks xmlns:a="http://schemas.openxmlformats.org/drawingml/2006/main" noChangeAspect="1"/>
+          </p:cNvPicPr>
+          <p:nvPr/>
+        </p:nvPicPr>
+        <p:blipFill>
+          <a:blip xmlns:r="http://schemas.openxmlformats.org/officeDocument/2006/relationships" xmlns:a="http://schemas.openxmlformats.org/drawingml/2006/main" r:embed="Ra84b89c1bc844338"/>
+          <a:stretch xmlns:a="http://schemas.openxmlformats.org/drawingml/2006/main"/>
+        </p:blipFill>
+        <p:spPr>
+          <a:xfrm xmlns:a="http://schemas.openxmlformats.org/drawingml/2006/main">
+            <a:off x="1952625" y="904875"/>
+            <a:ext cx="8286750" cy="5429250"/>
+          </a:xfrm>
+          <a:prstGeom xmlns:a="http://schemas.openxmlformats.org/drawingml/2006/main" prst="rect">
+            <a:avLst/>
+          </a:prstGeom>
+        </p:spPr>
+      </p:pic>
       <p:sp>
         <p:nvSpPr>
           <p:cNvPr id="7" name="">
             <a:extLst xmlns:a="http://schemas.openxmlformats.org/drawingml/2006/main">
               <a:ext uri="{FF2B5EF4-FFF2-40B4-BE49-F238E27FC236}">
-                <a16:creationId xmlns:a16="http://schemas.microsoft.com/office/drawing/2014/main" id="{C163F3B3-95EF-4131-8FDC-279BEC7E2368}"/>
-              </a:ext>
-            </a:extLst>
-          </p:cNvPr>
-          <p:cNvSpPr>
-            <a:spLocks xmlns:a="http://schemas.openxmlformats.org/drawingml/2006/main" noGrp="1"/>
-          </p:cNvSpPr>
-          <p:nvPr/>
-        </p:nvSpPr>
-        <p:spPr>
-          <a:xfrm xmlns:a="http://schemas.openxmlformats.org/drawingml/2006/main">
-            <a:off x="542925" y="1285875"/>
-            <a:ext cx="1771650" cy="809625"/>
+                <a16:creationId xmlns:a16="http://schemas.microsoft.com/office/drawing/2014/main" id="{8F52A0AF-EA67-411C-B4A8-46446548AA9C}"/>
+              </a:ext>
+            </a:extLst>
+          </p:cNvPr>
+          <p:cNvSpPr>
+            <a:spLocks xmlns:a="http://schemas.openxmlformats.org/drawingml/2006/main" noGrp="1"/>
+          </p:cNvSpPr>
+          <p:nvPr/>
+        </p:nvSpPr>
+        <p:spPr>
+          <a:xfrm xmlns:a="http://schemas.openxmlformats.org/drawingml/2006/main">
+            <a:off x="762000" y="6334125"/>
+            <a:ext cx="10668000" cy="228600"/>
           </a:xfrm>
           <a:prstGeom xmlns:a="http://schemas.openxmlformats.org/drawingml/2006/main" prst="rect">
             <a:avLst/>
@@ -8803,1803 +8791,12 @@
         </p:spPr>
         <p:txBody>
           <a:bodyPr xmlns:a="http://schemas.openxmlformats.org/drawingml/2006/main" anchor="ctr">
-            <a:normAutofit fontScale="100000"/>
+            <a:normAutofit fontScale="80000"/>
           </a:bodyPr>
           <a:lstStyle xmlns:a="http://schemas.openxmlformats.org/drawingml/2006/main"/>
           <a:p xmlns:a="http://schemas.openxmlformats.org/drawingml/2006/main">
             <a:pPr algn="ctr">
-              <a:defRPr sz="1125" b="1">
-                <a:solidFill>
-                  <a:srgbClr val="102A43"/>
-                </a:solidFill>
-                <a:latin typeface="Aptos"/>
-                <a:ea typeface="Aptos"/>
-                <a:cs typeface="Aptos"/>
-              </a:defRPr>
-            </a:pPr>
-            <a:r>
-              <a:rPr sz="1125" b="1">
-                <a:solidFill>
-                  <a:srgbClr val="102A43"/>
-                </a:solidFill>
-                <a:latin typeface="Aptos"/>
-                <a:ea typeface="Aptos"/>
-                <a:cs typeface="Aptos"/>
-              </a:rPr>
-              <a:t>HOTEL</a:t>
-            </a:r>
-          </a:p>
-          <a:p xmlns:a="http://schemas.openxmlformats.org/drawingml/2006/main">
-            <a:pPr algn="ctr">
-              <a:defRPr sz="1125" b="1">
-                <a:solidFill>
-                  <a:srgbClr val="102A43"/>
-                </a:solidFill>
-                <a:latin typeface="Aptos"/>
-                <a:ea typeface="Aptos"/>
-                <a:cs typeface="Aptos"/>
-              </a:defRPr>
-            </a:pPr>
-            <a:r>
-              <a:rPr sz="1125" b="1">
-                <a:solidFill>
-                  <a:srgbClr val="102A43"/>
-                </a:solidFill>
-                <a:latin typeface="Aptos"/>
-                <a:ea typeface="Aptos"/>
-                <a:cs typeface="Aptos"/>
-              </a:rPr>
-              <a:t>PK Sigla_Hotel</a:t>
-            </a:r>
-          </a:p>
-        </p:txBody>
-      </p:sp>
-      <p:sp>
-        <p:nvSpPr>
-          <p:cNvPr id="8" name="">
-            <a:extLst xmlns:a="http://schemas.openxmlformats.org/drawingml/2006/main">
-              <a:ext uri="{FF2B5EF4-FFF2-40B4-BE49-F238E27FC236}">
-                <a16:creationId xmlns:a16="http://schemas.microsoft.com/office/drawing/2014/main" id="{C9F519F8-14BD-4286-8557-ECDB911FAE60}"/>
-              </a:ext>
-            </a:extLst>
-          </p:cNvPr>
-          <p:cNvSpPr>
-            <a:spLocks xmlns:a="http://schemas.openxmlformats.org/drawingml/2006/main" noGrp="1"/>
-          </p:cNvSpPr>
-          <p:nvPr/>
-        </p:nvSpPr>
-        <p:spPr>
-          <a:xfrm xmlns:a="http://schemas.openxmlformats.org/drawingml/2006/main">
-            <a:off x="2905125" y="1095375"/>
-            <a:ext cx="2333625" cy="1000125"/>
-          </a:xfrm>
-          <a:prstGeom xmlns:a="http://schemas.openxmlformats.org/drawingml/2006/main" prst="roundRect">
-            <a:avLst>
-              <a:gd name="adj" fmla="val 7619"/>
-            </a:avLst>
-          </a:prstGeom>
-          <a:solidFill xmlns:a="http://schemas.openxmlformats.org/drawingml/2006/main">
-            <a:srgbClr val="FFFFFF"/>
-          </a:solidFill>
-          <a:ln xmlns:a="http://schemas.openxmlformats.org/drawingml/2006/main" w="9525">
-            <a:solidFill>
-              <a:srgbClr val="D8E0E6"/>
-            </a:solidFill>
-          </a:ln>
-        </p:spPr>
-      </p:sp>
-      <p:sp>
-        <p:nvSpPr>
-          <p:cNvPr id="9" name="">
-            <a:extLst xmlns:a="http://schemas.openxmlformats.org/drawingml/2006/main">
-              <a:ext uri="{FF2B5EF4-FFF2-40B4-BE49-F238E27FC236}">
-                <a16:creationId xmlns:a16="http://schemas.microsoft.com/office/drawing/2014/main" id="{BEA77F66-8A69-45E9-B6C2-1DFCCB81A3AF}"/>
-              </a:ext>
-            </a:extLst>
-          </p:cNvPr>
-          <p:cNvSpPr>
-            <a:spLocks xmlns:a="http://schemas.openxmlformats.org/drawingml/2006/main" noGrp="1"/>
-          </p:cNvSpPr>
-          <p:nvPr/>
-        </p:nvSpPr>
-        <p:spPr>
-          <a:xfrm xmlns:a="http://schemas.openxmlformats.org/drawingml/2006/main">
-            <a:off x="3019425" y="1190625"/>
-            <a:ext cx="2105025" cy="809625"/>
-          </a:xfrm>
-          <a:prstGeom xmlns:a="http://schemas.openxmlformats.org/drawingml/2006/main" prst="rect">
-            <a:avLst/>
-          </a:prstGeom>
-          <a:noFill xmlns:a="http://schemas.openxmlformats.org/drawingml/2006/main"/>
-          <a:ln xmlns:a="http://schemas.openxmlformats.org/drawingml/2006/main" w="0">
-            <a:noFill/>
-          </a:ln>
-        </p:spPr>
-        <p:txBody>
-          <a:bodyPr xmlns:a="http://schemas.openxmlformats.org/drawingml/2006/main" anchor="ctr">
-            <a:normAutofit fontScale="100000"/>
-          </a:bodyPr>
-          <a:lstStyle xmlns:a="http://schemas.openxmlformats.org/drawingml/2006/main"/>
-          <a:p xmlns:a="http://schemas.openxmlformats.org/drawingml/2006/main">
-            <a:pPr algn="ctr">
-              <a:defRPr sz="1125" b="1">
-                <a:solidFill>
-                  <a:srgbClr val="102A43"/>
-                </a:solidFill>
-                <a:latin typeface="Aptos"/>
-                <a:ea typeface="Aptos"/>
-                <a:cs typeface="Aptos"/>
-              </a:defRPr>
-            </a:pPr>
-            <a:r>
-              <a:rPr sz="1125" b="1">
-                <a:solidFill>
-                  <a:srgbClr val="102A43"/>
-                </a:solidFill>
-                <a:latin typeface="Aptos"/>
-                <a:ea typeface="Aptos"/>
-                <a:cs typeface="Aptos"/>
-              </a:rPr>
-              <a:t>QUARTO</a:t>
-            </a:r>
-          </a:p>
-          <a:p xmlns:a="http://schemas.openxmlformats.org/drawingml/2006/main">
-            <a:pPr algn="ctr">
-              <a:defRPr sz="1125" b="1">
-                <a:solidFill>
-                  <a:srgbClr val="102A43"/>
-                </a:solidFill>
-                <a:latin typeface="Aptos"/>
-                <a:ea typeface="Aptos"/>
-                <a:cs typeface="Aptos"/>
-              </a:defRPr>
-            </a:pPr>
-            <a:r>
-              <a:rPr sz="1125" b="1">
-                <a:solidFill>
-                  <a:srgbClr val="102A43"/>
-                </a:solidFill>
-                <a:latin typeface="Aptos"/>
-                <a:ea typeface="Aptos"/>
-                <a:cs typeface="Aptos"/>
-              </a:rPr>
-              <a:t>PK/FK Sigla_Hotel</a:t>
-            </a:r>
-          </a:p>
-          <a:p xmlns:a="http://schemas.openxmlformats.org/drawingml/2006/main">
-            <a:pPr algn="ctr">
-              <a:defRPr sz="1125" b="1">
-                <a:solidFill>
-                  <a:srgbClr val="102A43"/>
-                </a:solidFill>
-                <a:latin typeface="Aptos"/>
-                <a:ea typeface="Aptos"/>
-                <a:cs typeface="Aptos"/>
-              </a:defRPr>
-            </a:pPr>
-            <a:r>
-              <a:rPr sz="1125" b="1">
-                <a:solidFill>
-                  <a:srgbClr val="102A43"/>
-                </a:solidFill>
-                <a:latin typeface="Aptos"/>
-                <a:ea typeface="Aptos"/>
-                <a:cs typeface="Aptos"/>
-              </a:rPr>
-              <a:t>PK Numero_Quarto</a:t>
-            </a:r>
-          </a:p>
-        </p:txBody>
-      </p:sp>
-      <p:sp>
-        <p:nvSpPr>
-          <p:cNvPr id="10" name="">
-            <a:extLst xmlns:a="http://schemas.openxmlformats.org/drawingml/2006/main">
-              <a:ext uri="{FF2B5EF4-FFF2-40B4-BE49-F238E27FC236}">
-                <a16:creationId xmlns:a16="http://schemas.microsoft.com/office/drawing/2014/main" id="{EEA4A7D6-3D94-4A22-BD2C-50DB21B9FCCC}"/>
-              </a:ext>
-            </a:extLst>
-          </p:cNvPr>
-          <p:cNvSpPr>
-            <a:spLocks xmlns:a="http://schemas.openxmlformats.org/drawingml/2006/main" noGrp="1"/>
-          </p:cNvSpPr>
-          <p:nvPr/>
-        </p:nvSpPr>
-        <p:spPr>
-          <a:xfrm xmlns:a="http://schemas.openxmlformats.org/drawingml/2006/main">
-            <a:off x="5810250" y="952500"/>
-            <a:ext cx="2762250" cy="1524000"/>
-          </a:xfrm>
-          <a:prstGeom xmlns:a="http://schemas.openxmlformats.org/drawingml/2006/main" prst="roundRect">
-            <a:avLst>
-              <a:gd name="adj" fmla="val 5000"/>
-            </a:avLst>
-          </a:prstGeom>
-          <a:solidFill xmlns:a="http://schemas.openxmlformats.org/drawingml/2006/main">
-            <a:srgbClr val="FFFFFF"/>
-          </a:solidFill>
-          <a:ln xmlns:a="http://schemas.openxmlformats.org/drawingml/2006/main" w="9525">
-            <a:solidFill>
-              <a:srgbClr val="D8E0E6"/>
-            </a:solidFill>
-          </a:ln>
-        </p:spPr>
-      </p:sp>
-      <p:sp>
-        <p:nvSpPr>
-          <p:cNvPr id="11" name="">
-            <a:extLst xmlns:a="http://schemas.openxmlformats.org/drawingml/2006/main">
-              <a:ext uri="{FF2B5EF4-FFF2-40B4-BE49-F238E27FC236}">
-                <a16:creationId xmlns:a16="http://schemas.microsoft.com/office/drawing/2014/main" id="{8748DB60-5F7C-4268-B08C-146E0615A82B}"/>
-              </a:ext>
-            </a:extLst>
-          </p:cNvPr>
-          <p:cNvSpPr>
-            <a:spLocks xmlns:a="http://schemas.openxmlformats.org/drawingml/2006/main" noGrp="1"/>
-          </p:cNvSpPr>
-          <p:nvPr/>
-        </p:nvSpPr>
-        <p:spPr>
-          <a:xfrm xmlns:a="http://schemas.openxmlformats.org/drawingml/2006/main">
-            <a:off x="5924550" y="1047750"/>
-            <a:ext cx="2533650" cy="1333500"/>
-          </a:xfrm>
-          <a:prstGeom xmlns:a="http://schemas.openxmlformats.org/drawingml/2006/main" prst="rect">
-            <a:avLst/>
-          </a:prstGeom>
-          <a:noFill xmlns:a="http://schemas.openxmlformats.org/drawingml/2006/main"/>
-          <a:ln xmlns:a="http://schemas.openxmlformats.org/drawingml/2006/main" w="0">
-            <a:noFill/>
-          </a:ln>
-        </p:spPr>
-        <p:txBody>
-          <a:bodyPr xmlns:a="http://schemas.openxmlformats.org/drawingml/2006/main" anchor="ctr">
-            <a:normAutofit fontScale="100000"/>
-          </a:bodyPr>
-          <a:lstStyle xmlns:a="http://schemas.openxmlformats.org/drawingml/2006/main"/>
-          <a:p xmlns:a="http://schemas.openxmlformats.org/drawingml/2006/main">
-            <a:pPr algn="ctr">
-              <a:defRPr sz="1125" b="1">
-                <a:solidFill>
-                  <a:srgbClr val="102A43"/>
-                </a:solidFill>
-                <a:latin typeface="Aptos"/>
-                <a:ea typeface="Aptos"/>
-                <a:cs typeface="Aptos"/>
-              </a:defRPr>
-            </a:pPr>
-            <a:r>
-              <a:rPr sz="1125" b="1">
-                <a:solidFill>
-                  <a:srgbClr val="102A43"/>
-                </a:solidFill>
-                <a:latin typeface="Aptos"/>
-                <a:ea typeface="Aptos"/>
-                <a:cs typeface="Aptos"/>
-              </a:rPr>
-              <a:t>RESERVA_QUARTOS</a:t>
-            </a:r>
-          </a:p>
-          <a:p xmlns:a="http://schemas.openxmlformats.org/drawingml/2006/main">
-            <a:pPr algn="ctr">
-              <a:defRPr sz="1125" b="1">
-                <a:solidFill>
-                  <a:srgbClr val="102A43"/>
-                </a:solidFill>
-                <a:latin typeface="Aptos"/>
-                <a:ea typeface="Aptos"/>
-                <a:cs typeface="Aptos"/>
-              </a:defRPr>
-            </a:pPr>
-            <a:r>
-              <a:rPr sz="1125" b="1">
-                <a:solidFill>
-                  <a:srgbClr val="102A43"/>
-                </a:solidFill>
-                <a:latin typeface="Aptos"/>
-                <a:ea typeface="Aptos"/>
-                <a:cs typeface="Aptos"/>
-              </a:rPr>
-              <a:t>PK/FK Sigla_Hotel</a:t>
-            </a:r>
-          </a:p>
-          <a:p xmlns:a="http://schemas.openxmlformats.org/drawingml/2006/main">
-            <a:pPr algn="ctr">
-              <a:defRPr sz="1125" b="1">
-                <a:solidFill>
-                  <a:srgbClr val="102A43"/>
-                </a:solidFill>
-                <a:latin typeface="Aptos"/>
-                <a:ea typeface="Aptos"/>
-                <a:cs typeface="Aptos"/>
-              </a:defRPr>
-            </a:pPr>
-            <a:r>
-              <a:rPr sz="1125" b="1">
-                <a:solidFill>
-                  <a:srgbClr val="102A43"/>
-                </a:solidFill>
-                <a:latin typeface="Aptos"/>
-                <a:ea typeface="Aptos"/>
-                <a:cs typeface="Aptos"/>
-              </a:rPr>
-              <a:t>PK/FK Numero_Quarto</a:t>
-            </a:r>
-          </a:p>
-          <a:p xmlns:a="http://schemas.openxmlformats.org/drawingml/2006/main">
-            <a:pPr algn="ctr">
-              <a:defRPr sz="1125" b="1">
-                <a:solidFill>
-                  <a:srgbClr val="102A43"/>
-                </a:solidFill>
-                <a:latin typeface="Aptos"/>
-                <a:ea typeface="Aptos"/>
-                <a:cs typeface="Aptos"/>
-              </a:defRPr>
-            </a:pPr>
-            <a:r>
-              <a:rPr sz="1125" b="1">
-                <a:solidFill>
-                  <a:srgbClr val="102A43"/>
-                </a:solidFill>
-                <a:latin typeface="Aptos"/>
-                <a:ea typeface="Aptos"/>
-                <a:cs typeface="Aptos"/>
-              </a:rPr>
-              <a:t>PK/FK Numero_Reserva</a:t>
-            </a:r>
-          </a:p>
-        </p:txBody>
-      </p:sp>
-      <p:sp>
-        <p:nvSpPr>
-          <p:cNvPr id="12" name="">
-            <a:extLst xmlns:a="http://schemas.openxmlformats.org/drawingml/2006/main">
-              <a:ext uri="{FF2B5EF4-FFF2-40B4-BE49-F238E27FC236}">
-                <a16:creationId xmlns:a16="http://schemas.microsoft.com/office/drawing/2014/main" id="{1035E645-5F52-409E-8F74-D4A3BF82A55E}"/>
-              </a:ext>
-            </a:extLst>
-          </p:cNvPr>
-          <p:cNvSpPr>
-            <a:spLocks xmlns:a="http://schemas.openxmlformats.org/drawingml/2006/main" noGrp="1"/>
-          </p:cNvSpPr>
-          <p:nvPr/>
-        </p:nvSpPr>
-        <p:spPr>
-          <a:xfrm xmlns:a="http://schemas.openxmlformats.org/drawingml/2006/main">
-            <a:off x="9096375" y="1190625"/>
-            <a:ext cx="2428875" cy="1000125"/>
-          </a:xfrm>
-          <a:prstGeom xmlns:a="http://schemas.openxmlformats.org/drawingml/2006/main" prst="roundRect">
-            <a:avLst>
-              <a:gd name="adj" fmla="val 7619"/>
-            </a:avLst>
-          </a:prstGeom>
-          <a:solidFill xmlns:a="http://schemas.openxmlformats.org/drawingml/2006/main">
-            <a:srgbClr val="FFFFFF"/>
-          </a:solidFill>
-          <a:ln xmlns:a="http://schemas.openxmlformats.org/drawingml/2006/main" w="9525">
-            <a:solidFill>
-              <a:srgbClr val="D8E0E6"/>
-            </a:solidFill>
-          </a:ln>
-        </p:spPr>
-      </p:sp>
-      <p:sp>
-        <p:nvSpPr>
-          <p:cNvPr id="13" name="">
-            <a:extLst xmlns:a="http://schemas.openxmlformats.org/drawingml/2006/main">
-              <a:ext uri="{FF2B5EF4-FFF2-40B4-BE49-F238E27FC236}">
-                <a16:creationId xmlns:a16="http://schemas.microsoft.com/office/drawing/2014/main" id="{4AE0D84F-75E8-401F-81E1-E9BA07591560}"/>
-              </a:ext>
-            </a:extLst>
-          </p:cNvPr>
-          <p:cNvSpPr>
-            <a:spLocks xmlns:a="http://schemas.openxmlformats.org/drawingml/2006/main" noGrp="1"/>
-          </p:cNvSpPr>
-          <p:nvPr/>
-        </p:nvSpPr>
-        <p:spPr>
-          <a:xfrm xmlns:a="http://schemas.openxmlformats.org/drawingml/2006/main">
-            <a:off x="9210675" y="1285875"/>
-            <a:ext cx="2200275" cy="809625"/>
-          </a:xfrm>
-          <a:prstGeom xmlns:a="http://schemas.openxmlformats.org/drawingml/2006/main" prst="rect">
-            <a:avLst/>
-          </a:prstGeom>
-          <a:noFill xmlns:a="http://schemas.openxmlformats.org/drawingml/2006/main"/>
-          <a:ln xmlns:a="http://schemas.openxmlformats.org/drawingml/2006/main" w="0">
-            <a:noFill/>
-          </a:ln>
-        </p:spPr>
-        <p:txBody>
-          <a:bodyPr xmlns:a="http://schemas.openxmlformats.org/drawingml/2006/main" anchor="ctr">
-            <a:normAutofit fontScale="100000"/>
-          </a:bodyPr>
-          <a:lstStyle xmlns:a="http://schemas.openxmlformats.org/drawingml/2006/main"/>
-          <a:p xmlns:a="http://schemas.openxmlformats.org/drawingml/2006/main">
-            <a:pPr algn="ctr">
-              <a:defRPr sz="1125" b="1">
-                <a:solidFill>
-                  <a:srgbClr val="102A43"/>
-                </a:solidFill>
-                <a:latin typeface="Aptos"/>
-                <a:ea typeface="Aptos"/>
-                <a:cs typeface="Aptos"/>
-              </a:defRPr>
-            </a:pPr>
-            <a:r>
-              <a:rPr sz="1125" b="1">
-                <a:solidFill>
-                  <a:srgbClr val="102A43"/>
-                </a:solidFill>
-                <a:latin typeface="Aptos"/>
-                <a:ea typeface="Aptos"/>
-                <a:cs typeface="Aptos"/>
-              </a:rPr>
-              <a:t>RESERVA</a:t>
-            </a:r>
-          </a:p>
-          <a:p xmlns:a="http://schemas.openxmlformats.org/drawingml/2006/main">
-            <a:pPr algn="ctr">
-              <a:defRPr sz="1125" b="1">
-                <a:solidFill>
-                  <a:srgbClr val="102A43"/>
-                </a:solidFill>
-                <a:latin typeface="Aptos"/>
-                <a:ea typeface="Aptos"/>
-                <a:cs typeface="Aptos"/>
-              </a:defRPr>
-            </a:pPr>
-            <a:r>
-              <a:rPr sz="1125" b="1">
-                <a:solidFill>
-                  <a:srgbClr val="102A43"/>
-                </a:solidFill>
-                <a:latin typeface="Aptos"/>
-                <a:ea typeface="Aptos"/>
-                <a:cs typeface="Aptos"/>
-              </a:rPr>
-              <a:t>PK Numero_Reserva</a:t>
-            </a:r>
-          </a:p>
-          <a:p xmlns:a="http://schemas.openxmlformats.org/drawingml/2006/main">
-            <a:pPr algn="ctr">
-              <a:defRPr sz="1125" b="1">
-                <a:solidFill>
-                  <a:srgbClr val="102A43"/>
-                </a:solidFill>
-                <a:latin typeface="Aptos"/>
-                <a:ea typeface="Aptos"/>
-                <a:cs typeface="Aptos"/>
-              </a:defRPr>
-            </a:pPr>
-            <a:r>
-              <a:rPr sz="1125" b="1">
-                <a:solidFill>
-                  <a:srgbClr val="102A43"/>
-                </a:solidFill>
-                <a:latin typeface="Aptos"/>
-                <a:ea typeface="Aptos"/>
-                <a:cs typeface="Aptos"/>
-              </a:rPr>
-              <a:t>FK Numero_Cliente</a:t>
-            </a:r>
-          </a:p>
-        </p:txBody>
-      </p:sp>
-      <p:sp>
-        <p:nvSpPr>
-          <p:cNvPr id="14" name="">
-            <a:extLst xmlns:a="http://schemas.openxmlformats.org/drawingml/2006/main">
-              <a:ext uri="{FF2B5EF4-FFF2-40B4-BE49-F238E27FC236}">
-                <a16:creationId xmlns:a16="http://schemas.microsoft.com/office/drawing/2014/main" id="{3F5F3585-6965-45F3-9AFD-AC31E70BE75E}"/>
-              </a:ext>
-            </a:extLst>
-          </p:cNvPr>
-          <p:cNvSpPr>
-            <a:spLocks xmlns:a="http://schemas.openxmlformats.org/drawingml/2006/main" noGrp="1"/>
-          </p:cNvSpPr>
-          <p:nvPr/>
-        </p:nvSpPr>
-        <p:spPr>
-          <a:xfrm xmlns:a="http://schemas.openxmlformats.org/drawingml/2006/main">
-            <a:off x="5810250" y="4095750"/>
-            <a:ext cx="2762250" cy="1000125"/>
-          </a:xfrm>
-          <a:prstGeom xmlns:a="http://schemas.openxmlformats.org/drawingml/2006/main" prst="roundRect">
-            <a:avLst>
-              <a:gd name="adj" fmla="val 7619"/>
-            </a:avLst>
-          </a:prstGeom>
-          <a:solidFill xmlns:a="http://schemas.openxmlformats.org/drawingml/2006/main">
-            <a:srgbClr val="FFFFFF"/>
-          </a:solidFill>
-          <a:ln xmlns:a="http://schemas.openxmlformats.org/drawingml/2006/main" w="9525">
-            <a:solidFill>
-              <a:srgbClr val="D8E0E6"/>
-            </a:solidFill>
-          </a:ln>
-        </p:spPr>
-      </p:sp>
-      <p:sp>
-        <p:nvSpPr>
-          <p:cNvPr id="15" name="">
-            <a:extLst xmlns:a="http://schemas.openxmlformats.org/drawingml/2006/main">
-              <a:ext uri="{FF2B5EF4-FFF2-40B4-BE49-F238E27FC236}">
-                <a16:creationId xmlns:a16="http://schemas.microsoft.com/office/drawing/2014/main" id="{A83D14E9-6E9A-49AD-BD0A-419DE6109904}"/>
-              </a:ext>
-            </a:extLst>
-          </p:cNvPr>
-          <p:cNvSpPr>
-            <a:spLocks xmlns:a="http://schemas.openxmlformats.org/drawingml/2006/main" noGrp="1"/>
-          </p:cNvSpPr>
-          <p:nvPr/>
-        </p:nvSpPr>
-        <p:spPr>
-          <a:xfrm xmlns:a="http://schemas.openxmlformats.org/drawingml/2006/main">
-            <a:off x="5924550" y="4191000"/>
-            <a:ext cx="2533650" cy="809625"/>
-          </a:xfrm>
-          <a:prstGeom xmlns:a="http://schemas.openxmlformats.org/drawingml/2006/main" prst="rect">
-            <a:avLst/>
-          </a:prstGeom>
-          <a:noFill xmlns:a="http://schemas.openxmlformats.org/drawingml/2006/main"/>
-          <a:ln xmlns:a="http://schemas.openxmlformats.org/drawingml/2006/main" w="0">
-            <a:noFill/>
-          </a:ln>
-        </p:spPr>
-        <p:txBody>
-          <a:bodyPr xmlns:a="http://schemas.openxmlformats.org/drawingml/2006/main" anchor="ctr">
-            <a:normAutofit fontScale="100000"/>
-          </a:bodyPr>
-          <a:lstStyle xmlns:a="http://schemas.openxmlformats.org/drawingml/2006/main"/>
-          <a:p xmlns:a="http://schemas.openxmlformats.org/drawingml/2006/main">
-            <a:pPr algn="ctr">
-              <a:defRPr sz="1125" b="1">
-                <a:solidFill>
-                  <a:srgbClr val="102A43"/>
-                </a:solidFill>
-                <a:latin typeface="Aptos"/>
-                <a:ea typeface="Aptos"/>
-                <a:cs typeface="Aptos"/>
-              </a:defRPr>
-            </a:pPr>
-            <a:r>
-              <a:rPr sz="1125" b="1">
-                <a:solidFill>
-                  <a:srgbClr val="102A43"/>
-                </a:solidFill>
-                <a:latin typeface="Aptos"/>
-                <a:ea typeface="Aptos"/>
-                <a:cs typeface="Aptos"/>
-              </a:rPr>
-              <a:t>CLIENTE</a:t>
-            </a:r>
-          </a:p>
-          <a:p xmlns:a="http://schemas.openxmlformats.org/drawingml/2006/main">
-            <a:pPr algn="ctr">
-              <a:defRPr sz="1125" b="1">
-                <a:solidFill>
-                  <a:srgbClr val="102A43"/>
-                </a:solidFill>
-                <a:latin typeface="Aptos"/>
-                <a:ea typeface="Aptos"/>
-                <a:cs typeface="Aptos"/>
-              </a:defRPr>
-            </a:pPr>
-            <a:r>
-              <a:rPr sz="1125" b="1">
-                <a:solidFill>
-                  <a:srgbClr val="102A43"/>
-                </a:solidFill>
-                <a:latin typeface="Aptos"/>
-                <a:ea typeface="Aptos"/>
-                <a:cs typeface="Aptos"/>
-              </a:rPr>
-              <a:t>PK Numero_Cliente</a:t>
-            </a:r>
-          </a:p>
-        </p:txBody>
-      </p:sp>
-      <p:sp>
-        <p:nvSpPr>
-          <p:cNvPr id="16" name="">
-            <a:extLst xmlns:a="http://schemas.openxmlformats.org/drawingml/2006/main">
-              <a:ext uri="{FF2B5EF4-FFF2-40B4-BE49-F238E27FC236}">
-                <a16:creationId xmlns:a16="http://schemas.microsoft.com/office/drawing/2014/main" id="{CFA883F4-7C77-486D-88BD-5215CCB322E3}"/>
-              </a:ext>
-            </a:extLst>
-          </p:cNvPr>
-          <p:cNvSpPr>
-            <a:spLocks xmlns:a="http://schemas.openxmlformats.org/drawingml/2006/main" noGrp="1"/>
-          </p:cNvSpPr>
-          <p:nvPr/>
-        </p:nvSpPr>
-        <p:spPr>
-          <a:xfrm xmlns:a="http://schemas.openxmlformats.org/drawingml/2006/main">
-            <a:off x="2428875" y="4762500"/>
-            <a:ext cx="2381250" cy="1000125"/>
-          </a:xfrm>
-          <a:prstGeom xmlns:a="http://schemas.openxmlformats.org/drawingml/2006/main" prst="roundRect">
-            <a:avLst>
-              <a:gd name="adj" fmla="val 7619"/>
-            </a:avLst>
-          </a:prstGeom>
-          <a:solidFill xmlns:a="http://schemas.openxmlformats.org/drawingml/2006/main">
-            <a:srgbClr val="FFFFFF"/>
-          </a:solidFill>
-          <a:ln xmlns:a="http://schemas.openxmlformats.org/drawingml/2006/main" w="9525">
-            <a:solidFill>
-              <a:srgbClr val="D8E0E6"/>
-            </a:solidFill>
-          </a:ln>
-        </p:spPr>
-      </p:sp>
-      <p:sp>
-        <p:nvSpPr>
-          <p:cNvPr id="17" name="">
-            <a:extLst xmlns:a="http://schemas.openxmlformats.org/drawingml/2006/main">
-              <a:ext uri="{FF2B5EF4-FFF2-40B4-BE49-F238E27FC236}">
-                <a16:creationId xmlns:a16="http://schemas.microsoft.com/office/drawing/2014/main" id="{965F8C35-4B9B-4FA5-AC2E-152576AEDC45}"/>
-              </a:ext>
-            </a:extLst>
-          </p:cNvPr>
-          <p:cNvSpPr>
-            <a:spLocks xmlns:a="http://schemas.openxmlformats.org/drawingml/2006/main" noGrp="1"/>
-          </p:cNvSpPr>
-          <p:nvPr/>
-        </p:nvSpPr>
-        <p:spPr>
-          <a:xfrm xmlns:a="http://schemas.openxmlformats.org/drawingml/2006/main">
-            <a:off x="2543175" y="4857750"/>
-            <a:ext cx="2152650" cy="809625"/>
-          </a:xfrm>
-          <a:prstGeom xmlns:a="http://schemas.openxmlformats.org/drawingml/2006/main" prst="rect">
-            <a:avLst/>
-          </a:prstGeom>
-          <a:noFill xmlns:a="http://schemas.openxmlformats.org/drawingml/2006/main"/>
-          <a:ln xmlns:a="http://schemas.openxmlformats.org/drawingml/2006/main" w="0">
-            <a:noFill/>
-          </a:ln>
-        </p:spPr>
-        <p:txBody>
-          <a:bodyPr xmlns:a="http://schemas.openxmlformats.org/drawingml/2006/main" anchor="ctr">
-            <a:normAutofit fontScale="100000"/>
-          </a:bodyPr>
-          <a:lstStyle xmlns:a="http://schemas.openxmlformats.org/drawingml/2006/main"/>
-          <a:p xmlns:a="http://schemas.openxmlformats.org/drawingml/2006/main">
-            <a:pPr algn="ctr">
-              <a:defRPr sz="1125" b="1">
-                <a:solidFill>
-                  <a:srgbClr val="102A43"/>
-                </a:solidFill>
-                <a:latin typeface="Aptos"/>
-                <a:ea typeface="Aptos"/>
-                <a:cs typeface="Aptos"/>
-              </a:defRPr>
-            </a:pPr>
-            <a:r>
-              <a:rPr sz="1125" b="1">
-                <a:solidFill>
-                  <a:srgbClr val="102A43"/>
-                </a:solidFill>
-                <a:latin typeface="Aptos"/>
-                <a:ea typeface="Aptos"/>
-                <a:cs typeface="Aptos"/>
-              </a:rPr>
-              <a:t>INDIVIDUAL</a:t>
-            </a:r>
-          </a:p>
-          <a:p xmlns:a="http://schemas.openxmlformats.org/drawingml/2006/main">
-            <a:pPr algn="ctr">
-              <a:defRPr sz="1125" b="1">
-                <a:solidFill>
-                  <a:srgbClr val="102A43"/>
-                </a:solidFill>
-                <a:latin typeface="Aptos"/>
-                <a:ea typeface="Aptos"/>
-                <a:cs typeface="Aptos"/>
-              </a:defRPr>
-            </a:pPr>
-            <a:r>
-              <a:rPr sz="1125" b="1">
-                <a:solidFill>
-                  <a:srgbClr val="102A43"/>
-                </a:solidFill>
-                <a:latin typeface="Aptos"/>
-                <a:ea typeface="Aptos"/>
-                <a:cs typeface="Aptos"/>
-              </a:rPr>
-              <a:t>PK/FK Numero_Cliente</a:t>
-            </a:r>
-          </a:p>
-        </p:txBody>
-      </p:sp>
-      <p:sp>
-        <p:nvSpPr>
-          <p:cNvPr id="18" name="">
-            <a:extLst xmlns:a="http://schemas.openxmlformats.org/drawingml/2006/main">
-              <a:ext uri="{FF2B5EF4-FFF2-40B4-BE49-F238E27FC236}">
-                <a16:creationId xmlns:a16="http://schemas.microsoft.com/office/drawing/2014/main" id="{0E21F916-A112-42AE-87C3-36A60C05FB12}"/>
-              </a:ext>
-            </a:extLst>
-          </p:cNvPr>
-          <p:cNvSpPr>
-            <a:spLocks xmlns:a="http://schemas.openxmlformats.org/drawingml/2006/main" noGrp="1"/>
-          </p:cNvSpPr>
-          <p:nvPr/>
-        </p:nvSpPr>
-        <p:spPr>
-          <a:xfrm xmlns:a="http://schemas.openxmlformats.org/drawingml/2006/main">
-            <a:off x="5810250" y="5572125"/>
-            <a:ext cx="2762250" cy="1000125"/>
-          </a:xfrm>
-          <a:prstGeom xmlns:a="http://schemas.openxmlformats.org/drawingml/2006/main" prst="roundRect">
-            <a:avLst>
-              <a:gd name="adj" fmla="val 7619"/>
-            </a:avLst>
-          </a:prstGeom>
-          <a:solidFill xmlns:a="http://schemas.openxmlformats.org/drawingml/2006/main">
-            <a:srgbClr val="FFFFFF"/>
-          </a:solidFill>
-          <a:ln xmlns:a="http://schemas.openxmlformats.org/drawingml/2006/main" w="9525">
-            <a:solidFill>
-              <a:srgbClr val="D8E0E6"/>
-            </a:solidFill>
-          </a:ln>
-        </p:spPr>
-      </p:sp>
-      <p:sp>
-        <p:nvSpPr>
-          <p:cNvPr id="19" name="">
-            <a:extLst xmlns:a="http://schemas.openxmlformats.org/drawingml/2006/main">
-              <a:ext uri="{FF2B5EF4-FFF2-40B4-BE49-F238E27FC236}">
-                <a16:creationId xmlns:a16="http://schemas.microsoft.com/office/drawing/2014/main" id="{BD5FB505-DF36-42BB-94E5-3AD22FBAF7E5}"/>
-              </a:ext>
-            </a:extLst>
-          </p:cNvPr>
-          <p:cNvSpPr>
-            <a:spLocks xmlns:a="http://schemas.openxmlformats.org/drawingml/2006/main" noGrp="1"/>
-          </p:cNvSpPr>
-          <p:nvPr/>
-        </p:nvSpPr>
-        <p:spPr>
-          <a:xfrm xmlns:a="http://schemas.openxmlformats.org/drawingml/2006/main">
-            <a:off x="5924550" y="5667375"/>
-            <a:ext cx="2533650" cy="809625"/>
-          </a:xfrm>
-          <a:prstGeom xmlns:a="http://schemas.openxmlformats.org/drawingml/2006/main" prst="rect">
-            <a:avLst/>
-          </a:prstGeom>
-          <a:noFill xmlns:a="http://schemas.openxmlformats.org/drawingml/2006/main"/>
-          <a:ln xmlns:a="http://schemas.openxmlformats.org/drawingml/2006/main" w="0">
-            <a:noFill/>
-          </a:ln>
-        </p:spPr>
-        <p:txBody>
-          <a:bodyPr xmlns:a="http://schemas.openxmlformats.org/drawingml/2006/main" anchor="ctr">
-            <a:normAutofit fontScale="100000"/>
-          </a:bodyPr>
-          <a:lstStyle xmlns:a="http://schemas.openxmlformats.org/drawingml/2006/main"/>
-          <a:p xmlns:a="http://schemas.openxmlformats.org/drawingml/2006/main">
-            <a:pPr algn="ctr">
-              <a:defRPr sz="1125" b="1">
-                <a:solidFill>
-                  <a:srgbClr val="102A43"/>
-                </a:solidFill>
-                <a:latin typeface="Aptos"/>
-                <a:ea typeface="Aptos"/>
-                <a:cs typeface="Aptos"/>
-              </a:defRPr>
-            </a:pPr>
-            <a:r>
-              <a:rPr sz="1125" b="1">
-                <a:solidFill>
-                  <a:srgbClr val="102A43"/>
-                </a:solidFill>
-                <a:latin typeface="Aptos"/>
-                <a:ea typeface="Aptos"/>
-                <a:cs typeface="Aptos"/>
-              </a:rPr>
-              <a:t>ORGANIZACAO</a:t>
-            </a:r>
-          </a:p>
-          <a:p xmlns:a="http://schemas.openxmlformats.org/drawingml/2006/main">
-            <a:pPr algn="ctr">
-              <a:defRPr sz="1125" b="1">
-                <a:solidFill>
-                  <a:srgbClr val="102A43"/>
-                </a:solidFill>
-                <a:latin typeface="Aptos"/>
-                <a:ea typeface="Aptos"/>
-                <a:cs typeface="Aptos"/>
-              </a:defRPr>
-            </a:pPr>
-            <a:r>
-              <a:rPr sz="1125" b="1">
-                <a:solidFill>
-                  <a:srgbClr val="102A43"/>
-                </a:solidFill>
-                <a:latin typeface="Aptos"/>
-                <a:ea typeface="Aptos"/>
-                <a:cs typeface="Aptos"/>
-              </a:rPr>
-              <a:t>PK/FK Numero_Cliente</a:t>
-            </a:r>
-          </a:p>
-        </p:txBody>
-      </p:sp>
-      <p:sp>
-        <p:nvSpPr>
-          <p:cNvPr id="20" name="">
-            <a:extLst xmlns:a="http://schemas.openxmlformats.org/drawingml/2006/main">
-              <a:ext uri="{FF2B5EF4-FFF2-40B4-BE49-F238E27FC236}">
-                <a16:creationId xmlns:a16="http://schemas.microsoft.com/office/drawing/2014/main" id="{DFB8093F-CFF9-4DC8-9DB7-B5BE29239CE2}"/>
-              </a:ext>
-            </a:extLst>
-          </p:cNvPr>
-          <p:cNvSpPr>
-            <a:spLocks xmlns:a="http://schemas.openxmlformats.org/drawingml/2006/main" noGrp="1"/>
-          </p:cNvSpPr>
-          <p:nvPr/>
-        </p:nvSpPr>
-        <p:spPr>
-          <a:xfrm xmlns:a="http://schemas.openxmlformats.org/drawingml/2006/main">
-            <a:off x="9096375" y="4333875"/>
-            <a:ext cx="2428875" cy="1000125"/>
-          </a:xfrm>
-          <a:prstGeom xmlns:a="http://schemas.openxmlformats.org/drawingml/2006/main" prst="roundRect">
-            <a:avLst>
-              <a:gd name="adj" fmla="val 7619"/>
-            </a:avLst>
-          </a:prstGeom>
-          <a:solidFill xmlns:a="http://schemas.openxmlformats.org/drawingml/2006/main">
-            <a:srgbClr val="FFFFFF"/>
-          </a:solidFill>
-          <a:ln xmlns:a="http://schemas.openxmlformats.org/drawingml/2006/main" w="9525">
-            <a:solidFill>
-              <a:srgbClr val="D8E0E6"/>
-            </a:solidFill>
-          </a:ln>
-        </p:spPr>
-      </p:sp>
-      <p:sp>
-        <p:nvSpPr>
-          <p:cNvPr id="21" name="">
-            <a:extLst xmlns:a="http://schemas.openxmlformats.org/drawingml/2006/main">
-              <a:ext uri="{FF2B5EF4-FFF2-40B4-BE49-F238E27FC236}">
-                <a16:creationId xmlns:a16="http://schemas.microsoft.com/office/drawing/2014/main" id="{234A26BC-8F92-4B6F-8679-46E9452572BA}"/>
-              </a:ext>
-            </a:extLst>
-          </p:cNvPr>
-          <p:cNvSpPr>
-            <a:spLocks xmlns:a="http://schemas.openxmlformats.org/drawingml/2006/main" noGrp="1"/>
-          </p:cNvSpPr>
-          <p:nvPr/>
-        </p:nvSpPr>
-        <p:spPr>
-          <a:xfrm xmlns:a="http://schemas.openxmlformats.org/drawingml/2006/main">
-            <a:off x="9210675" y="4429125"/>
-            <a:ext cx="2200275" cy="809625"/>
-          </a:xfrm>
-          <a:prstGeom xmlns:a="http://schemas.openxmlformats.org/drawingml/2006/main" prst="rect">
-            <a:avLst/>
-          </a:prstGeom>
-          <a:noFill xmlns:a="http://schemas.openxmlformats.org/drawingml/2006/main"/>
-          <a:ln xmlns:a="http://schemas.openxmlformats.org/drawingml/2006/main" w="0">
-            <a:noFill/>
-          </a:ln>
-        </p:spPr>
-        <p:txBody>
-          <a:bodyPr xmlns:a="http://schemas.openxmlformats.org/drawingml/2006/main" anchor="ctr">
-            <a:normAutofit fontScale="100000"/>
-          </a:bodyPr>
-          <a:lstStyle xmlns:a="http://schemas.openxmlformats.org/drawingml/2006/main"/>
-          <a:p xmlns:a="http://schemas.openxmlformats.org/drawingml/2006/main">
-            <a:pPr algn="ctr">
-              <a:defRPr sz="1125" b="1">
-                <a:solidFill>
-                  <a:srgbClr val="102A43"/>
-                </a:solidFill>
-                <a:latin typeface="Aptos"/>
-                <a:ea typeface="Aptos"/>
-                <a:cs typeface="Aptos"/>
-              </a:defRPr>
-            </a:pPr>
-            <a:r>
-              <a:rPr sz="1125" b="1">
-                <a:solidFill>
-                  <a:srgbClr val="102A43"/>
-                </a:solidFill>
-                <a:latin typeface="Aptos"/>
-                <a:ea typeface="Aptos"/>
-                <a:cs typeface="Aptos"/>
-              </a:rPr>
-              <a:t>FACTURA</a:t>
-            </a:r>
-          </a:p>
-          <a:p xmlns:a="http://schemas.openxmlformats.org/drawingml/2006/main">
-            <a:pPr algn="ctr">
-              <a:defRPr sz="1125" b="1">
-                <a:solidFill>
-                  <a:srgbClr val="102A43"/>
-                </a:solidFill>
-                <a:latin typeface="Aptos"/>
-                <a:ea typeface="Aptos"/>
-                <a:cs typeface="Aptos"/>
-              </a:defRPr>
-            </a:pPr>
-            <a:r>
-              <a:rPr sz="1125" b="1">
-                <a:solidFill>
-                  <a:srgbClr val="102A43"/>
-                </a:solidFill>
-                <a:latin typeface="Aptos"/>
-                <a:ea typeface="Aptos"/>
-                <a:cs typeface="Aptos"/>
-              </a:rPr>
-              <a:t>PK Numero_Factura</a:t>
-            </a:r>
-          </a:p>
-          <a:p xmlns:a="http://schemas.openxmlformats.org/drawingml/2006/main">
-            <a:pPr algn="ctr">
-              <a:defRPr sz="1125" b="1">
-                <a:solidFill>
-                  <a:srgbClr val="102A43"/>
-                </a:solidFill>
-                <a:latin typeface="Aptos"/>
-                <a:ea typeface="Aptos"/>
-                <a:cs typeface="Aptos"/>
-              </a:defRPr>
-            </a:pPr>
-            <a:r>
-              <a:rPr sz="1125" b="1">
-                <a:solidFill>
-                  <a:srgbClr val="102A43"/>
-                </a:solidFill>
-                <a:latin typeface="Aptos"/>
-                <a:ea typeface="Aptos"/>
-                <a:cs typeface="Aptos"/>
-              </a:rPr>
-              <a:t>FK Numero_Reserva</a:t>
-            </a:r>
-          </a:p>
-        </p:txBody>
-      </p:sp>
-      <p:sp>
-        <p:nvSpPr>
-          <p:cNvPr id="22" name="">
-            <a:extLst xmlns:a="http://schemas.openxmlformats.org/drawingml/2006/main">
-              <a:ext uri="{FF2B5EF4-FFF2-40B4-BE49-F238E27FC236}">
-                <a16:creationId xmlns:a16="http://schemas.microsoft.com/office/drawing/2014/main" id="{7A0F6DA1-AA90-4071-81DA-56B7ACED5786}"/>
-              </a:ext>
-            </a:extLst>
-          </p:cNvPr>
-          <p:cNvSpPr>
-            <a:spLocks xmlns:a="http://schemas.openxmlformats.org/drawingml/2006/main" noGrp="1"/>
-          </p:cNvSpPr>
-          <p:nvPr/>
-        </p:nvSpPr>
-        <p:spPr>
-          <a:xfrm xmlns:a="http://schemas.openxmlformats.org/drawingml/2006/main">
-            <a:off x="2476500" y="1352550"/>
-            <a:ext cx="381000" cy="285750"/>
-          </a:xfrm>
-          <a:prstGeom xmlns:a="http://schemas.openxmlformats.org/drawingml/2006/main" prst="rect">
-            <a:avLst/>
-          </a:prstGeom>
-          <a:noFill xmlns:a="http://schemas.openxmlformats.org/drawingml/2006/main"/>
-          <a:ln xmlns:a="http://schemas.openxmlformats.org/drawingml/2006/main" w="0">
-            <a:noFill/>
-          </a:ln>
-        </p:spPr>
-        <p:txBody>
-          <a:bodyPr xmlns:a="http://schemas.openxmlformats.org/drawingml/2006/main" anchor="ctr">
-            <a:normAutofit fontScale="100000"/>
-          </a:bodyPr>
-          <a:lstStyle xmlns:a="http://schemas.openxmlformats.org/drawingml/2006/main"/>
-          <a:p xmlns:a="http://schemas.openxmlformats.org/drawingml/2006/main">
-            <a:pPr algn="ctr">
-              <a:defRPr sz="1050" b="1">
-                <a:solidFill>
-                  <a:srgbClr val="087F8C"/>
-                </a:solidFill>
-                <a:latin typeface="Aptos"/>
-                <a:ea typeface="Aptos"/>
-                <a:cs typeface="Aptos"/>
-              </a:defRPr>
-            </a:pPr>
-            <a:r>
-              <a:rPr sz="1050" b="1">
-                <a:solidFill>
-                  <a:srgbClr val="087F8C"/>
-                </a:solidFill>
-                <a:latin typeface="Aptos"/>
-                <a:ea typeface="Aptos"/>
-                <a:cs typeface="Aptos"/>
-              </a:rPr>
-              <a:t>FK</a:t>
-            </a:r>
-          </a:p>
-        </p:txBody>
-      </p:sp>
-      <p:sp>
-        <p:nvSpPr>
-          <p:cNvPr id="23" name="">
-            <a:extLst xmlns:a="http://schemas.openxmlformats.org/drawingml/2006/main">
-              <a:ext uri="{FF2B5EF4-FFF2-40B4-BE49-F238E27FC236}">
-                <a16:creationId xmlns:a16="http://schemas.microsoft.com/office/drawing/2014/main" id="{E0B3297E-D11A-4129-A654-B52D69DCF509}"/>
-              </a:ext>
-            </a:extLst>
-          </p:cNvPr>
-          <p:cNvSpPr>
-            <a:spLocks xmlns:a="http://schemas.openxmlformats.org/drawingml/2006/main" noGrp="1"/>
-          </p:cNvSpPr>
-          <p:nvPr/>
-        </p:nvSpPr>
-        <p:spPr>
-          <a:xfrm xmlns:a="http://schemas.openxmlformats.org/drawingml/2006/main">
-            <a:off x="2600325" y="1638300"/>
-            <a:ext cx="333375" cy="333375"/>
-          </a:xfrm>
-          <a:prstGeom xmlns:a="http://schemas.openxmlformats.org/drawingml/2006/main" prst="rect">
-            <a:avLst/>
-          </a:prstGeom>
-          <a:noFill xmlns:a="http://schemas.openxmlformats.org/drawingml/2006/main"/>
-          <a:ln xmlns:a="http://schemas.openxmlformats.org/drawingml/2006/main" w="0">
-            <a:noFill/>
-          </a:ln>
-        </p:spPr>
-        <p:txBody>
-          <a:bodyPr xmlns:a="http://schemas.openxmlformats.org/drawingml/2006/main" anchor="ctr">
-            <a:normAutofit fontScale="58313"/>
-          </a:bodyPr>
-          <a:lstStyle xmlns:a="http://schemas.openxmlformats.org/drawingml/2006/main"/>
-          <a:p xmlns:a="http://schemas.openxmlformats.org/drawingml/2006/main">
-            <a:pPr algn="ctr">
-              <a:defRPr sz="2025" b="1">
-                <a:solidFill>
-                  <a:srgbClr val="087F8C"/>
-                </a:solidFill>
-                <a:latin typeface="Aptos"/>
-                <a:ea typeface="Aptos"/>
-                <a:cs typeface="Aptos"/>
-              </a:defRPr>
-            </a:pPr>
-            <a:r>
-              <a:rPr sz="2025" b="1">
-                <a:solidFill>
-                  <a:srgbClr val="087F8C"/>
-                </a:solidFill>
-                <a:latin typeface="Aptos"/>
-                <a:ea typeface="Aptos"/>
-                <a:cs typeface="Aptos"/>
-              </a:rPr>
-              <a:t>←</a:t>
-            </a:r>
-          </a:p>
-        </p:txBody>
-      </p:sp>
-      <p:sp>
-        <p:nvSpPr>
-          <p:cNvPr id="24" name="">
-            <a:extLst xmlns:a="http://schemas.openxmlformats.org/drawingml/2006/main">
-              <a:ext uri="{FF2B5EF4-FFF2-40B4-BE49-F238E27FC236}">
-                <a16:creationId xmlns:a16="http://schemas.microsoft.com/office/drawing/2014/main" id="{CF208364-91D5-47C3-9052-AD3A6289B8E4}"/>
-              </a:ext>
-            </a:extLst>
-          </p:cNvPr>
-          <p:cNvSpPr>
-            <a:spLocks xmlns:a="http://schemas.openxmlformats.org/drawingml/2006/main" noGrp="1"/>
-          </p:cNvSpPr>
-          <p:nvPr/>
-        </p:nvSpPr>
-        <p:spPr>
-          <a:xfrm xmlns:a="http://schemas.openxmlformats.org/drawingml/2006/main">
-            <a:off x="4953000" y="1381125"/>
-            <a:ext cx="857250" cy="285750"/>
-          </a:xfrm>
-          <a:prstGeom xmlns:a="http://schemas.openxmlformats.org/drawingml/2006/main" prst="rect">
-            <a:avLst/>
-          </a:prstGeom>
-          <a:noFill xmlns:a="http://schemas.openxmlformats.org/drawingml/2006/main"/>
-          <a:ln xmlns:a="http://schemas.openxmlformats.org/drawingml/2006/main" w="0">
-            <a:noFill/>
-          </a:ln>
-        </p:spPr>
-        <p:txBody>
-          <a:bodyPr xmlns:a="http://schemas.openxmlformats.org/drawingml/2006/main" anchor="ctr">
-            <a:normAutofit fontScale="85435"/>
-          </a:bodyPr>
-          <a:lstStyle xmlns:a="http://schemas.openxmlformats.org/drawingml/2006/main"/>
-          <a:p xmlns:a="http://schemas.openxmlformats.org/drawingml/2006/main">
-            <a:pPr algn="ctr">
-              <a:defRPr sz="975" b="1">
-                <a:solidFill>
-                  <a:srgbClr val="087F8C"/>
-                </a:solidFill>
-                <a:latin typeface="Aptos"/>
-                <a:ea typeface="Aptos"/>
-                <a:cs typeface="Aptos"/>
-              </a:defRPr>
-            </a:pPr>
-            <a:r>
-              <a:rPr sz="975" b="1">
-                <a:solidFill>
-                  <a:srgbClr val="087F8C"/>
-                </a:solidFill>
-                <a:latin typeface="Aptos"/>
-                <a:ea typeface="Aptos"/>
-                <a:cs typeface="Aptos"/>
-              </a:rPr>
-              <a:t>FK composta</a:t>
-            </a:r>
-          </a:p>
-        </p:txBody>
-      </p:sp>
-      <p:sp>
-        <p:nvSpPr>
-          <p:cNvPr id="25" name="">
-            <a:extLst xmlns:a="http://schemas.openxmlformats.org/drawingml/2006/main">
-              <a:ext uri="{FF2B5EF4-FFF2-40B4-BE49-F238E27FC236}">
-                <a16:creationId xmlns:a16="http://schemas.microsoft.com/office/drawing/2014/main" id="{968A771D-E2F4-4F9D-9410-E7B50C8FADA3}"/>
-              </a:ext>
-            </a:extLst>
-          </p:cNvPr>
-          <p:cNvSpPr>
-            <a:spLocks xmlns:a="http://schemas.openxmlformats.org/drawingml/2006/main" noGrp="1"/>
-          </p:cNvSpPr>
-          <p:nvPr/>
-        </p:nvSpPr>
-        <p:spPr>
-          <a:xfrm xmlns:a="http://schemas.openxmlformats.org/drawingml/2006/main">
-            <a:off x="5381625" y="1695450"/>
-            <a:ext cx="333375" cy="333375"/>
-          </a:xfrm>
-          <a:prstGeom xmlns:a="http://schemas.openxmlformats.org/drawingml/2006/main" prst="rect">
-            <a:avLst/>
-          </a:prstGeom>
-          <a:noFill xmlns:a="http://schemas.openxmlformats.org/drawingml/2006/main"/>
-          <a:ln xmlns:a="http://schemas.openxmlformats.org/drawingml/2006/main" w="0">
-            <a:noFill/>
-          </a:ln>
-        </p:spPr>
-        <p:txBody>
-          <a:bodyPr xmlns:a="http://schemas.openxmlformats.org/drawingml/2006/main" anchor="ctr">
-            <a:normAutofit fontScale="58313"/>
-          </a:bodyPr>
-          <a:lstStyle xmlns:a="http://schemas.openxmlformats.org/drawingml/2006/main"/>
-          <a:p xmlns:a="http://schemas.openxmlformats.org/drawingml/2006/main">
-            <a:pPr algn="ctr">
-              <a:defRPr sz="2025" b="1">
-                <a:solidFill>
-                  <a:srgbClr val="087F8C"/>
-                </a:solidFill>
-                <a:latin typeface="Aptos"/>
-                <a:ea typeface="Aptos"/>
-                <a:cs typeface="Aptos"/>
-              </a:defRPr>
-            </a:pPr>
-            <a:r>
-              <a:rPr sz="2025" b="1">
-                <a:solidFill>
-                  <a:srgbClr val="087F8C"/>
-                </a:solidFill>
-                <a:latin typeface="Aptos"/>
-                <a:ea typeface="Aptos"/>
-                <a:cs typeface="Aptos"/>
-              </a:rPr>
-              <a:t>←</a:t>
-            </a:r>
-          </a:p>
-        </p:txBody>
-      </p:sp>
-      <p:sp>
-        <p:nvSpPr>
-          <p:cNvPr id="26" name="">
-            <a:extLst xmlns:a="http://schemas.openxmlformats.org/drawingml/2006/main">
-              <a:ext uri="{FF2B5EF4-FFF2-40B4-BE49-F238E27FC236}">
-                <a16:creationId xmlns:a16="http://schemas.microsoft.com/office/drawing/2014/main" id="{11D2EB42-D077-4820-B9DE-BDD478033541}"/>
-              </a:ext>
-            </a:extLst>
-          </p:cNvPr>
-          <p:cNvSpPr>
-            <a:spLocks xmlns:a="http://schemas.openxmlformats.org/drawingml/2006/main" noGrp="1"/>
-          </p:cNvSpPr>
-          <p:nvPr/>
-        </p:nvSpPr>
-        <p:spPr>
-          <a:xfrm xmlns:a="http://schemas.openxmlformats.org/drawingml/2006/main">
-            <a:off x="8620125" y="1476375"/>
-            <a:ext cx="428625" cy="285750"/>
-          </a:xfrm>
-          <a:prstGeom xmlns:a="http://schemas.openxmlformats.org/drawingml/2006/main" prst="rect">
-            <a:avLst/>
-          </a:prstGeom>
-          <a:noFill xmlns:a="http://schemas.openxmlformats.org/drawingml/2006/main"/>
-          <a:ln xmlns:a="http://schemas.openxmlformats.org/drawingml/2006/main" w="0">
-            <a:noFill/>
-          </a:ln>
-        </p:spPr>
-        <p:txBody>
-          <a:bodyPr xmlns:a="http://schemas.openxmlformats.org/drawingml/2006/main" anchor="ctr">
-            <a:normAutofit fontScale="100000"/>
-          </a:bodyPr>
-          <a:lstStyle xmlns:a="http://schemas.openxmlformats.org/drawingml/2006/main"/>
-          <a:p xmlns:a="http://schemas.openxmlformats.org/drawingml/2006/main">
-            <a:pPr algn="ctr">
-              <a:defRPr sz="1050" b="1">
-                <a:solidFill>
-                  <a:srgbClr val="087F8C"/>
-                </a:solidFill>
-                <a:latin typeface="Aptos"/>
-                <a:ea typeface="Aptos"/>
-                <a:cs typeface="Aptos"/>
-              </a:defRPr>
-            </a:pPr>
-            <a:r>
-              <a:rPr sz="1050" b="1">
-                <a:solidFill>
-                  <a:srgbClr val="087F8C"/>
-                </a:solidFill>
-                <a:latin typeface="Aptos"/>
-                <a:ea typeface="Aptos"/>
-                <a:cs typeface="Aptos"/>
-              </a:rPr>
-              <a:t>FK</a:t>
-            </a:r>
-          </a:p>
-        </p:txBody>
-      </p:sp>
-      <p:sp>
-        <p:nvSpPr>
-          <p:cNvPr id="27" name="">
-            <a:extLst xmlns:a="http://schemas.openxmlformats.org/drawingml/2006/main">
-              <a:ext uri="{FF2B5EF4-FFF2-40B4-BE49-F238E27FC236}">
-                <a16:creationId xmlns:a16="http://schemas.microsoft.com/office/drawing/2014/main" id="{00EB4F69-BDF4-495A-AAA1-FA10123E2847}"/>
-              </a:ext>
-            </a:extLst>
-          </p:cNvPr>
-          <p:cNvSpPr>
-            <a:spLocks xmlns:a="http://schemas.openxmlformats.org/drawingml/2006/main" noGrp="1"/>
-          </p:cNvSpPr>
-          <p:nvPr/>
-        </p:nvSpPr>
-        <p:spPr>
-          <a:xfrm xmlns:a="http://schemas.openxmlformats.org/drawingml/2006/main">
-            <a:off x="8715375" y="1762125"/>
-            <a:ext cx="333375" cy="333375"/>
-          </a:xfrm>
-          <a:prstGeom xmlns:a="http://schemas.openxmlformats.org/drawingml/2006/main" prst="rect">
-            <a:avLst/>
-          </a:prstGeom>
-          <a:noFill xmlns:a="http://schemas.openxmlformats.org/drawingml/2006/main"/>
-          <a:ln xmlns:a="http://schemas.openxmlformats.org/drawingml/2006/main" w="0">
-            <a:noFill/>
-          </a:ln>
-        </p:spPr>
-        <p:txBody>
-          <a:bodyPr xmlns:a="http://schemas.openxmlformats.org/drawingml/2006/main" anchor="ctr">
-            <a:normAutofit fontScale="58313"/>
-          </a:bodyPr>
-          <a:lstStyle xmlns:a="http://schemas.openxmlformats.org/drawingml/2006/main"/>
-          <a:p xmlns:a="http://schemas.openxmlformats.org/drawingml/2006/main">
-            <a:pPr algn="ctr">
-              <a:defRPr sz="2025" b="1">
-                <a:solidFill>
-                  <a:srgbClr val="087F8C"/>
-                </a:solidFill>
-                <a:latin typeface="Aptos"/>
-                <a:ea typeface="Aptos"/>
-                <a:cs typeface="Aptos"/>
-              </a:defRPr>
-            </a:pPr>
-            <a:r>
-              <a:rPr sz="2025" b="1">
-                <a:solidFill>
-                  <a:srgbClr val="087F8C"/>
-                </a:solidFill>
-                <a:latin typeface="Aptos"/>
-                <a:ea typeface="Aptos"/>
-                <a:cs typeface="Aptos"/>
-              </a:rPr>
-              <a:t>←</a:t>
-            </a:r>
-          </a:p>
-        </p:txBody>
-      </p:sp>
-      <p:sp>
-        <p:nvSpPr>
-          <p:cNvPr id="28" name="">
-            <a:extLst xmlns:a="http://schemas.openxmlformats.org/drawingml/2006/main">
-              <a:ext uri="{FF2B5EF4-FFF2-40B4-BE49-F238E27FC236}">
-                <a16:creationId xmlns:a16="http://schemas.microsoft.com/office/drawing/2014/main" id="{16BDE623-1294-4FA1-9B0D-D6596767B13A}"/>
-              </a:ext>
-            </a:extLst>
-          </p:cNvPr>
-          <p:cNvSpPr>
-            <a:spLocks xmlns:a="http://schemas.openxmlformats.org/drawingml/2006/main" noGrp="1"/>
-          </p:cNvSpPr>
-          <p:nvPr/>
-        </p:nvSpPr>
-        <p:spPr>
-          <a:xfrm xmlns:a="http://schemas.openxmlformats.org/drawingml/2006/main">
-            <a:off x="7239000" y="3476625"/>
-            <a:ext cx="428625" cy="285750"/>
-          </a:xfrm>
-          <a:prstGeom xmlns:a="http://schemas.openxmlformats.org/drawingml/2006/main" prst="rect">
-            <a:avLst/>
-          </a:prstGeom>
-          <a:noFill xmlns:a="http://schemas.openxmlformats.org/drawingml/2006/main"/>
-          <a:ln xmlns:a="http://schemas.openxmlformats.org/drawingml/2006/main" w="0">
-            <a:noFill/>
-          </a:ln>
-        </p:spPr>
-        <p:txBody>
-          <a:bodyPr xmlns:a="http://schemas.openxmlformats.org/drawingml/2006/main" anchor="ctr">
-            <a:normAutofit fontScale="100000"/>
-          </a:bodyPr>
-          <a:lstStyle xmlns:a="http://schemas.openxmlformats.org/drawingml/2006/main"/>
-          <a:p xmlns:a="http://schemas.openxmlformats.org/drawingml/2006/main">
-            <a:pPr algn="ctr">
-              <a:defRPr sz="1050" b="1">
-                <a:solidFill>
-                  <a:srgbClr val="087F8C"/>
-                </a:solidFill>
-                <a:latin typeface="Aptos"/>
-                <a:ea typeface="Aptos"/>
-                <a:cs typeface="Aptos"/>
-              </a:defRPr>
-            </a:pPr>
-            <a:r>
-              <a:rPr sz="1050" b="1">
-                <a:solidFill>
-                  <a:srgbClr val="087F8C"/>
-                </a:solidFill>
-                <a:latin typeface="Aptos"/>
-                <a:ea typeface="Aptos"/>
-                <a:cs typeface="Aptos"/>
-              </a:rPr>
-              <a:t>FK</a:t>
-            </a:r>
-          </a:p>
-        </p:txBody>
-      </p:sp>
-      <p:sp>
-        <p:nvSpPr>
-          <p:cNvPr id="29" name="">
-            <a:extLst xmlns:a="http://schemas.openxmlformats.org/drawingml/2006/main">
-              <a:ext uri="{FF2B5EF4-FFF2-40B4-BE49-F238E27FC236}">
-                <a16:creationId xmlns:a16="http://schemas.microsoft.com/office/drawing/2014/main" id="{A1BDF700-D0BE-4329-999C-D9E205691B2D}"/>
-              </a:ext>
-            </a:extLst>
-          </p:cNvPr>
-          <p:cNvSpPr>
-            <a:spLocks xmlns:a="http://schemas.openxmlformats.org/drawingml/2006/main" noGrp="1"/>
-          </p:cNvSpPr>
-          <p:nvPr/>
-        </p:nvSpPr>
-        <p:spPr>
-          <a:xfrm xmlns:a="http://schemas.openxmlformats.org/drawingml/2006/main">
-            <a:off x="7286625" y="3762375"/>
-            <a:ext cx="333375" cy="333375"/>
-          </a:xfrm>
-          <a:prstGeom xmlns:a="http://schemas.openxmlformats.org/drawingml/2006/main" prst="rect">
-            <a:avLst/>
-          </a:prstGeom>
-          <a:noFill xmlns:a="http://schemas.openxmlformats.org/drawingml/2006/main"/>
-          <a:ln xmlns:a="http://schemas.openxmlformats.org/drawingml/2006/main" w="0">
-            <a:noFill/>
-          </a:ln>
-        </p:spPr>
-        <p:txBody>
-          <a:bodyPr xmlns:a="http://schemas.openxmlformats.org/drawingml/2006/main" anchor="ctr">
-            <a:normAutofit fontScale="78395"/>
-          </a:bodyPr>
-          <a:lstStyle xmlns:a="http://schemas.openxmlformats.org/drawingml/2006/main"/>
-          <a:p xmlns:a="http://schemas.openxmlformats.org/drawingml/2006/main">
-            <a:pPr algn="ctr">
-              <a:defRPr sz="2025" b="1">
-                <a:solidFill>
-                  <a:srgbClr val="087F8C"/>
-                </a:solidFill>
-                <a:latin typeface="Aptos"/>
-                <a:ea typeface="Aptos"/>
-                <a:cs typeface="Aptos"/>
-              </a:defRPr>
-            </a:pPr>
-            <a:r>
-              <a:rPr sz="2025" b="1">
-                <a:solidFill>
-                  <a:srgbClr val="087F8C"/>
-                </a:solidFill>
-                <a:latin typeface="Aptos"/>
-                <a:ea typeface="Aptos"/>
-                <a:cs typeface="Aptos"/>
-              </a:rPr>
-              <a:t>↓</a:t>
-            </a:r>
-          </a:p>
-        </p:txBody>
-      </p:sp>
-      <p:sp>
-        <p:nvSpPr>
-          <p:cNvPr id="30" name="">
-            <a:extLst xmlns:a="http://schemas.openxmlformats.org/drawingml/2006/main">
-              <a:ext uri="{FF2B5EF4-FFF2-40B4-BE49-F238E27FC236}">
-                <a16:creationId xmlns:a16="http://schemas.microsoft.com/office/drawing/2014/main" id="{3662F918-1870-4D0B-AEAD-DAFAF476C914}"/>
-              </a:ext>
-            </a:extLst>
-          </p:cNvPr>
-          <p:cNvSpPr>
-            <a:spLocks xmlns:a="http://schemas.openxmlformats.org/drawingml/2006/main" noGrp="1"/>
-          </p:cNvSpPr>
-          <p:nvPr/>
-        </p:nvSpPr>
-        <p:spPr>
-          <a:xfrm xmlns:a="http://schemas.openxmlformats.org/drawingml/2006/main">
-            <a:off x="4905375" y="4762500"/>
-            <a:ext cx="428625" cy="285750"/>
-          </a:xfrm>
-          <a:prstGeom xmlns:a="http://schemas.openxmlformats.org/drawingml/2006/main" prst="rect">
-            <a:avLst/>
-          </a:prstGeom>
-          <a:noFill xmlns:a="http://schemas.openxmlformats.org/drawingml/2006/main"/>
-          <a:ln xmlns:a="http://schemas.openxmlformats.org/drawingml/2006/main" w="0">
-            <a:noFill/>
-          </a:ln>
-        </p:spPr>
-        <p:txBody>
-          <a:bodyPr xmlns:a="http://schemas.openxmlformats.org/drawingml/2006/main" anchor="ctr">
-            <a:normAutofit fontScale="100000"/>
-          </a:bodyPr>
-          <a:lstStyle xmlns:a="http://schemas.openxmlformats.org/drawingml/2006/main"/>
-          <a:p xmlns:a="http://schemas.openxmlformats.org/drawingml/2006/main">
-            <a:pPr algn="ctr">
-              <a:defRPr sz="1050" b="1">
-                <a:solidFill>
-                  <a:srgbClr val="087F8C"/>
-                </a:solidFill>
-                <a:latin typeface="Aptos"/>
-                <a:ea typeface="Aptos"/>
-                <a:cs typeface="Aptos"/>
-              </a:defRPr>
-            </a:pPr>
-            <a:r>
-              <a:rPr sz="1050" b="1">
-                <a:solidFill>
-                  <a:srgbClr val="087F8C"/>
-                </a:solidFill>
-                <a:latin typeface="Aptos"/>
-                <a:ea typeface="Aptos"/>
-                <a:cs typeface="Aptos"/>
-              </a:rPr>
-              <a:t>FK</a:t>
-            </a:r>
-          </a:p>
-        </p:txBody>
-      </p:sp>
-      <p:sp>
-        <p:nvSpPr>
-          <p:cNvPr id="31" name="">
-            <a:extLst xmlns:a="http://schemas.openxmlformats.org/drawingml/2006/main">
-              <a:ext uri="{FF2B5EF4-FFF2-40B4-BE49-F238E27FC236}">
-                <a16:creationId xmlns:a16="http://schemas.microsoft.com/office/drawing/2014/main" id="{CD200982-778F-4F9C-9B1A-EB12E68454FC}"/>
-              </a:ext>
-            </a:extLst>
-          </p:cNvPr>
-          <p:cNvSpPr>
-            <a:spLocks xmlns:a="http://schemas.openxmlformats.org/drawingml/2006/main" noGrp="1"/>
-          </p:cNvSpPr>
-          <p:nvPr/>
-        </p:nvSpPr>
-        <p:spPr>
-          <a:xfrm xmlns:a="http://schemas.openxmlformats.org/drawingml/2006/main">
-            <a:off x="5095875" y="5000625"/>
-            <a:ext cx="523875" cy="333375"/>
-          </a:xfrm>
-          <a:prstGeom xmlns:a="http://schemas.openxmlformats.org/drawingml/2006/main" prst="rect">
-            <a:avLst/>
-          </a:prstGeom>
-          <a:noFill xmlns:a="http://schemas.openxmlformats.org/drawingml/2006/main"/>
-          <a:ln xmlns:a="http://schemas.openxmlformats.org/drawingml/2006/main" w="0">
-            <a:noFill/>
-          </a:ln>
-        </p:spPr>
-        <p:txBody>
-          <a:bodyPr xmlns:a="http://schemas.openxmlformats.org/drawingml/2006/main" anchor="ctr">
-            <a:normAutofit fontScale="78395"/>
-          </a:bodyPr>
-          <a:lstStyle xmlns:a="http://schemas.openxmlformats.org/drawingml/2006/main"/>
-          <a:p xmlns:a="http://schemas.openxmlformats.org/drawingml/2006/main">
-            <a:pPr algn="ctr">
-              <a:defRPr sz="2025" b="1">
-                <a:solidFill>
-                  <a:srgbClr val="087F8C"/>
-                </a:solidFill>
-                <a:latin typeface="Aptos"/>
-                <a:ea typeface="Aptos"/>
-                <a:cs typeface="Aptos"/>
-              </a:defRPr>
-            </a:pPr>
-            <a:r>
-              <a:rPr sz="2025" b="1">
-                <a:solidFill>
-                  <a:srgbClr val="087F8C"/>
-                </a:solidFill>
-                <a:latin typeface="Aptos"/>
-                <a:ea typeface="Aptos"/>
-                <a:cs typeface="Aptos"/>
-              </a:rPr>
-              <a:t>→</a:t>
-            </a:r>
-          </a:p>
-        </p:txBody>
-      </p:sp>
-      <p:sp>
-        <p:nvSpPr>
-          <p:cNvPr id="32" name="">
-            <a:extLst xmlns:a="http://schemas.openxmlformats.org/drawingml/2006/main">
-              <a:ext uri="{FF2B5EF4-FFF2-40B4-BE49-F238E27FC236}">
-                <a16:creationId xmlns:a16="http://schemas.microsoft.com/office/drawing/2014/main" id="{DBFB1657-5503-46BF-9226-123008F05AFE}"/>
-              </a:ext>
-            </a:extLst>
-          </p:cNvPr>
-          <p:cNvSpPr>
-            <a:spLocks xmlns:a="http://schemas.openxmlformats.org/drawingml/2006/main" noGrp="1"/>
-          </p:cNvSpPr>
-          <p:nvPr/>
-        </p:nvSpPr>
-        <p:spPr>
-          <a:xfrm xmlns:a="http://schemas.openxmlformats.org/drawingml/2006/main">
-            <a:off x="7191375" y="5143500"/>
-            <a:ext cx="428625" cy="285750"/>
-          </a:xfrm>
-          <a:prstGeom xmlns:a="http://schemas.openxmlformats.org/drawingml/2006/main" prst="rect">
-            <a:avLst/>
-          </a:prstGeom>
-          <a:noFill xmlns:a="http://schemas.openxmlformats.org/drawingml/2006/main"/>
-          <a:ln xmlns:a="http://schemas.openxmlformats.org/drawingml/2006/main" w="0">
-            <a:noFill/>
-          </a:ln>
-        </p:spPr>
-        <p:txBody>
-          <a:bodyPr xmlns:a="http://schemas.openxmlformats.org/drawingml/2006/main" anchor="ctr">
-            <a:normAutofit fontScale="100000"/>
-          </a:bodyPr>
-          <a:lstStyle xmlns:a="http://schemas.openxmlformats.org/drawingml/2006/main"/>
-          <a:p xmlns:a="http://schemas.openxmlformats.org/drawingml/2006/main">
-            <a:pPr algn="ctr">
-              <a:defRPr sz="1050" b="1">
-                <a:solidFill>
-                  <a:srgbClr val="087F8C"/>
-                </a:solidFill>
-                <a:latin typeface="Aptos"/>
-                <a:ea typeface="Aptos"/>
-                <a:cs typeface="Aptos"/>
-              </a:defRPr>
-            </a:pPr>
-            <a:r>
-              <a:rPr sz="1050" b="1">
-                <a:solidFill>
-                  <a:srgbClr val="087F8C"/>
-                </a:solidFill>
-                <a:latin typeface="Aptos"/>
-                <a:ea typeface="Aptos"/>
-                <a:cs typeface="Aptos"/>
-              </a:rPr>
-              <a:t>FK</a:t>
-            </a:r>
-          </a:p>
-        </p:txBody>
-      </p:sp>
-      <p:sp>
-        <p:nvSpPr>
-          <p:cNvPr id="33" name="">
-            <a:extLst xmlns:a="http://schemas.openxmlformats.org/drawingml/2006/main">
-              <a:ext uri="{FF2B5EF4-FFF2-40B4-BE49-F238E27FC236}">
-                <a16:creationId xmlns:a16="http://schemas.microsoft.com/office/drawing/2014/main" id="{CBB516D1-5801-45BC-A577-C22DBF28BBA0}"/>
-              </a:ext>
-            </a:extLst>
-          </p:cNvPr>
-          <p:cNvSpPr>
-            <a:spLocks xmlns:a="http://schemas.openxmlformats.org/drawingml/2006/main" noGrp="1"/>
-          </p:cNvSpPr>
-          <p:nvPr/>
-        </p:nvSpPr>
-        <p:spPr>
-          <a:xfrm xmlns:a="http://schemas.openxmlformats.org/drawingml/2006/main">
-            <a:off x="7286625" y="5381625"/>
-            <a:ext cx="333375" cy="333375"/>
-          </a:xfrm>
-          <a:prstGeom xmlns:a="http://schemas.openxmlformats.org/drawingml/2006/main" prst="rect">
-            <a:avLst/>
-          </a:prstGeom>
-          <a:noFill xmlns:a="http://schemas.openxmlformats.org/drawingml/2006/main"/>
-          <a:ln xmlns:a="http://schemas.openxmlformats.org/drawingml/2006/main" w="0">
-            <a:noFill/>
-          </a:ln>
-        </p:spPr>
-        <p:txBody>
-          <a:bodyPr xmlns:a="http://schemas.openxmlformats.org/drawingml/2006/main" anchor="ctr">
-            <a:normAutofit fontScale="78395"/>
-          </a:bodyPr>
-          <a:lstStyle xmlns:a="http://schemas.openxmlformats.org/drawingml/2006/main"/>
-          <a:p xmlns:a="http://schemas.openxmlformats.org/drawingml/2006/main">
-            <a:pPr algn="ctr">
-              <a:defRPr sz="2025" b="1">
-                <a:solidFill>
-                  <a:srgbClr val="087F8C"/>
-                </a:solidFill>
-                <a:latin typeface="Aptos"/>
-                <a:ea typeface="Aptos"/>
-                <a:cs typeface="Aptos"/>
-              </a:defRPr>
-            </a:pPr>
-            <a:r>
-              <a:rPr sz="2025" b="1">
-                <a:solidFill>
-                  <a:srgbClr val="087F8C"/>
-                </a:solidFill>
-                <a:latin typeface="Aptos"/>
-                <a:ea typeface="Aptos"/>
-                <a:cs typeface="Aptos"/>
-              </a:rPr>
-              <a:t>↑</a:t>
-            </a:r>
-          </a:p>
-        </p:txBody>
-      </p:sp>
-      <p:sp>
-        <p:nvSpPr>
-          <p:cNvPr id="34" name="">
-            <a:extLst xmlns:a="http://schemas.openxmlformats.org/drawingml/2006/main">
-              <a:ext uri="{FF2B5EF4-FFF2-40B4-BE49-F238E27FC236}">
-                <a16:creationId xmlns:a16="http://schemas.microsoft.com/office/drawing/2014/main" id="{B4CFD9A6-D686-4671-98FB-D563EF82E099}"/>
-              </a:ext>
-            </a:extLst>
-          </p:cNvPr>
-          <p:cNvSpPr>
-            <a:spLocks xmlns:a="http://schemas.openxmlformats.org/drawingml/2006/main" noGrp="1"/>
-          </p:cNvSpPr>
-          <p:nvPr/>
-        </p:nvSpPr>
-        <p:spPr>
-          <a:xfrm xmlns:a="http://schemas.openxmlformats.org/drawingml/2006/main">
-            <a:off x="8620125" y="4429125"/>
-            <a:ext cx="428625" cy="285750"/>
-          </a:xfrm>
-          <a:prstGeom xmlns:a="http://schemas.openxmlformats.org/drawingml/2006/main" prst="rect">
-            <a:avLst/>
-          </a:prstGeom>
-          <a:noFill xmlns:a="http://schemas.openxmlformats.org/drawingml/2006/main"/>
-          <a:ln xmlns:a="http://schemas.openxmlformats.org/drawingml/2006/main" w="0">
-            <a:noFill/>
-          </a:ln>
-        </p:spPr>
-        <p:txBody>
-          <a:bodyPr xmlns:a="http://schemas.openxmlformats.org/drawingml/2006/main" anchor="ctr">
-            <a:normAutofit fontScale="100000"/>
-          </a:bodyPr>
-          <a:lstStyle xmlns:a="http://schemas.openxmlformats.org/drawingml/2006/main"/>
-          <a:p xmlns:a="http://schemas.openxmlformats.org/drawingml/2006/main">
-            <a:pPr algn="ctr">
-              <a:defRPr sz="1050" b="1">
-                <a:solidFill>
-                  <a:srgbClr val="087F8C"/>
-                </a:solidFill>
-                <a:latin typeface="Aptos"/>
-                <a:ea typeface="Aptos"/>
-                <a:cs typeface="Aptos"/>
-              </a:defRPr>
-            </a:pPr>
-            <a:r>
-              <a:rPr sz="1050" b="1">
-                <a:solidFill>
-                  <a:srgbClr val="087F8C"/>
-                </a:solidFill>
-                <a:latin typeface="Aptos"/>
-                <a:ea typeface="Aptos"/>
-                <a:cs typeface="Aptos"/>
-              </a:rPr>
-              <a:t>FK</a:t>
-            </a:r>
-          </a:p>
-        </p:txBody>
-      </p:sp>
-      <p:sp>
-        <p:nvSpPr>
-          <p:cNvPr id="35" name="">
-            <a:extLst xmlns:a="http://schemas.openxmlformats.org/drawingml/2006/main">
-              <a:ext uri="{FF2B5EF4-FFF2-40B4-BE49-F238E27FC236}">
-                <a16:creationId xmlns:a16="http://schemas.microsoft.com/office/drawing/2014/main" id="{B5A95596-883E-4093-82F6-A6DD502E0633}"/>
-              </a:ext>
-            </a:extLst>
-          </p:cNvPr>
-          <p:cNvSpPr>
-            <a:spLocks xmlns:a="http://schemas.openxmlformats.org/drawingml/2006/main" noGrp="1"/>
-          </p:cNvSpPr>
-          <p:nvPr/>
-        </p:nvSpPr>
-        <p:spPr>
-          <a:xfrm xmlns:a="http://schemas.openxmlformats.org/drawingml/2006/main">
-            <a:off x="8715375" y="4714875"/>
-            <a:ext cx="333375" cy="333375"/>
-          </a:xfrm>
-          <a:prstGeom xmlns:a="http://schemas.openxmlformats.org/drawingml/2006/main" prst="rect">
-            <a:avLst/>
-          </a:prstGeom>
-          <a:noFill xmlns:a="http://schemas.openxmlformats.org/drawingml/2006/main"/>
-          <a:ln xmlns:a="http://schemas.openxmlformats.org/drawingml/2006/main" w="0">
-            <a:noFill/>
-          </a:ln>
-        </p:spPr>
-        <p:txBody>
-          <a:bodyPr xmlns:a="http://schemas.openxmlformats.org/drawingml/2006/main" anchor="ctr">
-            <a:normAutofit fontScale="58313"/>
-          </a:bodyPr>
-          <a:lstStyle xmlns:a="http://schemas.openxmlformats.org/drawingml/2006/main"/>
-          <a:p xmlns:a="http://schemas.openxmlformats.org/drawingml/2006/main">
-            <a:pPr algn="ctr">
-              <a:defRPr sz="2025" b="1">
-                <a:solidFill>
-                  <a:srgbClr val="087F8C"/>
-                </a:solidFill>
-                <a:latin typeface="Aptos"/>
-                <a:ea typeface="Aptos"/>
-                <a:cs typeface="Aptos"/>
-              </a:defRPr>
-            </a:pPr>
-            <a:r>
-              <a:rPr sz="2025" b="1">
-                <a:solidFill>
-                  <a:srgbClr val="087F8C"/>
-                </a:solidFill>
-                <a:latin typeface="Aptos"/>
-                <a:ea typeface="Aptos"/>
-                <a:cs typeface="Aptos"/>
-              </a:rPr>
-              <a:t>←</a:t>
-            </a:r>
-          </a:p>
-        </p:txBody>
-      </p:sp>
-      <p:sp>
-        <p:nvSpPr>
-          <p:cNvPr id="36" name="">
-            <a:extLst xmlns:a="http://schemas.openxmlformats.org/drawingml/2006/main">
-              <a:ext uri="{FF2B5EF4-FFF2-40B4-BE49-F238E27FC236}">
-                <a16:creationId xmlns:a16="http://schemas.microsoft.com/office/drawing/2014/main" id="{2E799069-877F-4707-B270-D03F44DD4DAC}"/>
-              </a:ext>
-            </a:extLst>
-          </p:cNvPr>
-          <p:cNvSpPr>
-            <a:spLocks xmlns:a="http://schemas.openxmlformats.org/drawingml/2006/main" noGrp="1"/>
-          </p:cNvSpPr>
-          <p:nvPr/>
-        </p:nvSpPr>
-        <p:spPr>
-          <a:xfrm xmlns:a="http://schemas.openxmlformats.org/drawingml/2006/main">
-            <a:off x="762000" y="6334125"/>
-            <a:ext cx="10668000" cy="285750"/>
-          </a:xfrm>
-          <a:prstGeom xmlns:a="http://schemas.openxmlformats.org/drawingml/2006/main" prst="rect">
-            <a:avLst/>
-          </a:prstGeom>
-          <a:noFill xmlns:a="http://schemas.openxmlformats.org/drawingml/2006/main"/>
-          <a:ln xmlns:a="http://schemas.openxmlformats.org/drawingml/2006/main" w="0">
-            <a:noFill/>
-          </a:ln>
-        </p:spPr>
-        <p:txBody>
-          <a:bodyPr xmlns:a="http://schemas.openxmlformats.org/drawingml/2006/main" anchor="ctr">
-            <a:normAutofit fontScale="100000"/>
-          </a:bodyPr>
-          <a:lstStyle xmlns:a="http://schemas.openxmlformats.org/drawingml/2006/main"/>
-          <a:p xmlns:a="http://schemas.openxmlformats.org/drawingml/2006/main">
-            <a:pPr algn="ctr">
-              <a:defRPr sz="1275" b="0">
+              <a:defRPr sz="1125" b="0">
                 <a:solidFill>
                   <a:srgbClr val="607080"/>
                 </a:solidFill>
@@ -10609,7 +8806,7 @@
               </a:defRPr>
             </a:pPr>
             <a:r>
-              <a:rPr sz="1275" b="0">
+              <a:rPr sz="1125" b="0">
                 <a:solidFill>
                   <a:srgbClr val="607080"/>
                 </a:solidFill>
@@ -10617,7 +8814,7 @@
                 <a:ea typeface="Aptos"/>
                 <a:cs typeface="Aptos"/>
               </a:rPr>
-              <a:t>Cada seta parte de uma chave estrangeira e aponta para a chave primária referenciada.</a:t>
+              <a:t>O mesmo diagrama apresentado no início do enunciado.</a:t>
             </a:r>
           </a:p>
         </p:txBody>
@@ -10625,7 +8822,7 @@
     </p:spTree>
     <p:extLst>
       <p:ext uri="{BB962C8B-B14F-4D97-AF65-F5344CB8AC3E}">
-        <p14:creationId xmlns:p14="http://schemas.microsoft.com/office/powerpoint/2010/main" val="727020578"/>
+        <p14:creationId xmlns:p14="http://schemas.microsoft.com/office/powerpoint/2010/main" val="188899355"/>
       </p:ext>
     </p:extLst>
   </p:cSld>
@@ -10649,7 +8846,7 @@
           <p:cNvPr id="10" name="">
             <a:extLst xmlns:a="http://schemas.openxmlformats.org/drawingml/2006/main">
               <a:ext uri="{FF2B5EF4-FFF2-40B4-BE49-F238E27FC236}">
-                <a16:creationId xmlns:a16="http://schemas.microsoft.com/office/drawing/2014/main" id="{F7AAD135-6BD7-4C45-963B-C55A53AE95F8}"/>
+                <a16:creationId xmlns:a16="http://schemas.microsoft.com/office/drawing/2014/main" id="{2BE2A4AC-1168-4D17-AA11-298BF03E8C6C}"/>
               </a:ext>
             </a:extLst>
           </p:cNvPr>
@@ -10679,7 +8876,7 @@
           <p:cNvPr id="2" name="">
             <a:extLst xmlns:a="http://schemas.openxmlformats.org/drawingml/2006/main">
               <a:ext uri="{FF2B5EF4-FFF2-40B4-BE49-F238E27FC236}">
-                <a16:creationId xmlns:a16="http://schemas.microsoft.com/office/drawing/2014/main" id="{050078F9-45E4-4409-A0AA-3E5014C55EAE}"/>
+                <a16:creationId xmlns:a16="http://schemas.microsoft.com/office/drawing/2014/main" id="{200CAFCA-0734-46BD-8094-5001082EC6A9}"/>
               </a:ext>
             </a:extLst>
           </p:cNvPr>
@@ -10709,7 +8906,7 @@
           <p:cNvPr id="3" name="">
             <a:extLst xmlns:a="http://schemas.openxmlformats.org/drawingml/2006/main">
               <a:ext uri="{FF2B5EF4-FFF2-40B4-BE49-F238E27FC236}">
-                <a16:creationId xmlns:a16="http://schemas.microsoft.com/office/drawing/2014/main" id="{F3B03A6C-A228-4E2F-822D-64406B1A5BBC}"/>
+                <a16:creationId xmlns:a16="http://schemas.microsoft.com/office/drawing/2014/main" id="{6688F575-BB5F-4879-8967-BFEDB824E6F5}"/>
               </a:ext>
             </a:extLst>
           </p:cNvPr>
@@ -10766,7 +8963,7 @@
           <p:cNvPr id="4" name="">
             <a:extLst xmlns:a="http://schemas.openxmlformats.org/drawingml/2006/main">
               <a:ext uri="{FF2B5EF4-FFF2-40B4-BE49-F238E27FC236}">
-                <a16:creationId xmlns:a16="http://schemas.microsoft.com/office/drawing/2014/main" id="{84F0BEF5-E57F-4E77-A8F8-05FCCCCAEEA1}"/>
+                <a16:creationId xmlns:a16="http://schemas.microsoft.com/office/drawing/2014/main" id="{B9E30049-977B-48B0-8786-FED6171AFB11}"/>
               </a:ext>
             </a:extLst>
           </p:cNvPr>
@@ -10823,7 +9020,7 @@
           <p:cNvPr id="5" name="">
             <a:extLst xmlns:a="http://schemas.openxmlformats.org/drawingml/2006/main">
               <a:ext uri="{FF2B5EF4-FFF2-40B4-BE49-F238E27FC236}">
-                <a16:creationId xmlns:a16="http://schemas.microsoft.com/office/drawing/2014/main" id="{2B9D4133-8AA0-41E6-90A9-FE76DE1A8F3A}"/>
+                <a16:creationId xmlns:a16="http://schemas.microsoft.com/office/drawing/2014/main" id="{557EC912-B5AB-4A6E-9CC7-8D62CB59B0B5}"/>
               </a:ext>
             </a:extLst>
           </p:cNvPr>
@@ -10880,7 +9077,7 @@
           <p:cNvPr id="6" name="">
             <a:extLst xmlns:a="http://schemas.openxmlformats.org/drawingml/2006/main">
               <a:ext uri="{FF2B5EF4-FFF2-40B4-BE49-F238E27FC236}">
-                <a16:creationId xmlns:a16="http://schemas.microsoft.com/office/drawing/2014/main" id="{05538252-1BF5-462E-8601-417BB7716260}"/>
+                <a16:creationId xmlns:a16="http://schemas.microsoft.com/office/drawing/2014/main" id="{4514EB26-F248-43E3-8FAB-AA5063E6380B}"/>
               </a:ext>
             </a:extLst>
           </p:cNvPr>
@@ -10937,7 +9134,7 @@
           <p:cNvPr id="7" name="">
             <a:extLst xmlns:a="http://schemas.openxmlformats.org/drawingml/2006/main">
               <a:ext uri="{FF2B5EF4-FFF2-40B4-BE49-F238E27FC236}">
-                <a16:creationId xmlns:a16="http://schemas.microsoft.com/office/drawing/2014/main" id="{57F93133-468F-4564-8C4E-F1F075EA5AF4}"/>
+                <a16:creationId xmlns:a16="http://schemas.microsoft.com/office/drawing/2014/main" id="{5391A0E8-0687-4FE8-8114-6482C008F57D}"/>
               </a:ext>
             </a:extLst>
           </p:cNvPr>
@@ -10994,7 +9191,7 @@
           <p:cNvPr id="8" name="">
             <a:extLst xmlns:a="http://schemas.openxmlformats.org/drawingml/2006/main">
               <a:ext uri="{FF2B5EF4-FFF2-40B4-BE49-F238E27FC236}">
-                <a16:creationId xmlns:a16="http://schemas.microsoft.com/office/drawing/2014/main" id="{EC09E576-C4C3-4CDD-95CA-C1721BD141ED}"/>
+                <a16:creationId xmlns:a16="http://schemas.microsoft.com/office/drawing/2014/main" id="{6FF16E46-0DE2-43AE-BE52-BF4BA08399A7}"/>
               </a:ext>
             </a:extLst>
           </p:cNvPr>
@@ -11026,7 +9223,7 @@
           <p:cNvPr id="9" name="">
             <a:extLst xmlns:a="http://schemas.openxmlformats.org/drawingml/2006/main">
               <a:ext uri="{FF2B5EF4-FFF2-40B4-BE49-F238E27FC236}">
-                <a16:creationId xmlns:a16="http://schemas.microsoft.com/office/drawing/2014/main" id="{66E6CF0E-F48E-4262-A35F-56284096BCAE}"/>
+                <a16:creationId xmlns:a16="http://schemas.microsoft.com/office/drawing/2014/main" id="{276F3AB8-D547-4343-856B-86CC5B02B63F}"/>
               </a:ext>
             </a:extLst>
           </p:cNvPr>
@@ -11104,7 +9301,7 @@
     </p:spTree>
     <p:extLst>
       <p:ext uri="{BB962C8B-B14F-4D97-AF65-F5344CB8AC3E}">
-        <p14:creationId xmlns:p14="http://schemas.microsoft.com/office/powerpoint/2010/main" val="326302741"/>
+        <p14:creationId xmlns:p14="http://schemas.microsoft.com/office/powerpoint/2010/main" val="2065031729"/>
       </p:ext>
     </p:extLst>
   </p:cSld>
@@ -11128,7 +9325,7 @@
           <p:cNvPr id="10" name="">
             <a:extLst xmlns:a="http://schemas.openxmlformats.org/drawingml/2006/main">
               <a:ext uri="{FF2B5EF4-FFF2-40B4-BE49-F238E27FC236}">
-                <a16:creationId xmlns:a16="http://schemas.microsoft.com/office/drawing/2014/main" id="{A4630252-A8E7-4D9A-BBCB-00383BDAFC37}"/>
+                <a16:creationId xmlns:a16="http://schemas.microsoft.com/office/drawing/2014/main" id="{BA3E32C1-488B-418E-8601-49E27FADE773}"/>
               </a:ext>
             </a:extLst>
           </p:cNvPr>
@@ -11158,7 +9355,7 @@
           <p:cNvPr id="2" name="">
             <a:extLst xmlns:a="http://schemas.openxmlformats.org/drawingml/2006/main">
               <a:ext uri="{FF2B5EF4-FFF2-40B4-BE49-F238E27FC236}">
-                <a16:creationId xmlns:a16="http://schemas.microsoft.com/office/drawing/2014/main" id="{31A551C8-61CC-4875-A83B-F348B5C60DB5}"/>
+                <a16:creationId xmlns:a16="http://schemas.microsoft.com/office/drawing/2014/main" id="{A778B81A-07AB-4FE2-A6D5-C1EC0B643755}"/>
               </a:ext>
             </a:extLst>
           </p:cNvPr>
@@ -11188,7 +9385,7 @@
           <p:cNvPr id="3" name="">
             <a:extLst xmlns:a="http://schemas.openxmlformats.org/drawingml/2006/main">
               <a:ext uri="{FF2B5EF4-FFF2-40B4-BE49-F238E27FC236}">
-                <a16:creationId xmlns:a16="http://schemas.microsoft.com/office/drawing/2014/main" id="{3278D8E4-6FBD-4D86-9B6E-363DB2858AF3}"/>
+                <a16:creationId xmlns:a16="http://schemas.microsoft.com/office/drawing/2014/main" id="{6A5B49C2-19F5-46C9-84C1-E2E709541591}"/>
               </a:ext>
             </a:extLst>
           </p:cNvPr>
@@ -11245,7 +9442,7 @@
           <p:cNvPr id="4" name="">
             <a:extLst xmlns:a="http://schemas.openxmlformats.org/drawingml/2006/main">
               <a:ext uri="{FF2B5EF4-FFF2-40B4-BE49-F238E27FC236}">
-                <a16:creationId xmlns:a16="http://schemas.microsoft.com/office/drawing/2014/main" id="{36594F8C-9B3D-4E43-BED4-4BB6A9E1E982}"/>
+                <a16:creationId xmlns:a16="http://schemas.microsoft.com/office/drawing/2014/main" id="{FE1266C9-AAE8-49A8-BEBA-B051617FD895}"/>
               </a:ext>
             </a:extLst>
           </p:cNvPr>
@@ -11302,7 +9499,7 @@
           <p:cNvPr id="5" name="">
             <a:extLst xmlns:a="http://schemas.openxmlformats.org/drawingml/2006/main">
               <a:ext uri="{FF2B5EF4-FFF2-40B4-BE49-F238E27FC236}">
-                <a16:creationId xmlns:a16="http://schemas.microsoft.com/office/drawing/2014/main" id="{E5FCD758-63F7-4CB9-B9E0-5572BDC491B5}"/>
+                <a16:creationId xmlns:a16="http://schemas.microsoft.com/office/drawing/2014/main" id="{9A3A0EE6-E718-4ABC-B5CF-EED15088C684}"/>
               </a:ext>
             </a:extLst>
           </p:cNvPr>
@@ -11359,7 +9556,7 @@
           <p:cNvPr id="6" name="">
             <a:extLst xmlns:a="http://schemas.openxmlformats.org/drawingml/2006/main">
               <a:ext uri="{FF2B5EF4-FFF2-40B4-BE49-F238E27FC236}">
-                <a16:creationId xmlns:a16="http://schemas.microsoft.com/office/drawing/2014/main" id="{80FD324E-1D6E-4FD5-A079-B37F686D32B7}"/>
+                <a16:creationId xmlns:a16="http://schemas.microsoft.com/office/drawing/2014/main" id="{E9825A8D-281F-4E91-A087-15679AAAB0A8}"/>
               </a:ext>
             </a:extLst>
           </p:cNvPr>
@@ -11416,7 +9613,7 @@
           <p:cNvPr id="7" name="">
             <a:extLst xmlns:a="http://schemas.openxmlformats.org/drawingml/2006/main">
               <a:ext uri="{FF2B5EF4-FFF2-40B4-BE49-F238E27FC236}">
-                <a16:creationId xmlns:a16="http://schemas.microsoft.com/office/drawing/2014/main" id="{69B461C5-3D46-4033-AEA4-EEE7A6E8E64A}"/>
+                <a16:creationId xmlns:a16="http://schemas.microsoft.com/office/drawing/2014/main" id="{3D263BBE-237A-4A72-A0A7-4057730C0FBE}"/>
               </a:ext>
             </a:extLst>
           </p:cNvPr>
@@ -11473,7 +9670,7 @@
           <p:cNvPr id="8" name="">
             <a:extLst xmlns:a="http://schemas.openxmlformats.org/drawingml/2006/main">
               <a:ext uri="{FF2B5EF4-FFF2-40B4-BE49-F238E27FC236}">
-                <a16:creationId xmlns:a16="http://schemas.microsoft.com/office/drawing/2014/main" id="{2E899C37-4991-4A75-BE3A-C66A29D8F763}"/>
+                <a16:creationId xmlns:a16="http://schemas.microsoft.com/office/drawing/2014/main" id="{F0BD6C15-C3D5-4BAD-8FC5-8F5694F7376F}"/>
               </a:ext>
             </a:extLst>
           </p:cNvPr>
@@ -11505,7 +9702,7 @@
           <p:cNvPr id="9" name="">
             <a:extLst xmlns:a="http://schemas.openxmlformats.org/drawingml/2006/main">
               <a:ext uri="{FF2B5EF4-FFF2-40B4-BE49-F238E27FC236}">
-                <a16:creationId xmlns:a16="http://schemas.microsoft.com/office/drawing/2014/main" id="{6FD6174E-E386-4066-9830-77C0035BED13}"/>
+                <a16:creationId xmlns:a16="http://schemas.microsoft.com/office/drawing/2014/main" id="{C5E9F71C-15FD-436E-A8A0-D4ED68E02660}"/>
               </a:ext>
             </a:extLst>
           </p:cNvPr>
@@ -11583,7 +9780,7 @@
     </p:spTree>
     <p:extLst>
       <p:ext uri="{BB962C8B-B14F-4D97-AF65-F5344CB8AC3E}">
-        <p14:creationId xmlns:p14="http://schemas.microsoft.com/office/powerpoint/2010/main" val="189812915"/>
+        <p14:creationId xmlns:p14="http://schemas.microsoft.com/office/powerpoint/2010/main" val="405561809"/>
       </p:ext>
     </p:extLst>
   </p:cSld>
@@ -11607,7 +9804,7 @@
           <p:cNvPr id="10" name="">
             <a:extLst xmlns:a="http://schemas.openxmlformats.org/drawingml/2006/main">
               <a:ext uri="{FF2B5EF4-FFF2-40B4-BE49-F238E27FC236}">
-                <a16:creationId xmlns:a16="http://schemas.microsoft.com/office/drawing/2014/main" id="{432786CD-FDAD-44A8-9FD0-87337E7A2881}"/>
+                <a16:creationId xmlns:a16="http://schemas.microsoft.com/office/drawing/2014/main" id="{EBD14B84-C01B-4317-A052-F8A7C2D22D80}"/>
               </a:ext>
             </a:extLst>
           </p:cNvPr>
@@ -11637,7 +9834,7 @@
           <p:cNvPr id="2" name="">
             <a:extLst xmlns:a="http://schemas.openxmlformats.org/drawingml/2006/main">
               <a:ext uri="{FF2B5EF4-FFF2-40B4-BE49-F238E27FC236}">
-                <a16:creationId xmlns:a16="http://schemas.microsoft.com/office/drawing/2014/main" id="{5A63ADD3-0312-48FB-939C-9AD4271D7CC0}"/>
+                <a16:creationId xmlns:a16="http://schemas.microsoft.com/office/drawing/2014/main" id="{E011CD82-24EA-4B66-89C5-6081295C2D7B}"/>
               </a:ext>
             </a:extLst>
           </p:cNvPr>
@@ -11667,7 +9864,7 @@
           <p:cNvPr id="3" name="">
             <a:extLst xmlns:a="http://schemas.openxmlformats.org/drawingml/2006/main">
               <a:ext uri="{FF2B5EF4-FFF2-40B4-BE49-F238E27FC236}">
-                <a16:creationId xmlns:a16="http://schemas.microsoft.com/office/drawing/2014/main" id="{8F505E5A-C9F1-4135-8A04-2BD445A6F5B7}"/>
+                <a16:creationId xmlns:a16="http://schemas.microsoft.com/office/drawing/2014/main" id="{540854C8-330C-4C16-8406-778215C9697E}"/>
               </a:ext>
             </a:extLst>
           </p:cNvPr>
@@ -11724,7 +9921,7 @@
           <p:cNvPr id="4" name="">
             <a:extLst xmlns:a="http://schemas.openxmlformats.org/drawingml/2006/main">
               <a:ext uri="{FF2B5EF4-FFF2-40B4-BE49-F238E27FC236}">
-                <a16:creationId xmlns:a16="http://schemas.microsoft.com/office/drawing/2014/main" id="{3D0F718C-642D-4681-9252-F8FB05E1F0BE}"/>
+                <a16:creationId xmlns:a16="http://schemas.microsoft.com/office/drawing/2014/main" id="{C6CD2EC3-A42C-4087-9164-A5902831AB25}"/>
               </a:ext>
             </a:extLst>
           </p:cNvPr>
@@ -11781,7 +9978,7 @@
           <p:cNvPr id="5" name="">
             <a:extLst xmlns:a="http://schemas.openxmlformats.org/drawingml/2006/main">
               <a:ext uri="{FF2B5EF4-FFF2-40B4-BE49-F238E27FC236}">
-                <a16:creationId xmlns:a16="http://schemas.microsoft.com/office/drawing/2014/main" id="{7742FBBF-61F9-482E-B63F-FE600D03AF72}"/>
+                <a16:creationId xmlns:a16="http://schemas.microsoft.com/office/drawing/2014/main" id="{3BF75631-EFEC-49ED-8920-BE99F32478E9}"/>
               </a:ext>
             </a:extLst>
           </p:cNvPr>
@@ -11838,7 +10035,7 @@
           <p:cNvPr id="6" name="">
             <a:extLst xmlns:a="http://schemas.openxmlformats.org/drawingml/2006/main">
               <a:ext uri="{FF2B5EF4-FFF2-40B4-BE49-F238E27FC236}">
-                <a16:creationId xmlns:a16="http://schemas.microsoft.com/office/drawing/2014/main" id="{BCA00571-497A-4BCA-9C4F-A3D867BD6E0F}"/>
+                <a16:creationId xmlns:a16="http://schemas.microsoft.com/office/drawing/2014/main" id="{D20BB561-9D8F-435F-A0BE-FB2D8C6F5180}"/>
               </a:ext>
             </a:extLst>
           </p:cNvPr>
@@ -11895,7 +10092,7 @@
           <p:cNvPr id="7" name="">
             <a:extLst xmlns:a="http://schemas.openxmlformats.org/drawingml/2006/main">
               <a:ext uri="{FF2B5EF4-FFF2-40B4-BE49-F238E27FC236}">
-                <a16:creationId xmlns:a16="http://schemas.microsoft.com/office/drawing/2014/main" id="{9C1CBA0C-EBBE-42FB-89FB-B5EF60029617}"/>
+                <a16:creationId xmlns:a16="http://schemas.microsoft.com/office/drawing/2014/main" id="{0420453E-E879-4164-BFF7-667867336E35}"/>
               </a:ext>
             </a:extLst>
           </p:cNvPr>
@@ -11952,7 +10149,7 @@
           <p:cNvPr id="8" name="">
             <a:extLst xmlns:a="http://schemas.openxmlformats.org/drawingml/2006/main">
               <a:ext uri="{FF2B5EF4-FFF2-40B4-BE49-F238E27FC236}">
-                <a16:creationId xmlns:a16="http://schemas.microsoft.com/office/drawing/2014/main" id="{19685D67-5DE6-430B-B05E-7E86A784BFCB}"/>
+                <a16:creationId xmlns:a16="http://schemas.microsoft.com/office/drawing/2014/main" id="{C059BFE0-28CD-4893-AEB6-E754E40F1E66}"/>
               </a:ext>
             </a:extLst>
           </p:cNvPr>
@@ -11984,7 +10181,7 @@
           <p:cNvPr id="9" name="">
             <a:extLst xmlns:a="http://schemas.openxmlformats.org/drawingml/2006/main">
               <a:ext uri="{FF2B5EF4-FFF2-40B4-BE49-F238E27FC236}">
-                <a16:creationId xmlns:a16="http://schemas.microsoft.com/office/drawing/2014/main" id="{570AE6A5-9D94-4B98-B7DF-F2897DEB0B11}"/>
+                <a16:creationId xmlns:a16="http://schemas.microsoft.com/office/drawing/2014/main" id="{BC2B719D-9D3D-44C0-8D60-6142929BA352}"/>
               </a:ext>
             </a:extLst>
           </p:cNvPr>
@@ -12338,7 +10535,7 @@
     </p:spTree>
     <p:extLst>
       <p:ext uri="{BB962C8B-B14F-4D97-AF65-F5344CB8AC3E}">
-        <p14:creationId xmlns:p14="http://schemas.microsoft.com/office/powerpoint/2010/main" val="401127868"/>
+        <p14:creationId xmlns:p14="http://schemas.microsoft.com/office/powerpoint/2010/main" val="1584348563"/>
       </p:ext>
     </p:extLst>
   </p:cSld>
@@ -12362,7 +10559,7 @@
           <p:cNvPr id="10" name="">
             <a:extLst xmlns:a="http://schemas.openxmlformats.org/drawingml/2006/main">
               <a:ext uri="{FF2B5EF4-FFF2-40B4-BE49-F238E27FC236}">
-                <a16:creationId xmlns:a16="http://schemas.microsoft.com/office/drawing/2014/main" id="{85DA3AFD-3F42-42E1-A407-45953972A8D2}"/>
+                <a16:creationId xmlns:a16="http://schemas.microsoft.com/office/drawing/2014/main" id="{4AEE4A41-AC9B-469E-AB95-A48BC7F15C8F}"/>
               </a:ext>
             </a:extLst>
           </p:cNvPr>
@@ -12392,7 +10589,7 @@
           <p:cNvPr id="2" name="">
             <a:extLst xmlns:a="http://schemas.openxmlformats.org/drawingml/2006/main">
               <a:ext uri="{FF2B5EF4-FFF2-40B4-BE49-F238E27FC236}">
-                <a16:creationId xmlns:a16="http://schemas.microsoft.com/office/drawing/2014/main" id="{B316EF75-1D88-4944-8A9F-3C682B168DAC}"/>
+                <a16:creationId xmlns:a16="http://schemas.microsoft.com/office/drawing/2014/main" id="{CF4C4DCD-1571-42D8-9AE4-6A6FB0BF23DD}"/>
               </a:ext>
             </a:extLst>
           </p:cNvPr>
@@ -12422,7 +10619,7 @@
           <p:cNvPr id="3" name="">
             <a:extLst xmlns:a="http://schemas.openxmlformats.org/drawingml/2006/main">
               <a:ext uri="{FF2B5EF4-FFF2-40B4-BE49-F238E27FC236}">
-                <a16:creationId xmlns:a16="http://schemas.microsoft.com/office/drawing/2014/main" id="{014F57B0-AB8E-46BF-BD47-98B52A9F91C2}"/>
+                <a16:creationId xmlns:a16="http://schemas.microsoft.com/office/drawing/2014/main" id="{844EACC8-7A2B-464E-8A56-CCBE8A15BB82}"/>
               </a:ext>
             </a:extLst>
           </p:cNvPr>
@@ -12479,7 +10676,7 @@
           <p:cNvPr id="4" name="">
             <a:extLst xmlns:a="http://schemas.openxmlformats.org/drawingml/2006/main">
               <a:ext uri="{FF2B5EF4-FFF2-40B4-BE49-F238E27FC236}">
-                <a16:creationId xmlns:a16="http://schemas.microsoft.com/office/drawing/2014/main" id="{AEEC8D84-7F75-467D-AC2F-E300C7D37C4D}"/>
+                <a16:creationId xmlns:a16="http://schemas.microsoft.com/office/drawing/2014/main" id="{FAE5A726-9692-41D8-8270-07C8B0C53477}"/>
               </a:ext>
             </a:extLst>
           </p:cNvPr>
@@ -12536,7 +10733,7 @@
           <p:cNvPr id="5" name="">
             <a:extLst xmlns:a="http://schemas.openxmlformats.org/drawingml/2006/main">
               <a:ext uri="{FF2B5EF4-FFF2-40B4-BE49-F238E27FC236}">
-                <a16:creationId xmlns:a16="http://schemas.microsoft.com/office/drawing/2014/main" id="{3AD93FDA-9096-4FC6-AB97-C294B013D594}"/>
+                <a16:creationId xmlns:a16="http://schemas.microsoft.com/office/drawing/2014/main" id="{F7409742-8B2B-4AFA-8835-F0BA912C7E18}"/>
               </a:ext>
             </a:extLst>
           </p:cNvPr>
@@ -12593,7 +10790,7 @@
           <p:cNvPr id="6" name="">
             <a:extLst xmlns:a="http://schemas.openxmlformats.org/drawingml/2006/main">
               <a:ext uri="{FF2B5EF4-FFF2-40B4-BE49-F238E27FC236}">
-                <a16:creationId xmlns:a16="http://schemas.microsoft.com/office/drawing/2014/main" id="{11FC93C8-50D8-4F34-B257-AB82CD9EB355}"/>
+                <a16:creationId xmlns:a16="http://schemas.microsoft.com/office/drawing/2014/main" id="{99C8B3CA-0AC8-45AF-BBF2-12C4CC7CE21B}"/>
               </a:ext>
             </a:extLst>
           </p:cNvPr>
@@ -12650,7 +10847,7 @@
           <p:cNvPr id="7" name="">
             <a:extLst xmlns:a="http://schemas.openxmlformats.org/drawingml/2006/main">
               <a:ext uri="{FF2B5EF4-FFF2-40B4-BE49-F238E27FC236}">
-                <a16:creationId xmlns:a16="http://schemas.microsoft.com/office/drawing/2014/main" id="{3527B628-02CB-4429-AD3B-F9EA9F1DC8ED}"/>
+                <a16:creationId xmlns:a16="http://schemas.microsoft.com/office/drawing/2014/main" id="{C6CD0859-9C72-49B7-A96D-08407271DEEE}"/>
               </a:ext>
             </a:extLst>
           </p:cNvPr>
@@ -12707,7 +10904,7 @@
           <p:cNvPr id="8" name="">
             <a:extLst xmlns:a="http://schemas.openxmlformats.org/drawingml/2006/main">
               <a:ext uri="{FF2B5EF4-FFF2-40B4-BE49-F238E27FC236}">
-                <a16:creationId xmlns:a16="http://schemas.microsoft.com/office/drawing/2014/main" id="{198677C4-2231-4A18-8677-8078DD7962D7}"/>
+                <a16:creationId xmlns:a16="http://schemas.microsoft.com/office/drawing/2014/main" id="{D9C023D1-2358-471B-9C4B-C6EC5F51CBCD}"/>
               </a:ext>
             </a:extLst>
           </p:cNvPr>
@@ -12739,7 +10936,7 @@
           <p:cNvPr id="9" name="">
             <a:extLst xmlns:a="http://schemas.openxmlformats.org/drawingml/2006/main">
               <a:ext uri="{FF2B5EF4-FFF2-40B4-BE49-F238E27FC236}">
-                <a16:creationId xmlns:a16="http://schemas.microsoft.com/office/drawing/2014/main" id="{7309938A-6E7C-4A38-A5E0-4279C96DF082}"/>
+                <a16:creationId xmlns:a16="http://schemas.microsoft.com/office/drawing/2014/main" id="{E4014658-6990-4F84-8EF0-9BFD2A14E2D3}"/>
               </a:ext>
             </a:extLst>
           </p:cNvPr>
@@ -13024,7 +11221,7 @@
     </p:spTree>
     <p:extLst>
       <p:ext uri="{BB962C8B-B14F-4D97-AF65-F5344CB8AC3E}">
-        <p14:creationId xmlns:p14="http://schemas.microsoft.com/office/powerpoint/2010/main" val="2090964095"/>
+        <p14:creationId xmlns:p14="http://schemas.microsoft.com/office/powerpoint/2010/main" val="904184513"/>
       </p:ext>
     </p:extLst>
   </p:cSld>
@@ -13048,7 +11245,7 @@
           <p:cNvPr id="10" name="">
             <a:extLst xmlns:a="http://schemas.openxmlformats.org/drawingml/2006/main">
               <a:ext uri="{FF2B5EF4-FFF2-40B4-BE49-F238E27FC236}">
-                <a16:creationId xmlns:a16="http://schemas.microsoft.com/office/drawing/2014/main" id="{C807A0CE-B443-4C52-B005-EDB5B7D6A12C}"/>
+                <a16:creationId xmlns:a16="http://schemas.microsoft.com/office/drawing/2014/main" id="{63874EBD-BEDF-4D51-AAD8-0F80C6C617F4}"/>
               </a:ext>
             </a:extLst>
           </p:cNvPr>
@@ -13078,7 +11275,7 @@
           <p:cNvPr id="2" name="">
             <a:extLst xmlns:a="http://schemas.openxmlformats.org/drawingml/2006/main">
               <a:ext uri="{FF2B5EF4-FFF2-40B4-BE49-F238E27FC236}">
-                <a16:creationId xmlns:a16="http://schemas.microsoft.com/office/drawing/2014/main" id="{DAE66430-7C2F-4B3F-AA5D-ED0D396BEFC0}"/>
+                <a16:creationId xmlns:a16="http://schemas.microsoft.com/office/drawing/2014/main" id="{876E2AA0-1E77-4D62-9640-94F375CDB6A1}"/>
               </a:ext>
             </a:extLst>
           </p:cNvPr>
@@ -13108,7 +11305,7 @@
           <p:cNvPr id="3" name="">
             <a:extLst xmlns:a="http://schemas.openxmlformats.org/drawingml/2006/main">
               <a:ext uri="{FF2B5EF4-FFF2-40B4-BE49-F238E27FC236}">
-                <a16:creationId xmlns:a16="http://schemas.microsoft.com/office/drawing/2014/main" id="{E4D05E7A-F485-4B73-A970-D65F52379ED3}"/>
+                <a16:creationId xmlns:a16="http://schemas.microsoft.com/office/drawing/2014/main" id="{65050CA7-0A69-41D4-8E14-DA06BB12F503}"/>
               </a:ext>
             </a:extLst>
           </p:cNvPr>
@@ -13165,7 +11362,7 @@
           <p:cNvPr id="4" name="">
             <a:extLst xmlns:a="http://schemas.openxmlformats.org/drawingml/2006/main">
               <a:ext uri="{FF2B5EF4-FFF2-40B4-BE49-F238E27FC236}">
-                <a16:creationId xmlns:a16="http://schemas.microsoft.com/office/drawing/2014/main" id="{0E1E6523-8EF4-44FA-9B77-99A4969D232E}"/>
+                <a16:creationId xmlns:a16="http://schemas.microsoft.com/office/drawing/2014/main" id="{EE6A7E41-D34D-468E-A695-1182D4369E08}"/>
               </a:ext>
             </a:extLst>
           </p:cNvPr>
@@ -13222,7 +11419,7 @@
           <p:cNvPr id="5" name="">
             <a:extLst xmlns:a="http://schemas.openxmlformats.org/drawingml/2006/main">
               <a:ext uri="{FF2B5EF4-FFF2-40B4-BE49-F238E27FC236}">
-                <a16:creationId xmlns:a16="http://schemas.microsoft.com/office/drawing/2014/main" id="{2F9E8095-58CD-423F-A64A-D42F59E5C6D1}"/>
+                <a16:creationId xmlns:a16="http://schemas.microsoft.com/office/drawing/2014/main" id="{6C8E9DBF-4918-4A60-81AC-8793FEF5B1DA}"/>
               </a:ext>
             </a:extLst>
           </p:cNvPr>
@@ -13279,7 +11476,7 @@
           <p:cNvPr id="6" name="">
             <a:extLst xmlns:a="http://schemas.openxmlformats.org/drawingml/2006/main">
               <a:ext uri="{FF2B5EF4-FFF2-40B4-BE49-F238E27FC236}">
-                <a16:creationId xmlns:a16="http://schemas.microsoft.com/office/drawing/2014/main" id="{21F62AB0-84FB-454E-8D6E-EE2A2883477F}"/>
+                <a16:creationId xmlns:a16="http://schemas.microsoft.com/office/drawing/2014/main" id="{2BEF6974-7E8E-4645-8384-8D642A78A035}"/>
               </a:ext>
             </a:extLst>
           </p:cNvPr>
@@ -13336,7 +11533,7 @@
           <p:cNvPr id="7" name="">
             <a:extLst xmlns:a="http://schemas.openxmlformats.org/drawingml/2006/main">
               <a:ext uri="{FF2B5EF4-FFF2-40B4-BE49-F238E27FC236}">
-                <a16:creationId xmlns:a16="http://schemas.microsoft.com/office/drawing/2014/main" id="{7DB0EA9B-C478-465D-8645-345382512675}"/>
+                <a16:creationId xmlns:a16="http://schemas.microsoft.com/office/drawing/2014/main" id="{07A59A49-5887-4B3A-B77F-3881ADDFAA17}"/>
               </a:ext>
             </a:extLst>
           </p:cNvPr>
@@ -13393,7 +11590,7 @@
           <p:cNvPr id="8" name="">
             <a:extLst xmlns:a="http://schemas.openxmlformats.org/drawingml/2006/main">
               <a:ext uri="{FF2B5EF4-FFF2-40B4-BE49-F238E27FC236}">
-                <a16:creationId xmlns:a16="http://schemas.microsoft.com/office/drawing/2014/main" id="{2B909D39-92EF-4BCF-89A5-5D65D6765D48}"/>
+                <a16:creationId xmlns:a16="http://schemas.microsoft.com/office/drawing/2014/main" id="{FFD765C5-2B1F-4D47-9B26-5A0045B837FA}"/>
               </a:ext>
             </a:extLst>
           </p:cNvPr>
@@ -13425,7 +11622,7 @@
           <p:cNvPr id="9" name="">
             <a:extLst xmlns:a="http://schemas.openxmlformats.org/drawingml/2006/main">
               <a:ext uri="{FF2B5EF4-FFF2-40B4-BE49-F238E27FC236}">
-                <a16:creationId xmlns:a16="http://schemas.microsoft.com/office/drawing/2014/main" id="{34D58606-A357-4EFB-A098-0186A9FC7495}"/>
+                <a16:creationId xmlns:a16="http://schemas.microsoft.com/office/drawing/2014/main" id="{33BA2865-3830-4FF9-9324-E81949AABDAC}"/>
               </a:ext>
             </a:extLst>
           </p:cNvPr>
@@ -13503,7 +11700,7 @@
     </p:spTree>
     <p:extLst>
       <p:ext uri="{BB962C8B-B14F-4D97-AF65-F5344CB8AC3E}">
-        <p14:creationId xmlns:p14="http://schemas.microsoft.com/office/powerpoint/2010/main" val="1287146831"/>
+        <p14:creationId xmlns:p14="http://schemas.microsoft.com/office/powerpoint/2010/main" val="1372721524"/>
       </p:ext>
     </p:extLst>
   </p:cSld>
@@ -13527,7 +11724,7 @@
           <p:cNvPr id="10" name="">
             <a:extLst xmlns:a="http://schemas.openxmlformats.org/drawingml/2006/main">
               <a:ext uri="{FF2B5EF4-FFF2-40B4-BE49-F238E27FC236}">
-                <a16:creationId xmlns:a16="http://schemas.microsoft.com/office/drawing/2014/main" id="{866E27F1-69FF-4528-A101-98EC5C1A4A83}"/>
+                <a16:creationId xmlns:a16="http://schemas.microsoft.com/office/drawing/2014/main" id="{A087AF89-83CE-4971-A5FB-09E2F7BA8E37}"/>
               </a:ext>
             </a:extLst>
           </p:cNvPr>
@@ -13557,7 +11754,7 @@
           <p:cNvPr id="2" name="">
             <a:extLst xmlns:a="http://schemas.openxmlformats.org/drawingml/2006/main">
               <a:ext uri="{FF2B5EF4-FFF2-40B4-BE49-F238E27FC236}">
-                <a16:creationId xmlns:a16="http://schemas.microsoft.com/office/drawing/2014/main" id="{D93B8297-C274-45AB-9B4D-D3202AE556F3}"/>
+                <a16:creationId xmlns:a16="http://schemas.microsoft.com/office/drawing/2014/main" id="{22108C4A-0F96-485C-B792-D41129A96A23}"/>
               </a:ext>
             </a:extLst>
           </p:cNvPr>
@@ -13587,7 +11784,7 @@
           <p:cNvPr id="3" name="">
             <a:extLst xmlns:a="http://schemas.openxmlformats.org/drawingml/2006/main">
               <a:ext uri="{FF2B5EF4-FFF2-40B4-BE49-F238E27FC236}">
-                <a16:creationId xmlns:a16="http://schemas.microsoft.com/office/drawing/2014/main" id="{95F3C681-074D-4A16-B599-236C33C9FF7F}"/>
+                <a16:creationId xmlns:a16="http://schemas.microsoft.com/office/drawing/2014/main" id="{982CA1A8-7AF8-4B87-8703-D4DB648091C8}"/>
               </a:ext>
             </a:extLst>
           </p:cNvPr>
@@ -13644,7 +11841,7 @@
           <p:cNvPr id="4" name="">
             <a:extLst xmlns:a="http://schemas.openxmlformats.org/drawingml/2006/main">
               <a:ext uri="{FF2B5EF4-FFF2-40B4-BE49-F238E27FC236}">
-                <a16:creationId xmlns:a16="http://schemas.microsoft.com/office/drawing/2014/main" id="{0937B61E-49E4-4B53-9EDA-06819BA7D0BA}"/>
+                <a16:creationId xmlns:a16="http://schemas.microsoft.com/office/drawing/2014/main" id="{1544CFFB-25FA-40C1-8F4A-F3616F8BCE91}"/>
               </a:ext>
             </a:extLst>
           </p:cNvPr>
@@ -13701,7 +11898,7 @@
           <p:cNvPr id="5" name="">
             <a:extLst xmlns:a="http://schemas.openxmlformats.org/drawingml/2006/main">
               <a:ext uri="{FF2B5EF4-FFF2-40B4-BE49-F238E27FC236}">
-                <a16:creationId xmlns:a16="http://schemas.microsoft.com/office/drawing/2014/main" id="{0B5CC94F-0A1F-4238-A140-A05B958B4E53}"/>
+                <a16:creationId xmlns:a16="http://schemas.microsoft.com/office/drawing/2014/main" id="{5D6A8258-8B99-4238-B917-83D92BC439BA}"/>
               </a:ext>
             </a:extLst>
           </p:cNvPr>
@@ -13758,7 +11955,7 @@
           <p:cNvPr id="6" name="">
             <a:extLst xmlns:a="http://schemas.openxmlformats.org/drawingml/2006/main">
               <a:ext uri="{FF2B5EF4-FFF2-40B4-BE49-F238E27FC236}">
-                <a16:creationId xmlns:a16="http://schemas.microsoft.com/office/drawing/2014/main" id="{D3C56B98-7F0E-401C-B3B6-194C7B3973D1}"/>
+                <a16:creationId xmlns:a16="http://schemas.microsoft.com/office/drawing/2014/main" id="{2329EEFC-C347-4A93-9391-923AF8FF4135}"/>
               </a:ext>
             </a:extLst>
           </p:cNvPr>
@@ -13815,7 +12012,7 @@
           <p:cNvPr id="7" name="">
             <a:extLst xmlns:a="http://schemas.openxmlformats.org/drawingml/2006/main">
               <a:ext uri="{FF2B5EF4-FFF2-40B4-BE49-F238E27FC236}">
-                <a16:creationId xmlns:a16="http://schemas.microsoft.com/office/drawing/2014/main" id="{7A44E9F9-0C31-4252-AC2E-217D141D65A8}"/>
+                <a16:creationId xmlns:a16="http://schemas.microsoft.com/office/drawing/2014/main" id="{DD695AEB-19D3-4E43-9605-08521BA4AE72}"/>
               </a:ext>
             </a:extLst>
           </p:cNvPr>
@@ -13872,7 +12069,7 @@
           <p:cNvPr id="8" name="">
             <a:extLst xmlns:a="http://schemas.openxmlformats.org/drawingml/2006/main">
               <a:ext uri="{FF2B5EF4-FFF2-40B4-BE49-F238E27FC236}">
-                <a16:creationId xmlns:a16="http://schemas.microsoft.com/office/drawing/2014/main" id="{92A84716-D710-472B-A6D4-6EC20CF3C3A1}"/>
+                <a16:creationId xmlns:a16="http://schemas.microsoft.com/office/drawing/2014/main" id="{FC19193D-B26D-4E53-B066-1C3A1C3A3106}"/>
               </a:ext>
             </a:extLst>
           </p:cNvPr>
@@ -13904,7 +12101,7 @@
           <p:cNvPr id="9" name="">
             <a:extLst xmlns:a="http://schemas.openxmlformats.org/drawingml/2006/main">
               <a:ext uri="{FF2B5EF4-FFF2-40B4-BE49-F238E27FC236}">
-                <a16:creationId xmlns:a16="http://schemas.microsoft.com/office/drawing/2014/main" id="{DAE13337-3E2B-4AAB-A67A-C012FC13973A}"/>
+                <a16:creationId xmlns:a16="http://schemas.microsoft.com/office/drawing/2014/main" id="{81A8FD80-BB6C-4569-818B-1A34F3540796}"/>
               </a:ext>
             </a:extLst>
           </p:cNvPr>
@@ -13982,7 +12179,7 @@
     </p:spTree>
     <p:extLst>
       <p:ext uri="{BB962C8B-B14F-4D97-AF65-F5344CB8AC3E}">
-        <p14:creationId xmlns:p14="http://schemas.microsoft.com/office/powerpoint/2010/main" val="1214099183"/>
+        <p14:creationId xmlns:p14="http://schemas.microsoft.com/office/powerpoint/2010/main" val="2044388154"/>
       </p:ext>
     </p:extLst>
   </p:cSld>
@@ -14006,7 +12203,7 @@
           <p:cNvPr id="10" name="">
             <a:extLst xmlns:a="http://schemas.openxmlformats.org/drawingml/2006/main">
               <a:ext uri="{FF2B5EF4-FFF2-40B4-BE49-F238E27FC236}">
-                <a16:creationId xmlns:a16="http://schemas.microsoft.com/office/drawing/2014/main" id="{F9CA7066-7E91-4EB0-838A-B334EF87542C}"/>
+                <a16:creationId xmlns:a16="http://schemas.microsoft.com/office/drawing/2014/main" id="{5CB40286-6B8F-458B-BFD8-9CCA7CE14C1A}"/>
               </a:ext>
             </a:extLst>
           </p:cNvPr>
@@ -14036,7 +12233,7 @@
           <p:cNvPr id="2" name="">
             <a:extLst xmlns:a="http://schemas.openxmlformats.org/drawingml/2006/main">
               <a:ext uri="{FF2B5EF4-FFF2-40B4-BE49-F238E27FC236}">
-                <a16:creationId xmlns:a16="http://schemas.microsoft.com/office/drawing/2014/main" id="{68AE9FD4-6D62-490E-B2E7-EBF358EE0CBE}"/>
+                <a16:creationId xmlns:a16="http://schemas.microsoft.com/office/drawing/2014/main" id="{321C413C-EA9F-4D1A-844A-9B1D4EF19411}"/>
               </a:ext>
             </a:extLst>
           </p:cNvPr>
@@ -14066,7 +12263,7 @@
           <p:cNvPr id="3" name="">
             <a:extLst xmlns:a="http://schemas.openxmlformats.org/drawingml/2006/main">
               <a:ext uri="{FF2B5EF4-FFF2-40B4-BE49-F238E27FC236}">
-                <a16:creationId xmlns:a16="http://schemas.microsoft.com/office/drawing/2014/main" id="{12E27CEE-987C-4C4E-B736-74D9ABCEA9F4}"/>
+                <a16:creationId xmlns:a16="http://schemas.microsoft.com/office/drawing/2014/main" id="{D293D401-A4C9-4F9D-99B4-A47C53F9BEB3}"/>
               </a:ext>
             </a:extLst>
           </p:cNvPr>
@@ -14123,7 +12320,7 @@
           <p:cNvPr id="4" name="">
             <a:extLst xmlns:a="http://schemas.openxmlformats.org/drawingml/2006/main">
               <a:ext uri="{FF2B5EF4-FFF2-40B4-BE49-F238E27FC236}">
-                <a16:creationId xmlns:a16="http://schemas.microsoft.com/office/drawing/2014/main" id="{520F7F4C-03FE-461B-A887-FCCBCD48F5A3}"/>
+                <a16:creationId xmlns:a16="http://schemas.microsoft.com/office/drawing/2014/main" id="{031B5B28-9C7A-4AAF-831A-0ADFA21A0A45}"/>
               </a:ext>
             </a:extLst>
           </p:cNvPr>
@@ -14180,7 +12377,7 @@
           <p:cNvPr id="5" name="">
             <a:extLst xmlns:a="http://schemas.openxmlformats.org/drawingml/2006/main">
               <a:ext uri="{FF2B5EF4-FFF2-40B4-BE49-F238E27FC236}">
-                <a16:creationId xmlns:a16="http://schemas.microsoft.com/office/drawing/2014/main" id="{3F82E2A2-1CB5-4AAF-BB92-99C22297A13D}"/>
+                <a16:creationId xmlns:a16="http://schemas.microsoft.com/office/drawing/2014/main" id="{E20F8C6A-7521-4485-BEA8-C66DA4C5B2B9}"/>
               </a:ext>
             </a:extLst>
           </p:cNvPr>
@@ -14237,7 +12434,7 @@
           <p:cNvPr id="6" name="">
             <a:extLst xmlns:a="http://schemas.openxmlformats.org/drawingml/2006/main">
               <a:ext uri="{FF2B5EF4-FFF2-40B4-BE49-F238E27FC236}">
-                <a16:creationId xmlns:a16="http://schemas.microsoft.com/office/drawing/2014/main" id="{60ABFB19-FF63-4011-BFFF-63759DF07BE5}"/>
+                <a16:creationId xmlns:a16="http://schemas.microsoft.com/office/drawing/2014/main" id="{D30341D4-CC1A-49F4-819F-943C0193F49C}"/>
               </a:ext>
             </a:extLst>
           </p:cNvPr>
@@ -14294,7 +12491,7 @@
           <p:cNvPr id="7" name="">
             <a:extLst xmlns:a="http://schemas.openxmlformats.org/drawingml/2006/main">
               <a:ext uri="{FF2B5EF4-FFF2-40B4-BE49-F238E27FC236}">
-                <a16:creationId xmlns:a16="http://schemas.microsoft.com/office/drawing/2014/main" id="{803972CA-202C-40D4-AA83-5281D74ED027}"/>
+                <a16:creationId xmlns:a16="http://schemas.microsoft.com/office/drawing/2014/main" id="{1CC2C394-C1C2-4DA1-8CD3-6E708386D9BA}"/>
               </a:ext>
             </a:extLst>
           </p:cNvPr>
@@ -14351,7 +12548,7 @@
           <p:cNvPr id="8" name="">
             <a:extLst xmlns:a="http://schemas.openxmlformats.org/drawingml/2006/main">
               <a:ext uri="{FF2B5EF4-FFF2-40B4-BE49-F238E27FC236}">
-                <a16:creationId xmlns:a16="http://schemas.microsoft.com/office/drawing/2014/main" id="{A3FCCAC4-D9DA-4863-BF27-D0B378E144EB}"/>
+                <a16:creationId xmlns:a16="http://schemas.microsoft.com/office/drawing/2014/main" id="{A8E4C6AC-24EB-4FEA-8416-952C34BEE80F}"/>
               </a:ext>
             </a:extLst>
           </p:cNvPr>
@@ -14383,7 +12580,7 @@
           <p:cNvPr id="9" name="">
             <a:extLst xmlns:a="http://schemas.openxmlformats.org/drawingml/2006/main">
               <a:ext uri="{FF2B5EF4-FFF2-40B4-BE49-F238E27FC236}">
-                <a16:creationId xmlns:a16="http://schemas.microsoft.com/office/drawing/2014/main" id="{C018551E-D0CC-41AB-BECC-22FC9B3BF035}"/>
+                <a16:creationId xmlns:a16="http://schemas.microsoft.com/office/drawing/2014/main" id="{9AC36AFC-62A4-4020-826D-9F9EFF607418}"/>
               </a:ext>
             </a:extLst>
           </p:cNvPr>
@@ -14599,7 +12796,7 @@
     </p:spTree>
     <p:extLst>
       <p:ext uri="{BB962C8B-B14F-4D97-AF65-F5344CB8AC3E}">
-        <p14:creationId xmlns:p14="http://schemas.microsoft.com/office/powerpoint/2010/main" val="24049931"/>
+        <p14:creationId xmlns:p14="http://schemas.microsoft.com/office/powerpoint/2010/main" val="681743873"/>
       </p:ext>
     </p:extLst>
   </p:cSld>
@@ -14623,7 +12820,7 @@
           <p:cNvPr id="10" name="">
             <a:extLst xmlns:a="http://schemas.openxmlformats.org/drawingml/2006/main">
               <a:ext uri="{FF2B5EF4-FFF2-40B4-BE49-F238E27FC236}">
-                <a16:creationId xmlns:a16="http://schemas.microsoft.com/office/drawing/2014/main" id="{A788F614-FB24-4ED8-A24D-19BB6A6FD98D}"/>
+                <a16:creationId xmlns:a16="http://schemas.microsoft.com/office/drawing/2014/main" id="{3971D957-6444-44EE-A5A7-8001CF50E919}"/>
               </a:ext>
             </a:extLst>
           </p:cNvPr>
@@ -14653,7 +12850,7 @@
           <p:cNvPr id="2" name="">
             <a:extLst xmlns:a="http://schemas.openxmlformats.org/drawingml/2006/main">
               <a:ext uri="{FF2B5EF4-FFF2-40B4-BE49-F238E27FC236}">
-                <a16:creationId xmlns:a16="http://schemas.microsoft.com/office/drawing/2014/main" id="{85B18CB4-AFC0-4C80-A1F2-606ED925FE8A}"/>
+                <a16:creationId xmlns:a16="http://schemas.microsoft.com/office/drawing/2014/main" id="{FBAC6581-9FEA-497E-ABB5-FB43902000D2}"/>
               </a:ext>
             </a:extLst>
           </p:cNvPr>
@@ -14683,7 +12880,7 @@
           <p:cNvPr id="3" name="">
             <a:extLst xmlns:a="http://schemas.openxmlformats.org/drawingml/2006/main">
               <a:ext uri="{FF2B5EF4-FFF2-40B4-BE49-F238E27FC236}">
-                <a16:creationId xmlns:a16="http://schemas.microsoft.com/office/drawing/2014/main" id="{B5D34EDA-9A3B-4857-8B31-4EC37A5CE9FE}"/>
+                <a16:creationId xmlns:a16="http://schemas.microsoft.com/office/drawing/2014/main" id="{7520101E-8C8B-4CAE-90FA-06D6083BBD0F}"/>
               </a:ext>
             </a:extLst>
           </p:cNvPr>
@@ -14740,7 +12937,7 @@
           <p:cNvPr id="4" name="">
             <a:extLst xmlns:a="http://schemas.openxmlformats.org/drawingml/2006/main">
               <a:ext uri="{FF2B5EF4-FFF2-40B4-BE49-F238E27FC236}">
-                <a16:creationId xmlns:a16="http://schemas.microsoft.com/office/drawing/2014/main" id="{338253DC-9DA2-4E90-82B1-E1EEA0310F71}"/>
+                <a16:creationId xmlns:a16="http://schemas.microsoft.com/office/drawing/2014/main" id="{07CBF7E6-B8E0-47DF-9ED4-07A43EE0C737}"/>
               </a:ext>
             </a:extLst>
           </p:cNvPr>
@@ -14797,7 +12994,7 @@
           <p:cNvPr id="5" name="">
             <a:extLst xmlns:a="http://schemas.openxmlformats.org/drawingml/2006/main">
               <a:ext uri="{FF2B5EF4-FFF2-40B4-BE49-F238E27FC236}">
-                <a16:creationId xmlns:a16="http://schemas.microsoft.com/office/drawing/2014/main" id="{FFD3175B-1938-449C-9DB7-943F2033F14F}"/>
+                <a16:creationId xmlns:a16="http://schemas.microsoft.com/office/drawing/2014/main" id="{0B40E324-5560-44FA-A2CA-2CC825453EF6}"/>
               </a:ext>
             </a:extLst>
           </p:cNvPr>
@@ -14854,7 +13051,7 @@
           <p:cNvPr id="6" name="">
             <a:extLst xmlns:a="http://schemas.openxmlformats.org/drawingml/2006/main">
               <a:ext uri="{FF2B5EF4-FFF2-40B4-BE49-F238E27FC236}">
-                <a16:creationId xmlns:a16="http://schemas.microsoft.com/office/drawing/2014/main" id="{9EEFA4B2-9C33-4E59-9C81-D2C50CAA2B1C}"/>
+                <a16:creationId xmlns:a16="http://schemas.microsoft.com/office/drawing/2014/main" id="{D8CD96D7-70AF-4826-B6B8-CD6BDBD9CF06}"/>
               </a:ext>
             </a:extLst>
           </p:cNvPr>
@@ -14911,7 +13108,7 @@
           <p:cNvPr id="7" name="">
             <a:extLst xmlns:a="http://schemas.openxmlformats.org/drawingml/2006/main">
               <a:ext uri="{FF2B5EF4-FFF2-40B4-BE49-F238E27FC236}">
-                <a16:creationId xmlns:a16="http://schemas.microsoft.com/office/drawing/2014/main" id="{97F15FA4-CEA4-46BF-81FA-25E1697EC0FB}"/>
+                <a16:creationId xmlns:a16="http://schemas.microsoft.com/office/drawing/2014/main" id="{AC76541D-A049-4F25-A6FB-CA34AB3D7F69}"/>
               </a:ext>
             </a:extLst>
           </p:cNvPr>
@@ -14968,7 +13165,7 @@
           <p:cNvPr id="8" name="">
             <a:extLst xmlns:a="http://schemas.openxmlformats.org/drawingml/2006/main">
               <a:ext uri="{FF2B5EF4-FFF2-40B4-BE49-F238E27FC236}">
-                <a16:creationId xmlns:a16="http://schemas.microsoft.com/office/drawing/2014/main" id="{35EA2C14-5865-4F87-B2AB-999B7B0AD9DA}"/>
+                <a16:creationId xmlns:a16="http://schemas.microsoft.com/office/drawing/2014/main" id="{5257E067-69FF-427A-8777-6DC6D6AAAA04}"/>
               </a:ext>
             </a:extLst>
           </p:cNvPr>
@@ -15000,7 +13197,7 @@
           <p:cNvPr id="9" name="">
             <a:extLst xmlns:a="http://schemas.openxmlformats.org/drawingml/2006/main">
               <a:ext uri="{FF2B5EF4-FFF2-40B4-BE49-F238E27FC236}">
-                <a16:creationId xmlns:a16="http://schemas.microsoft.com/office/drawing/2014/main" id="{1A54BA27-A4D3-4AB0-A50E-880AD2A4C6B9}"/>
+                <a16:creationId xmlns:a16="http://schemas.microsoft.com/office/drawing/2014/main" id="{9863EF13-3FC3-4F1D-BC04-95FFC3C962C3}"/>
               </a:ext>
             </a:extLst>
           </p:cNvPr>
@@ -15078,7 +13275,7 @@
     </p:spTree>
     <p:extLst>
       <p:ext uri="{BB962C8B-B14F-4D97-AF65-F5344CB8AC3E}">
-        <p14:creationId xmlns:p14="http://schemas.microsoft.com/office/powerpoint/2010/main" val="1562608423"/>
+        <p14:creationId xmlns:p14="http://schemas.microsoft.com/office/powerpoint/2010/main" val="211533499"/>
       </p:ext>
     </p:extLst>
   </p:cSld>
@@ -15102,7 +13299,7 @@
           <p:cNvPr id="10" name="">
             <a:extLst xmlns:a="http://schemas.openxmlformats.org/drawingml/2006/main">
               <a:ext uri="{FF2B5EF4-FFF2-40B4-BE49-F238E27FC236}">
-                <a16:creationId xmlns:a16="http://schemas.microsoft.com/office/drawing/2014/main" id="{8FD6B267-91CA-46B8-BCFA-54BCA32E1105}"/>
+                <a16:creationId xmlns:a16="http://schemas.microsoft.com/office/drawing/2014/main" id="{450FEA9B-897B-4201-B890-20C9A1E700D2}"/>
               </a:ext>
             </a:extLst>
           </p:cNvPr>
@@ -15132,7 +13329,7 @@
           <p:cNvPr id="2" name="">
             <a:extLst xmlns:a="http://schemas.openxmlformats.org/drawingml/2006/main">
               <a:ext uri="{FF2B5EF4-FFF2-40B4-BE49-F238E27FC236}">
-                <a16:creationId xmlns:a16="http://schemas.microsoft.com/office/drawing/2014/main" id="{D3D9D46F-F2B4-4482-86BD-9477F9C46520}"/>
+                <a16:creationId xmlns:a16="http://schemas.microsoft.com/office/drawing/2014/main" id="{D310ACBE-68DB-4BB6-A82B-1AFA84D737A5}"/>
               </a:ext>
             </a:extLst>
           </p:cNvPr>
@@ -15162,7 +13359,7 @@
           <p:cNvPr id="3" name="">
             <a:extLst xmlns:a="http://schemas.openxmlformats.org/drawingml/2006/main">
               <a:ext uri="{FF2B5EF4-FFF2-40B4-BE49-F238E27FC236}">
-                <a16:creationId xmlns:a16="http://schemas.microsoft.com/office/drawing/2014/main" id="{B3E957E2-D51D-41BC-9E98-8B2E17EB7C31}"/>
+                <a16:creationId xmlns:a16="http://schemas.microsoft.com/office/drawing/2014/main" id="{D7CA5D8E-AF2C-468D-A8E2-AFC4D7D9D018}"/>
               </a:ext>
             </a:extLst>
           </p:cNvPr>
@@ -15219,7 +13416,7 @@
           <p:cNvPr id="4" name="">
             <a:extLst xmlns:a="http://schemas.openxmlformats.org/drawingml/2006/main">
               <a:ext uri="{FF2B5EF4-FFF2-40B4-BE49-F238E27FC236}">
-                <a16:creationId xmlns:a16="http://schemas.microsoft.com/office/drawing/2014/main" id="{72AAE732-BE96-4D4D-A285-E03E7EFA8579}"/>
+                <a16:creationId xmlns:a16="http://schemas.microsoft.com/office/drawing/2014/main" id="{D580D727-E1B6-48F1-834E-6D4ED94F044A}"/>
               </a:ext>
             </a:extLst>
           </p:cNvPr>
@@ -15276,7 +13473,7 @@
           <p:cNvPr id="5" name="">
             <a:extLst xmlns:a="http://schemas.openxmlformats.org/drawingml/2006/main">
               <a:ext uri="{FF2B5EF4-FFF2-40B4-BE49-F238E27FC236}">
-                <a16:creationId xmlns:a16="http://schemas.microsoft.com/office/drawing/2014/main" id="{6DAADD17-031B-42FE-8269-A8D29110454C}"/>
+                <a16:creationId xmlns:a16="http://schemas.microsoft.com/office/drawing/2014/main" id="{4B04DFA4-961C-46EF-8955-C6808A4F2B0D}"/>
               </a:ext>
             </a:extLst>
           </p:cNvPr>
@@ -15333,7 +13530,7 @@
           <p:cNvPr id="6" name="">
             <a:extLst xmlns:a="http://schemas.openxmlformats.org/drawingml/2006/main">
               <a:ext uri="{FF2B5EF4-FFF2-40B4-BE49-F238E27FC236}">
-                <a16:creationId xmlns:a16="http://schemas.microsoft.com/office/drawing/2014/main" id="{9BA9AE27-663B-4AC6-A35B-CCBE62CA9041}"/>
+                <a16:creationId xmlns:a16="http://schemas.microsoft.com/office/drawing/2014/main" id="{ACF80149-D766-422E-97FD-9A219191D882}"/>
               </a:ext>
             </a:extLst>
           </p:cNvPr>
@@ -15390,7 +13587,7 @@
           <p:cNvPr id="7" name="">
             <a:extLst xmlns:a="http://schemas.openxmlformats.org/drawingml/2006/main">
               <a:ext uri="{FF2B5EF4-FFF2-40B4-BE49-F238E27FC236}">
-                <a16:creationId xmlns:a16="http://schemas.microsoft.com/office/drawing/2014/main" id="{36BF11B0-C3F0-461C-AEE8-84BF2FCF7571}"/>
+                <a16:creationId xmlns:a16="http://schemas.microsoft.com/office/drawing/2014/main" id="{FCAAFDE3-F2B2-4906-A212-42A17931B810}"/>
               </a:ext>
             </a:extLst>
           </p:cNvPr>
@@ -15447,7 +13644,7 @@
           <p:cNvPr id="8" name="">
             <a:extLst xmlns:a="http://schemas.openxmlformats.org/drawingml/2006/main">
               <a:ext uri="{FF2B5EF4-FFF2-40B4-BE49-F238E27FC236}">
-                <a16:creationId xmlns:a16="http://schemas.microsoft.com/office/drawing/2014/main" id="{3CBC0FEC-13CD-4B16-B00F-D637BFC31474}"/>
+                <a16:creationId xmlns:a16="http://schemas.microsoft.com/office/drawing/2014/main" id="{5E8F7E0B-293B-42FC-8A99-78DEE0BB4549}"/>
               </a:ext>
             </a:extLst>
           </p:cNvPr>
@@ -15479,7 +13676,7 @@
           <p:cNvPr id="9" name="">
             <a:extLst xmlns:a="http://schemas.openxmlformats.org/drawingml/2006/main">
               <a:ext uri="{FF2B5EF4-FFF2-40B4-BE49-F238E27FC236}">
-                <a16:creationId xmlns:a16="http://schemas.microsoft.com/office/drawing/2014/main" id="{C841FF9B-9D28-486B-A425-99F8D0665918}"/>
+                <a16:creationId xmlns:a16="http://schemas.microsoft.com/office/drawing/2014/main" id="{9069D254-F870-4A29-A233-6E10B2CB7B1A}"/>
               </a:ext>
             </a:extLst>
           </p:cNvPr>
@@ -15580,7 +13777,7 @@
     </p:spTree>
     <p:extLst>
       <p:ext uri="{BB962C8B-B14F-4D97-AF65-F5344CB8AC3E}">
-        <p14:creationId xmlns:p14="http://schemas.microsoft.com/office/powerpoint/2010/main" val="1919002715"/>
+        <p14:creationId xmlns:p14="http://schemas.microsoft.com/office/powerpoint/2010/main" val="163166042"/>
       </p:ext>
     </p:extLst>
   </p:cSld>

</xml_diff>